<commit_message>
Clarify lighting assumption and synchronize final MM12 review exports
</commit_message>
<xml_diff>
--- a/reviews/design-story-2026-10-09/downloads/MM12_Sprint04_Believable_Composite_2026-10-09_v1.pptx
+++ b/reviews/design-story-2026-10-09/downloads/MM12_Sprint04_Believable_Composite_2026-10-09_v1.pptx
@@ -2,28 +2,28 @@
 <file path=ppt/presentation.xml><?xml version="1.0" encoding="utf-8"?>
 <p:presentation xmlns:p="http://schemas.openxmlformats.org/presentationml/2006/main">
   <p:sldMasterIdLst>
-    <p:sldMasterId xmlns:r="http://schemas.openxmlformats.org/officeDocument/2006/relationships" id="2147483648" r:id="R76cfd160b97d4ea5"/>
+    <p:sldMasterId xmlns:r="http://schemas.openxmlformats.org/officeDocument/2006/relationships" id="2147483648" r:id="Rd61b4080ae0c4dc9"/>
   </p:sldMasterIdLst>
   <p:notesMasterIdLst>
-    <p:notesMasterId xmlns:r="http://schemas.openxmlformats.org/officeDocument/2006/relationships" r:id="R84090be56bd34d8e"/>
+    <p:notesMasterId xmlns:r="http://schemas.openxmlformats.org/officeDocument/2006/relationships" r:id="Rdc64392334664205"/>
   </p:notesMasterIdLst>
   <p:sldIdLst>
-    <p:sldId xmlns:r="http://schemas.openxmlformats.org/officeDocument/2006/relationships" id="256" r:id="Red91caf6514e49cc"/>
-    <p:sldId xmlns:r="http://schemas.openxmlformats.org/officeDocument/2006/relationships" id="257" r:id="R7513fcce50a94c51"/>
-    <p:sldId xmlns:r="http://schemas.openxmlformats.org/officeDocument/2006/relationships" id="258" r:id="Rd76b310210f244b8"/>
-    <p:sldId xmlns:r="http://schemas.openxmlformats.org/officeDocument/2006/relationships" id="259" r:id="R562a275f67d04c1a"/>
-    <p:sldId xmlns:r="http://schemas.openxmlformats.org/officeDocument/2006/relationships" id="260" r:id="R1091666f8fed407a"/>
-    <p:sldId xmlns:r="http://schemas.openxmlformats.org/officeDocument/2006/relationships" id="261" r:id="Rb3cc21a731b14666"/>
-    <p:sldId xmlns:r="http://schemas.openxmlformats.org/officeDocument/2006/relationships" id="262" r:id="Rc9ec57fb22404648"/>
-    <p:sldId xmlns:r="http://schemas.openxmlformats.org/officeDocument/2006/relationships" id="263" r:id="R618cafc560df4538"/>
-    <p:sldId xmlns:r="http://schemas.openxmlformats.org/officeDocument/2006/relationships" id="264" r:id="Re6e7386ad9a3455a"/>
-    <p:sldId xmlns:r="http://schemas.openxmlformats.org/officeDocument/2006/relationships" id="265" r:id="R096daaa3244d492f"/>
-    <p:sldId xmlns:r="http://schemas.openxmlformats.org/officeDocument/2006/relationships" id="266" r:id="R2590f1c5dcc2485f"/>
-    <p:sldId xmlns:r="http://schemas.openxmlformats.org/officeDocument/2006/relationships" id="267" r:id="Rec2a89bdcb224af5"/>
-    <p:sldId xmlns:r="http://schemas.openxmlformats.org/officeDocument/2006/relationships" id="268" r:id="R13f4b430547c4acb"/>
-    <p:sldId xmlns:r="http://schemas.openxmlformats.org/officeDocument/2006/relationships" id="269" r:id="Ra51e6d149d174d97"/>
-    <p:sldId xmlns:r="http://schemas.openxmlformats.org/officeDocument/2006/relationships" id="270" r:id="R44d4cce93aae4642"/>
-    <p:sldId xmlns:r="http://schemas.openxmlformats.org/officeDocument/2006/relationships" id="271" r:id="R2221340000974836"/>
+    <p:sldId xmlns:r="http://schemas.openxmlformats.org/officeDocument/2006/relationships" id="256" r:id="Rdc3ed59e7dcb4e3a"/>
+    <p:sldId xmlns:r="http://schemas.openxmlformats.org/officeDocument/2006/relationships" id="257" r:id="Rb61d6349e9c246ad"/>
+    <p:sldId xmlns:r="http://schemas.openxmlformats.org/officeDocument/2006/relationships" id="258" r:id="Rdfbcaf7e482944a6"/>
+    <p:sldId xmlns:r="http://schemas.openxmlformats.org/officeDocument/2006/relationships" id="259" r:id="R8f651d8677694477"/>
+    <p:sldId xmlns:r="http://schemas.openxmlformats.org/officeDocument/2006/relationships" id="260" r:id="Re71b8ecda65c4523"/>
+    <p:sldId xmlns:r="http://schemas.openxmlformats.org/officeDocument/2006/relationships" id="261" r:id="Ra0c2aba927324639"/>
+    <p:sldId xmlns:r="http://schemas.openxmlformats.org/officeDocument/2006/relationships" id="262" r:id="Rc6fdb413c6594d09"/>
+    <p:sldId xmlns:r="http://schemas.openxmlformats.org/officeDocument/2006/relationships" id="263" r:id="R9138133ba97c40ef"/>
+    <p:sldId xmlns:r="http://schemas.openxmlformats.org/officeDocument/2006/relationships" id="264" r:id="Rf417d5704e764eff"/>
+    <p:sldId xmlns:r="http://schemas.openxmlformats.org/officeDocument/2006/relationships" id="265" r:id="Ra7a58b6378074c50"/>
+    <p:sldId xmlns:r="http://schemas.openxmlformats.org/officeDocument/2006/relationships" id="266" r:id="Re8c5ef969d7744b1"/>
+    <p:sldId xmlns:r="http://schemas.openxmlformats.org/officeDocument/2006/relationships" id="267" r:id="Rf3818b33210f42d3"/>
+    <p:sldId xmlns:r="http://schemas.openxmlformats.org/officeDocument/2006/relationships" id="268" r:id="R9e064d026bd14c7e"/>
+    <p:sldId xmlns:r="http://schemas.openxmlformats.org/officeDocument/2006/relationships" id="269" r:id="Ra4387c010784464b"/>
+    <p:sldId xmlns:r="http://schemas.openxmlformats.org/officeDocument/2006/relationships" id="270" r:id="R5e3ed7b2814448da"/>
+    <p:sldId xmlns:r="http://schemas.openxmlformats.org/officeDocument/2006/relationships" id="271" r:id="Rd4e68ea4e12344d6"/>
   </p:sldIdLst>
   <p:sldSz cx="12192000" cy="6858000"/>
   <p:notesSz cx="6858000" cy="9144000"/>
@@ -2067,7 +2067,7 @@
           <a:lstStyle xmlns:a="http://schemas.openxmlformats.org/drawingml/2006/main"/>
           <a:p xmlns:a="http://schemas.openxmlformats.org/drawingml/2006/main">
             <a:r>
-              <a:t>The original practice treatment uses a visible luminous object as a lighting cue. Added colour alone does not establish plausible illumination. Compare the source-side surfaces with surfaces facing away; consider the strength of the effect in context.</a:t>
+              <a:t>In this constructed practice treatment, the green illumination suggests an off-frame source on the viewer’s right. That is a lighting assumption to test, not proof of a photographed emitter. Compare surfaces facing that direction with surfaces turning away. Added colour alone does not establish plausible illumination; inspect brightness and shadow relationships as well.</a:t>
             </a:r>
           </a:p>
           <a:p xmlns:a="http://schemas.openxmlformats.org/drawingml/2006/main">
@@ -2295,7 +2295,7 @@
   </p:cSld>
   <p:clrMap bg1="lt1" tx1="dk1" bg2="lt2" tx2="dk2" accent1="accent1" accent2="accent2" accent3="accent3" accent4="accent4" accent5="accent5" accent6="accent6" hlink="hlink" folHlink="folHlink"/>
   <p:sldLayoutIdLst>
-    <p:sldLayoutId xmlns:r="http://schemas.openxmlformats.org/officeDocument/2006/relationships" id="2147483649" r:id="Ra0df375be4214c6e"/>
+    <p:sldLayoutId xmlns:r="http://schemas.openxmlformats.org/officeDocument/2006/relationships" id="2147483649" r:id="Rb673d3bf260b4bb9"/>
   </p:sldLayoutIdLst>
   <p:txStyles>
     <p:titleStyle>
@@ -2846,7 +2846,7 @@
           <p:cNvPr id="11" name="">
             <a:extLst xmlns:a="http://schemas.openxmlformats.org/drawingml/2006/main">
               <a:ext uri="{FF2B5EF4-FFF2-40B4-BE49-F238E27FC236}">
-                <a16:creationId xmlns:a16="http://schemas.microsoft.com/office/drawing/2014/main" id="{B1595C84-34F3-4759-8567-8FA6523B5271}"/>
+                <a16:creationId xmlns:a16="http://schemas.microsoft.com/office/drawing/2014/main" id="{4C724E39-963A-4116-8BB2-4EE03BDFAA60}"/>
               </a:ext>
             </a:extLst>
           </p:cNvPr>
@@ -2903,7 +2903,7 @@
           <p:cNvPr id="2" name="">
             <a:extLst xmlns:a="http://schemas.openxmlformats.org/drawingml/2006/main">
               <a:ext uri="{FF2B5EF4-FFF2-40B4-BE49-F238E27FC236}">
-                <a16:creationId xmlns:a16="http://schemas.microsoft.com/office/drawing/2014/main" id="{B9523B46-ED07-4AB9-9658-E65A2EDACDB4}"/>
+                <a16:creationId xmlns:a16="http://schemas.microsoft.com/office/drawing/2014/main" id="{6382773A-B2EB-4C18-9DB0-9A6F33D8F8CF}"/>
               </a:ext>
             </a:extLst>
           </p:cNvPr>
@@ -2960,7 +2960,7 @@
           <p:cNvPr id="3" name="">
             <a:extLst xmlns:a="http://schemas.openxmlformats.org/drawingml/2006/main">
               <a:ext uri="{FF2B5EF4-FFF2-40B4-BE49-F238E27FC236}">
-                <a16:creationId xmlns:a16="http://schemas.microsoft.com/office/drawing/2014/main" id="{8B317067-9AC9-4B1E-A86A-2A38B4A9DF0A}"/>
+                <a16:creationId xmlns:a16="http://schemas.microsoft.com/office/drawing/2014/main" id="{A11D0F78-F111-4522-BEDA-15141C11E01B}"/>
               </a:ext>
             </a:extLst>
           </p:cNvPr>
@@ -3021,7 +3021,7 @@
           <p:nvPr/>
         </p:nvPicPr>
         <p:blipFill>
-          <a:blip xmlns:r="http://schemas.openxmlformats.org/officeDocument/2006/relationships" xmlns:a="http://schemas.openxmlformats.org/drawingml/2006/main" r:embed="Rf1864e3e6f004bde"/>
+          <a:blip xmlns:r="http://schemas.openxmlformats.org/officeDocument/2006/relationships" xmlns:a="http://schemas.openxmlformats.org/drawingml/2006/main" r:embed="R6afad317e2b24b4e"/>
           <a:stretch xmlns:a="http://schemas.openxmlformats.org/drawingml/2006/main"/>
         </p:blipFill>
         <p:spPr>
@@ -3039,7 +3039,7 @@
           <p:cNvPr id="5" name="">
             <a:extLst xmlns:a="http://schemas.openxmlformats.org/drawingml/2006/main">
               <a:ext uri="{FF2B5EF4-FFF2-40B4-BE49-F238E27FC236}">
-                <a16:creationId xmlns:a16="http://schemas.microsoft.com/office/drawing/2014/main" id="{281DE125-FA72-446D-BC15-189AFBB79B9B}"/>
+                <a16:creationId xmlns:a16="http://schemas.microsoft.com/office/drawing/2014/main" id="{7CFC074B-955B-4D06-9F2A-2BAC386528C1}"/>
               </a:ext>
             </a:extLst>
           </p:cNvPr>
@@ -3096,7 +3096,7 @@
           <p:cNvPr id="6" name="">
             <a:extLst xmlns:a="http://schemas.openxmlformats.org/drawingml/2006/main">
               <a:ext uri="{FF2B5EF4-FFF2-40B4-BE49-F238E27FC236}">
-                <a16:creationId xmlns:a16="http://schemas.microsoft.com/office/drawing/2014/main" id="{684147F0-FA82-44A3-9C85-185757BC640A}"/>
+                <a16:creationId xmlns:a16="http://schemas.microsoft.com/office/drawing/2014/main" id="{7C0BFE5E-5C49-4266-B3FF-6AE52B1B7192}"/>
               </a:ext>
             </a:extLst>
           </p:cNvPr>
@@ -3153,7 +3153,7 @@
           <p:cNvPr id="7" name="">
             <a:extLst xmlns:a="http://schemas.openxmlformats.org/drawingml/2006/main">
               <a:ext uri="{FF2B5EF4-FFF2-40B4-BE49-F238E27FC236}">
-                <a16:creationId xmlns:a16="http://schemas.microsoft.com/office/drawing/2014/main" id="{162417FA-4EBF-4553-955E-648956F403A8}"/>
+                <a16:creationId xmlns:a16="http://schemas.microsoft.com/office/drawing/2014/main" id="{DF812207-FCAC-4F54-99D9-7133FEFA849F}"/>
               </a:ext>
             </a:extLst>
           </p:cNvPr>
@@ -3210,7 +3210,7 @@
           <p:cNvPr id="8" name="">
             <a:extLst xmlns:a="http://schemas.openxmlformats.org/drawingml/2006/main">
               <a:ext uri="{FF2B5EF4-FFF2-40B4-BE49-F238E27FC236}">
-                <a16:creationId xmlns:a16="http://schemas.microsoft.com/office/drawing/2014/main" id="{4DA2802F-6926-4081-A949-0BDC84695854}"/>
+                <a16:creationId xmlns:a16="http://schemas.microsoft.com/office/drawing/2014/main" id="{02B9093F-0491-4188-A042-902F815C30C4}"/>
               </a:ext>
             </a:extLst>
           </p:cNvPr>
@@ -3240,7 +3240,7 @@
           <p:cNvPr id="9" name="">
             <a:extLst xmlns:a="http://schemas.openxmlformats.org/drawingml/2006/main">
               <a:ext uri="{FF2B5EF4-FFF2-40B4-BE49-F238E27FC236}">
-                <a16:creationId xmlns:a16="http://schemas.microsoft.com/office/drawing/2014/main" id="{BF8A435F-93E5-4176-AA7E-6BD8C78B7E37}"/>
+                <a16:creationId xmlns:a16="http://schemas.microsoft.com/office/drawing/2014/main" id="{18AD67B9-7FD5-4510-87F2-6CA7004AA72D}"/>
               </a:ext>
             </a:extLst>
           </p:cNvPr>
@@ -3297,7 +3297,7 @@
           <p:cNvPr id="10" name="">
             <a:extLst xmlns:a="http://schemas.openxmlformats.org/drawingml/2006/main">
               <a:ext uri="{FF2B5EF4-FFF2-40B4-BE49-F238E27FC236}">
-                <a16:creationId xmlns:a16="http://schemas.microsoft.com/office/drawing/2014/main" id="{FE703FDC-8EED-4E8E-BD5A-E3E879DE1DE3}"/>
+                <a16:creationId xmlns:a16="http://schemas.microsoft.com/office/drawing/2014/main" id="{A9178FE8-5A7D-4FF1-AD04-4C26F4F28D0C}"/>
               </a:ext>
             </a:extLst>
           </p:cNvPr>
@@ -3352,7 +3352,7 @@
     </p:spTree>
     <p:extLst>
       <p:ext uri="{BB962C8B-B14F-4D97-AF65-F5344CB8AC3E}">
-        <p14:creationId xmlns:p14="http://schemas.microsoft.com/office/powerpoint/2010/main" val="351210191"/>
+        <p14:creationId xmlns:p14="http://schemas.microsoft.com/office/powerpoint/2010/main" val="446353875"/>
       </p:ext>
     </p:extLst>
   </p:cSld>
@@ -3383,7 +3383,7 @@
           <p:cNvPr id="19" name="">
             <a:extLst xmlns:a="http://schemas.openxmlformats.org/drawingml/2006/main">
               <a:ext uri="{FF2B5EF4-FFF2-40B4-BE49-F238E27FC236}">
-                <a16:creationId xmlns:a16="http://schemas.microsoft.com/office/drawing/2014/main" id="{ADACB2A5-2321-4567-9F28-94086BB15E11}"/>
+                <a16:creationId xmlns:a16="http://schemas.microsoft.com/office/drawing/2014/main" id="{2F93FF0B-8BDE-46CF-966D-5E502A77B444}"/>
               </a:ext>
             </a:extLst>
           </p:cNvPr>
@@ -3440,7 +3440,7 @@
           <p:cNvPr id="2" name="">
             <a:extLst xmlns:a="http://schemas.openxmlformats.org/drawingml/2006/main">
               <a:ext uri="{FF2B5EF4-FFF2-40B4-BE49-F238E27FC236}">
-                <a16:creationId xmlns:a16="http://schemas.microsoft.com/office/drawing/2014/main" id="{8EA0934C-0248-4805-A90F-949A8C8CD722}"/>
+                <a16:creationId xmlns:a16="http://schemas.microsoft.com/office/drawing/2014/main" id="{FC70A0DF-6D5E-47B1-B8F3-BC20E29B518D}"/>
               </a:ext>
             </a:extLst>
           </p:cNvPr>
@@ -3497,7 +3497,7 @@
           <p:cNvPr id="3" name="">
             <a:extLst xmlns:a="http://schemas.openxmlformats.org/drawingml/2006/main">
               <a:ext uri="{FF2B5EF4-FFF2-40B4-BE49-F238E27FC236}">
-                <a16:creationId xmlns:a16="http://schemas.microsoft.com/office/drawing/2014/main" id="{C15C1694-63A5-483A-AD06-9D5894CF278B}"/>
+                <a16:creationId xmlns:a16="http://schemas.microsoft.com/office/drawing/2014/main" id="{6CA98506-BB24-4365-8978-E7A70A65A15A}"/>
               </a:ext>
             </a:extLst>
           </p:cNvPr>
@@ -3554,7 +3554,7 @@
           <p:cNvPr id="4" name="">
             <a:extLst xmlns:a="http://schemas.openxmlformats.org/drawingml/2006/main">
               <a:ext uri="{FF2B5EF4-FFF2-40B4-BE49-F238E27FC236}">
-                <a16:creationId xmlns:a16="http://schemas.microsoft.com/office/drawing/2014/main" id="{52530EA8-C5B8-4E94-8F3B-565CD7D5E35B}"/>
+                <a16:creationId xmlns:a16="http://schemas.microsoft.com/office/drawing/2014/main" id="{B860E5AC-ACD6-44FF-B27B-77818CADE781}"/>
               </a:ext>
             </a:extLst>
           </p:cNvPr>
@@ -3611,7 +3611,7 @@
           <p:cNvPr id="5" name="">
             <a:extLst xmlns:a="http://schemas.openxmlformats.org/drawingml/2006/main">
               <a:ext uri="{FF2B5EF4-FFF2-40B4-BE49-F238E27FC236}">
-                <a16:creationId xmlns:a16="http://schemas.microsoft.com/office/drawing/2014/main" id="{DE1BA629-3FE2-42FB-A46E-A76EDB10C12C}"/>
+                <a16:creationId xmlns:a16="http://schemas.microsoft.com/office/drawing/2014/main" id="{02F509EC-ED8C-46E3-88AB-9EF8013CA513}"/>
               </a:ext>
             </a:extLst>
           </p:cNvPr>
@@ -3668,7 +3668,7 @@
           <p:cNvPr id="6" name="">
             <a:extLst xmlns:a="http://schemas.openxmlformats.org/drawingml/2006/main">
               <a:ext uri="{FF2B5EF4-FFF2-40B4-BE49-F238E27FC236}">
-                <a16:creationId xmlns:a16="http://schemas.microsoft.com/office/drawing/2014/main" id="{40311110-5C70-4254-B705-1F1932769989}"/>
+                <a16:creationId xmlns:a16="http://schemas.microsoft.com/office/drawing/2014/main" id="{03BE41FE-AB8D-49A1-898E-6FB6F53D20E3}"/>
               </a:ext>
             </a:extLst>
           </p:cNvPr>
@@ -3698,7 +3698,7 @@
           <p:cNvPr id="7" name="">
             <a:extLst xmlns:a="http://schemas.openxmlformats.org/drawingml/2006/main">
               <a:ext uri="{FF2B5EF4-FFF2-40B4-BE49-F238E27FC236}">
-                <a16:creationId xmlns:a16="http://schemas.microsoft.com/office/drawing/2014/main" id="{4035E63C-99A0-488E-9492-DF665FD7890F}"/>
+                <a16:creationId xmlns:a16="http://schemas.microsoft.com/office/drawing/2014/main" id="{D3D5B1C6-BA9B-4940-8558-BA18E6C381AA}"/>
               </a:ext>
             </a:extLst>
           </p:cNvPr>
@@ -3755,7 +3755,7 @@
           <p:cNvPr id="8" name="">
             <a:extLst xmlns:a="http://schemas.openxmlformats.org/drawingml/2006/main">
               <a:ext uri="{FF2B5EF4-FFF2-40B4-BE49-F238E27FC236}">
-                <a16:creationId xmlns:a16="http://schemas.microsoft.com/office/drawing/2014/main" id="{3F971838-B743-457F-8775-0912DB2D3B15}"/>
+                <a16:creationId xmlns:a16="http://schemas.microsoft.com/office/drawing/2014/main" id="{94EB59E9-695D-4750-A934-BDA52CA8B6AB}"/>
               </a:ext>
             </a:extLst>
           </p:cNvPr>
@@ -3812,7 +3812,7 @@
           <p:cNvPr id="9" name="">
             <a:extLst xmlns:a="http://schemas.openxmlformats.org/drawingml/2006/main">
               <a:ext uri="{FF2B5EF4-FFF2-40B4-BE49-F238E27FC236}">
-                <a16:creationId xmlns:a16="http://schemas.microsoft.com/office/drawing/2014/main" id="{61EACE29-B938-47E6-AC03-3B8C4C4F2F00}"/>
+                <a16:creationId xmlns:a16="http://schemas.microsoft.com/office/drawing/2014/main" id="{21373034-942D-4F3F-BBBF-C58A5F6331C4}"/>
               </a:ext>
             </a:extLst>
           </p:cNvPr>
@@ -3842,7 +3842,7 @@
           <p:cNvPr id="10" name="">
             <a:extLst xmlns:a="http://schemas.openxmlformats.org/drawingml/2006/main">
               <a:ext uri="{FF2B5EF4-FFF2-40B4-BE49-F238E27FC236}">
-                <a16:creationId xmlns:a16="http://schemas.microsoft.com/office/drawing/2014/main" id="{E04A449C-0169-431B-9C89-41C3A38702B0}"/>
+                <a16:creationId xmlns:a16="http://schemas.microsoft.com/office/drawing/2014/main" id="{788EB300-A9DC-4B01-8565-ADBCE8F2A03F}"/>
               </a:ext>
             </a:extLst>
           </p:cNvPr>
@@ -3899,7 +3899,7 @@
           <p:cNvPr id="11" name="">
             <a:extLst xmlns:a="http://schemas.openxmlformats.org/drawingml/2006/main">
               <a:ext uri="{FF2B5EF4-FFF2-40B4-BE49-F238E27FC236}">
-                <a16:creationId xmlns:a16="http://schemas.microsoft.com/office/drawing/2014/main" id="{3B4BF838-D74E-4B2A-9B86-13301BF9D33A}"/>
+                <a16:creationId xmlns:a16="http://schemas.microsoft.com/office/drawing/2014/main" id="{10C16A3C-2B6C-45E0-B374-8045DF52BB89}"/>
               </a:ext>
             </a:extLst>
           </p:cNvPr>
@@ -3956,7 +3956,7 @@
           <p:cNvPr id="12" name="">
             <a:extLst xmlns:a="http://schemas.openxmlformats.org/drawingml/2006/main">
               <a:ext uri="{FF2B5EF4-FFF2-40B4-BE49-F238E27FC236}">
-                <a16:creationId xmlns:a16="http://schemas.microsoft.com/office/drawing/2014/main" id="{1BFB0E9B-DED8-4BDD-A4DD-9FF25F10ABF6}"/>
+                <a16:creationId xmlns:a16="http://schemas.microsoft.com/office/drawing/2014/main" id="{C8D0EB66-9C9A-4F57-AC6E-DE7B5070A49C}"/>
               </a:ext>
             </a:extLst>
           </p:cNvPr>
@@ -3986,7 +3986,7 @@
           <p:cNvPr id="13" name="">
             <a:extLst xmlns:a="http://schemas.openxmlformats.org/drawingml/2006/main">
               <a:ext uri="{FF2B5EF4-FFF2-40B4-BE49-F238E27FC236}">
-                <a16:creationId xmlns:a16="http://schemas.microsoft.com/office/drawing/2014/main" id="{9C9F08D3-10FB-4374-8403-A7A636E140BB}"/>
+                <a16:creationId xmlns:a16="http://schemas.microsoft.com/office/drawing/2014/main" id="{7BD18494-D2E4-4F27-827F-0041883B4893}"/>
               </a:ext>
             </a:extLst>
           </p:cNvPr>
@@ -4043,7 +4043,7 @@
           <p:cNvPr id="14" name="">
             <a:extLst xmlns:a="http://schemas.openxmlformats.org/drawingml/2006/main">
               <a:ext uri="{FF2B5EF4-FFF2-40B4-BE49-F238E27FC236}">
-                <a16:creationId xmlns:a16="http://schemas.microsoft.com/office/drawing/2014/main" id="{E88F5A1D-33ED-4F10-8AC9-6F09FEC9B23E}"/>
+                <a16:creationId xmlns:a16="http://schemas.microsoft.com/office/drawing/2014/main" id="{99AAAF79-72DD-492A-9BB1-7F076D14616A}"/>
               </a:ext>
             </a:extLst>
           </p:cNvPr>
@@ -4100,7 +4100,7 @@
           <p:cNvPr id="15" name="">
             <a:extLst xmlns:a="http://schemas.openxmlformats.org/drawingml/2006/main">
               <a:ext uri="{FF2B5EF4-FFF2-40B4-BE49-F238E27FC236}">
-                <a16:creationId xmlns:a16="http://schemas.microsoft.com/office/drawing/2014/main" id="{BBE69B05-D16D-4F7E-B612-257850D448C0}"/>
+                <a16:creationId xmlns:a16="http://schemas.microsoft.com/office/drawing/2014/main" id="{FC664533-B845-44B2-A391-FCFB9AC29597}"/>
               </a:ext>
             </a:extLst>
           </p:cNvPr>
@@ -4157,7 +4157,7 @@
           <p:cNvPr id="16" name="">
             <a:extLst xmlns:a="http://schemas.openxmlformats.org/drawingml/2006/main">
               <a:ext uri="{FF2B5EF4-FFF2-40B4-BE49-F238E27FC236}">
-                <a16:creationId xmlns:a16="http://schemas.microsoft.com/office/drawing/2014/main" id="{A14F6264-01EE-49DE-BBFD-689788A2387D}"/>
+                <a16:creationId xmlns:a16="http://schemas.microsoft.com/office/drawing/2014/main" id="{C4604C50-1B1A-49B5-832B-9EC0A8C5099F}"/>
               </a:ext>
             </a:extLst>
           </p:cNvPr>
@@ -4187,7 +4187,7 @@
           <p:cNvPr id="17" name="">
             <a:extLst xmlns:a="http://schemas.openxmlformats.org/drawingml/2006/main">
               <a:ext uri="{FF2B5EF4-FFF2-40B4-BE49-F238E27FC236}">
-                <a16:creationId xmlns:a16="http://schemas.microsoft.com/office/drawing/2014/main" id="{916EC5C6-D02F-49AD-BD7A-2AC344D855FF}"/>
+                <a16:creationId xmlns:a16="http://schemas.microsoft.com/office/drawing/2014/main" id="{EC3F7CCA-A94B-404D-AC4E-C2DCBD546909}"/>
               </a:ext>
             </a:extLst>
           </p:cNvPr>
@@ -4244,7 +4244,7 @@
           <p:cNvPr id="18" name="">
             <a:extLst xmlns:a="http://schemas.openxmlformats.org/drawingml/2006/main">
               <a:ext uri="{FF2B5EF4-FFF2-40B4-BE49-F238E27FC236}">
-                <a16:creationId xmlns:a16="http://schemas.microsoft.com/office/drawing/2014/main" id="{09A07542-C3BF-48EC-ADAE-5D84DC34FD11}"/>
+                <a16:creationId xmlns:a16="http://schemas.microsoft.com/office/drawing/2014/main" id="{FB043676-EB19-4FD0-AB46-B8DC64CAEBD4}"/>
               </a:ext>
             </a:extLst>
           </p:cNvPr>
@@ -4299,7 +4299,7 @@
     </p:spTree>
     <p:extLst>
       <p:ext uri="{BB962C8B-B14F-4D97-AF65-F5344CB8AC3E}">
-        <p14:creationId xmlns:p14="http://schemas.microsoft.com/office/powerpoint/2010/main" val="1561635354"/>
+        <p14:creationId xmlns:p14="http://schemas.microsoft.com/office/powerpoint/2010/main" val="345768469"/>
       </p:ext>
     </p:extLst>
   </p:cSld>
@@ -4330,7 +4330,7 @@
           <p:cNvPr id="12" name="">
             <a:extLst xmlns:a="http://schemas.openxmlformats.org/drawingml/2006/main">
               <a:ext uri="{FF2B5EF4-FFF2-40B4-BE49-F238E27FC236}">
-                <a16:creationId xmlns:a16="http://schemas.microsoft.com/office/drawing/2014/main" id="{C27ACB6D-8B6C-48BC-807C-F372271F25C1}"/>
+                <a16:creationId xmlns:a16="http://schemas.microsoft.com/office/drawing/2014/main" id="{DA574200-B00A-4C11-AF3A-3EAA4E6092E6}"/>
               </a:ext>
             </a:extLst>
           </p:cNvPr>
@@ -4387,7 +4387,7 @@
           <p:cNvPr id="2" name="">
             <a:extLst xmlns:a="http://schemas.openxmlformats.org/drawingml/2006/main">
               <a:ext uri="{FF2B5EF4-FFF2-40B4-BE49-F238E27FC236}">
-                <a16:creationId xmlns:a16="http://schemas.microsoft.com/office/drawing/2014/main" id="{49F238E8-679C-4A94-AED3-140B3FFE7131}"/>
+                <a16:creationId xmlns:a16="http://schemas.microsoft.com/office/drawing/2014/main" id="{DBC0A4B2-624C-4164-ADE6-E53E0FD1011B}"/>
               </a:ext>
             </a:extLst>
           </p:cNvPr>
@@ -4444,7 +4444,7 @@
           <p:cNvPr id="3" name="">
             <a:extLst xmlns:a="http://schemas.openxmlformats.org/drawingml/2006/main">
               <a:ext uri="{FF2B5EF4-FFF2-40B4-BE49-F238E27FC236}">
-                <a16:creationId xmlns:a16="http://schemas.microsoft.com/office/drawing/2014/main" id="{76993C25-A9BB-4254-89BA-FB6319FA63B3}"/>
+                <a16:creationId xmlns:a16="http://schemas.microsoft.com/office/drawing/2014/main" id="{C78E6004-2262-419E-B399-82EA0CFAF6F3}"/>
               </a:ext>
             </a:extLst>
           </p:cNvPr>
@@ -4505,7 +4505,7 @@
           <p:nvPr/>
         </p:nvPicPr>
         <p:blipFill>
-          <a:blip xmlns:r="http://schemas.openxmlformats.org/officeDocument/2006/relationships" xmlns:a="http://schemas.openxmlformats.org/drawingml/2006/main" r:embed="R239db2f6f5a8475b"/>
+          <a:blip xmlns:r="http://schemas.openxmlformats.org/officeDocument/2006/relationships" xmlns:a="http://schemas.openxmlformats.org/drawingml/2006/main" r:embed="Ra386c9e52a9d4cbe"/>
           <a:stretch xmlns:a="http://schemas.openxmlformats.org/drawingml/2006/main"/>
         </p:blipFill>
         <p:spPr>
@@ -4523,7 +4523,7 @@
           <p:cNvPr id="5" name="">
             <a:extLst xmlns:a="http://schemas.openxmlformats.org/drawingml/2006/main">
               <a:ext uri="{FF2B5EF4-FFF2-40B4-BE49-F238E27FC236}">
-                <a16:creationId xmlns:a16="http://schemas.microsoft.com/office/drawing/2014/main" id="{90B82512-D560-4BD2-92C2-2AE347AEDB5A}"/>
+                <a16:creationId xmlns:a16="http://schemas.microsoft.com/office/drawing/2014/main" id="{E9F04212-0D63-4AB8-837A-F38C450ACB77}"/>
               </a:ext>
             </a:extLst>
           </p:cNvPr>
@@ -4580,7 +4580,7 @@
           <p:cNvPr id="6" name="">
             <a:extLst xmlns:a="http://schemas.openxmlformats.org/drawingml/2006/main">
               <a:ext uri="{FF2B5EF4-FFF2-40B4-BE49-F238E27FC236}">
-                <a16:creationId xmlns:a16="http://schemas.microsoft.com/office/drawing/2014/main" id="{D77C30D1-3FD1-4AB3-9A79-61AE418D9E01}"/>
+                <a16:creationId xmlns:a16="http://schemas.microsoft.com/office/drawing/2014/main" id="{9955099B-F097-40A5-A6A1-963D0888088C}"/>
               </a:ext>
             </a:extLst>
           </p:cNvPr>
@@ -4637,7 +4637,7 @@
           <p:cNvPr id="7" name="">
             <a:extLst xmlns:a="http://schemas.openxmlformats.org/drawingml/2006/main">
               <a:ext uri="{FF2B5EF4-FFF2-40B4-BE49-F238E27FC236}">
-                <a16:creationId xmlns:a16="http://schemas.microsoft.com/office/drawing/2014/main" id="{25CAD624-4DBD-4291-9FB8-BDC9B09AFC86}"/>
+                <a16:creationId xmlns:a16="http://schemas.microsoft.com/office/drawing/2014/main" id="{BD26C8DA-3CAF-4F94-B506-3BAB47488C7F}"/>
               </a:ext>
             </a:extLst>
           </p:cNvPr>
@@ -4694,7 +4694,7 @@
           <p:cNvPr id="8" name="">
             <a:extLst xmlns:a="http://schemas.openxmlformats.org/drawingml/2006/main">
               <a:ext uri="{FF2B5EF4-FFF2-40B4-BE49-F238E27FC236}">
-                <a16:creationId xmlns:a16="http://schemas.microsoft.com/office/drawing/2014/main" id="{5E53352A-4EC8-4AA9-A724-FA1EA6995244}"/>
+                <a16:creationId xmlns:a16="http://schemas.microsoft.com/office/drawing/2014/main" id="{59C0DF44-4B9C-47D2-A567-F23A816D52C3}"/>
               </a:ext>
             </a:extLst>
           </p:cNvPr>
@@ -4751,7 +4751,7 @@
           <p:cNvPr id="9" name="">
             <a:extLst xmlns:a="http://schemas.openxmlformats.org/drawingml/2006/main">
               <a:ext uri="{FF2B5EF4-FFF2-40B4-BE49-F238E27FC236}">
-                <a16:creationId xmlns:a16="http://schemas.microsoft.com/office/drawing/2014/main" id="{6FE3ECD0-BD03-4900-9C10-FA99D3916A87}"/>
+                <a16:creationId xmlns:a16="http://schemas.microsoft.com/office/drawing/2014/main" id="{96A1210B-A047-4F6D-90BC-7991B3B63A44}"/>
               </a:ext>
             </a:extLst>
           </p:cNvPr>
@@ -4781,7 +4781,7 @@
           <p:cNvPr id="10" name="">
             <a:extLst xmlns:a="http://schemas.openxmlformats.org/drawingml/2006/main">
               <a:ext uri="{FF2B5EF4-FFF2-40B4-BE49-F238E27FC236}">
-                <a16:creationId xmlns:a16="http://schemas.microsoft.com/office/drawing/2014/main" id="{1FED4B30-A9DE-4CFF-9917-92FE11770D53}"/>
+                <a16:creationId xmlns:a16="http://schemas.microsoft.com/office/drawing/2014/main" id="{C498F39E-3AAB-4A2D-91F5-0720443E6AA3}"/>
               </a:ext>
             </a:extLst>
           </p:cNvPr>
@@ -4838,7 +4838,7 @@
           <p:cNvPr id="11" name="">
             <a:extLst xmlns:a="http://schemas.openxmlformats.org/drawingml/2006/main">
               <a:ext uri="{FF2B5EF4-FFF2-40B4-BE49-F238E27FC236}">
-                <a16:creationId xmlns:a16="http://schemas.microsoft.com/office/drawing/2014/main" id="{142918D0-9139-4101-892B-A12699E013C9}"/>
+                <a16:creationId xmlns:a16="http://schemas.microsoft.com/office/drawing/2014/main" id="{3C23FF2F-3842-4879-8E12-5A1F9FBADD0D}"/>
               </a:ext>
             </a:extLst>
           </p:cNvPr>
@@ -4893,7 +4893,7 @@
     </p:spTree>
     <p:extLst>
       <p:ext uri="{BB962C8B-B14F-4D97-AF65-F5344CB8AC3E}">
-        <p14:creationId xmlns:p14="http://schemas.microsoft.com/office/powerpoint/2010/main" val="506847912"/>
+        <p14:creationId xmlns:p14="http://schemas.microsoft.com/office/powerpoint/2010/main" val="531683110"/>
       </p:ext>
     </p:extLst>
   </p:cSld>
@@ -4924,7 +4924,7 @@
           <p:cNvPr id="19" name="">
             <a:extLst xmlns:a="http://schemas.openxmlformats.org/drawingml/2006/main">
               <a:ext uri="{FF2B5EF4-FFF2-40B4-BE49-F238E27FC236}">
-                <a16:creationId xmlns:a16="http://schemas.microsoft.com/office/drawing/2014/main" id="{4C08AFD3-D99E-4C28-85EC-21CDEF834D3D}"/>
+                <a16:creationId xmlns:a16="http://schemas.microsoft.com/office/drawing/2014/main" id="{B47C7827-566F-45D3-923B-0A8CE4759709}"/>
               </a:ext>
             </a:extLst>
           </p:cNvPr>
@@ -4981,7 +4981,7 @@
           <p:cNvPr id="2" name="">
             <a:extLst xmlns:a="http://schemas.openxmlformats.org/drawingml/2006/main">
               <a:ext uri="{FF2B5EF4-FFF2-40B4-BE49-F238E27FC236}">
-                <a16:creationId xmlns:a16="http://schemas.microsoft.com/office/drawing/2014/main" id="{F262E12E-A36E-4B20-944F-7D0B7D2C8338}"/>
+                <a16:creationId xmlns:a16="http://schemas.microsoft.com/office/drawing/2014/main" id="{85B9E8C6-6927-47BA-B7D9-77A0E0E61E1E}"/>
               </a:ext>
             </a:extLst>
           </p:cNvPr>
@@ -5038,7 +5038,7 @@
           <p:cNvPr id="3" name="">
             <a:extLst xmlns:a="http://schemas.openxmlformats.org/drawingml/2006/main">
               <a:ext uri="{FF2B5EF4-FFF2-40B4-BE49-F238E27FC236}">
-                <a16:creationId xmlns:a16="http://schemas.microsoft.com/office/drawing/2014/main" id="{4EEC4CAE-B667-4DEE-A1DF-319968924B4C}"/>
+                <a16:creationId xmlns:a16="http://schemas.microsoft.com/office/drawing/2014/main" id="{4ABB3CDD-308B-434D-A8CF-F4D52FB6164C}"/>
               </a:ext>
             </a:extLst>
           </p:cNvPr>
@@ -5095,7 +5095,7 @@
           <p:cNvPr id="4" name="">
             <a:extLst xmlns:a="http://schemas.openxmlformats.org/drawingml/2006/main">
               <a:ext uri="{FF2B5EF4-FFF2-40B4-BE49-F238E27FC236}">
-                <a16:creationId xmlns:a16="http://schemas.microsoft.com/office/drawing/2014/main" id="{5BED3E77-5796-41A6-994A-02C8AF9E545E}"/>
+                <a16:creationId xmlns:a16="http://schemas.microsoft.com/office/drawing/2014/main" id="{1970268F-2863-487E-99B3-49B612841A1B}"/>
               </a:ext>
             </a:extLst>
           </p:cNvPr>
@@ -5152,7 +5152,7 @@
           <p:cNvPr id="5" name="">
             <a:extLst xmlns:a="http://schemas.openxmlformats.org/drawingml/2006/main">
               <a:ext uri="{FF2B5EF4-FFF2-40B4-BE49-F238E27FC236}">
-                <a16:creationId xmlns:a16="http://schemas.microsoft.com/office/drawing/2014/main" id="{09FA7163-2671-41AA-9487-41FAD1C1C238}"/>
+                <a16:creationId xmlns:a16="http://schemas.microsoft.com/office/drawing/2014/main" id="{7659AB51-13B4-477C-A39A-1A6A28284A98}"/>
               </a:ext>
             </a:extLst>
           </p:cNvPr>
@@ -5209,7 +5209,7 @@
           <p:cNvPr id="6" name="">
             <a:extLst xmlns:a="http://schemas.openxmlformats.org/drawingml/2006/main">
               <a:ext uri="{FF2B5EF4-FFF2-40B4-BE49-F238E27FC236}">
-                <a16:creationId xmlns:a16="http://schemas.microsoft.com/office/drawing/2014/main" id="{F27D7503-A4A6-4B51-8EC0-21BCB8316C43}"/>
+                <a16:creationId xmlns:a16="http://schemas.microsoft.com/office/drawing/2014/main" id="{54C17A4E-B702-4473-A9DC-7C75F9C83830}"/>
               </a:ext>
             </a:extLst>
           </p:cNvPr>
@@ -5239,7 +5239,7 @@
           <p:cNvPr id="7" name="">
             <a:extLst xmlns:a="http://schemas.openxmlformats.org/drawingml/2006/main">
               <a:ext uri="{FF2B5EF4-FFF2-40B4-BE49-F238E27FC236}">
-                <a16:creationId xmlns:a16="http://schemas.microsoft.com/office/drawing/2014/main" id="{73FB7CC8-29E0-4C7A-871D-B0F7AA3D47C5}"/>
+                <a16:creationId xmlns:a16="http://schemas.microsoft.com/office/drawing/2014/main" id="{B5326C1C-2D61-404D-90DA-CD7AD1FDA375}"/>
               </a:ext>
             </a:extLst>
           </p:cNvPr>
@@ -5296,7 +5296,7 @@
           <p:cNvPr id="8" name="">
             <a:extLst xmlns:a="http://schemas.openxmlformats.org/drawingml/2006/main">
               <a:ext uri="{FF2B5EF4-FFF2-40B4-BE49-F238E27FC236}">
-                <a16:creationId xmlns:a16="http://schemas.microsoft.com/office/drawing/2014/main" id="{0A83952E-F879-44D4-A3CD-B4B67B22E82B}"/>
+                <a16:creationId xmlns:a16="http://schemas.microsoft.com/office/drawing/2014/main" id="{B4AEF88A-6BF6-4C5C-BB20-AE4CF53847FF}"/>
               </a:ext>
             </a:extLst>
           </p:cNvPr>
@@ -5353,7 +5353,7 @@
           <p:cNvPr id="9" name="">
             <a:extLst xmlns:a="http://schemas.openxmlformats.org/drawingml/2006/main">
               <a:ext uri="{FF2B5EF4-FFF2-40B4-BE49-F238E27FC236}">
-                <a16:creationId xmlns:a16="http://schemas.microsoft.com/office/drawing/2014/main" id="{98C891E6-0C70-4884-B5C9-33FA4C2C7134}"/>
+                <a16:creationId xmlns:a16="http://schemas.microsoft.com/office/drawing/2014/main" id="{899ABC90-0F22-42EB-802E-982804BB4D11}"/>
               </a:ext>
             </a:extLst>
           </p:cNvPr>
@@ -5383,7 +5383,7 @@
           <p:cNvPr id="10" name="">
             <a:extLst xmlns:a="http://schemas.openxmlformats.org/drawingml/2006/main">
               <a:ext uri="{FF2B5EF4-FFF2-40B4-BE49-F238E27FC236}">
-                <a16:creationId xmlns:a16="http://schemas.microsoft.com/office/drawing/2014/main" id="{3F083ABF-78C0-4D32-99C2-4053212BF08D}"/>
+                <a16:creationId xmlns:a16="http://schemas.microsoft.com/office/drawing/2014/main" id="{6B1AE627-5D06-4A84-BAFC-9EF0E8C5519D}"/>
               </a:ext>
             </a:extLst>
           </p:cNvPr>
@@ -5440,7 +5440,7 @@
           <p:cNvPr id="11" name="">
             <a:extLst xmlns:a="http://schemas.openxmlformats.org/drawingml/2006/main">
               <a:ext uri="{FF2B5EF4-FFF2-40B4-BE49-F238E27FC236}">
-                <a16:creationId xmlns:a16="http://schemas.microsoft.com/office/drawing/2014/main" id="{9A089DD6-86A8-4010-8222-293CC57C65E3}"/>
+                <a16:creationId xmlns:a16="http://schemas.microsoft.com/office/drawing/2014/main" id="{03316186-52A0-4E32-BEE3-BA5A25ABAC8A}"/>
               </a:ext>
             </a:extLst>
           </p:cNvPr>
@@ -5497,7 +5497,7 @@
           <p:cNvPr id="12" name="">
             <a:extLst xmlns:a="http://schemas.openxmlformats.org/drawingml/2006/main">
               <a:ext uri="{FF2B5EF4-FFF2-40B4-BE49-F238E27FC236}">
-                <a16:creationId xmlns:a16="http://schemas.microsoft.com/office/drawing/2014/main" id="{05632406-D7A6-472E-AF29-08D99FF467E6}"/>
+                <a16:creationId xmlns:a16="http://schemas.microsoft.com/office/drawing/2014/main" id="{774AC000-0D68-404B-9E25-F20093EBBA70}"/>
               </a:ext>
             </a:extLst>
           </p:cNvPr>
@@ -5527,7 +5527,7 @@
           <p:cNvPr id="13" name="">
             <a:extLst xmlns:a="http://schemas.openxmlformats.org/drawingml/2006/main">
               <a:ext uri="{FF2B5EF4-FFF2-40B4-BE49-F238E27FC236}">
-                <a16:creationId xmlns:a16="http://schemas.microsoft.com/office/drawing/2014/main" id="{3D6325EA-A786-49E6-8A2F-6F0B174252F4}"/>
+                <a16:creationId xmlns:a16="http://schemas.microsoft.com/office/drawing/2014/main" id="{4823A812-8AF2-4088-A5EE-993D9DAFFEF2}"/>
               </a:ext>
             </a:extLst>
           </p:cNvPr>
@@ -5584,7 +5584,7 @@
           <p:cNvPr id="14" name="">
             <a:extLst xmlns:a="http://schemas.openxmlformats.org/drawingml/2006/main">
               <a:ext uri="{FF2B5EF4-FFF2-40B4-BE49-F238E27FC236}">
-                <a16:creationId xmlns:a16="http://schemas.microsoft.com/office/drawing/2014/main" id="{93C1DA61-7394-48CC-826B-3E6236715ECC}"/>
+                <a16:creationId xmlns:a16="http://schemas.microsoft.com/office/drawing/2014/main" id="{E6495F4C-E89A-44C0-955A-B9671FC353D5}"/>
               </a:ext>
             </a:extLst>
           </p:cNvPr>
@@ -5641,7 +5641,7 @@
           <p:cNvPr id="15" name="">
             <a:extLst xmlns:a="http://schemas.openxmlformats.org/drawingml/2006/main">
               <a:ext uri="{FF2B5EF4-FFF2-40B4-BE49-F238E27FC236}">
-                <a16:creationId xmlns:a16="http://schemas.microsoft.com/office/drawing/2014/main" id="{62B0FE38-1447-48BD-8B31-90587A3265EB}"/>
+                <a16:creationId xmlns:a16="http://schemas.microsoft.com/office/drawing/2014/main" id="{AF959E2D-E121-492B-9D5F-69F0D944DF39}"/>
               </a:ext>
             </a:extLst>
           </p:cNvPr>
@@ -5698,7 +5698,7 @@
           <p:cNvPr id="16" name="">
             <a:extLst xmlns:a="http://schemas.openxmlformats.org/drawingml/2006/main">
               <a:ext uri="{FF2B5EF4-FFF2-40B4-BE49-F238E27FC236}">
-                <a16:creationId xmlns:a16="http://schemas.microsoft.com/office/drawing/2014/main" id="{77E1F2B2-AE0B-4B6D-9EC7-AA08C1D10C94}"/>
+                <a16:creationId xmlns:a16="http://schemas.microsoft.com/office/drawing/2014/main" id="{D74891D9-98C7-4394-9AA8-546AFDA93744}"/>
               </a:ext>
             </a:extLst>
           </p:cNvPr>
@@ -5728,7 +5728,7 @@
           <p:cNvPr id="17" name="">
             <a:extLst xmlns:a="http://schemas.openxmlformats.org/drawingml/2006/main">
               <a:ext uri="{FF2B5EF4-FFF2-40B4-BE49-F238E27FC236}">
-                <a16:creationId xmlns:a16="http://schemas.microsoft.com/office/drawing/2014/main" id="{E26C4BC9-1A94-4585-8A47-674B688D7316}"/>
+                <a16:creationId xmlns:a16="http://schemas.microsoft.com/office/drawing/2014/main" id="{4F86E42B-E3F8-4A3B-985A-4B577098D113}"/>
               </a:ext>
             </a:extLst>
           </p:cNvPr>
@@ -5785,7 +5785,7 @@
           <p:cNvPr id="18" name="">
             <a:extLst xmlns:a="http://schemas.openxmlformats.org/drawingml/2006/main">
               <a:ext uri="{FF2B5EF4-FFF2-40B4-BE49-F238E27FC236}">
-                <a16:creationId xmlns:a16="http://schemas.microsoft.com/office/drawing/2014/main" id="{9ECDAF69-E56B-46F3-A548-EA1A13E09802}"/>
+                <a16:creationId xmlns:a16="http://schemas.microsoft.com/office/drawing/2014/main" id="{3E1B67BC-3A0E-4B8A-860D-3375B490320E}"/>
               </a:ext>
             </a:extLst>
           </p:cNvPr>
@@ -5840,7 +5840,7 @@
     </p:spTree>
     <p:extLst>
       <p:ext uri="{BB962C8B-B14F-4D97-AF65-F5344CB8AC3E}">
-        <p14:creationId xmlns:p14="http://schemas.microsoft.com/office/powerpoint/2010/main" val="578165698"/>
+        <p14:creationId xmlns:p14="http://schemas.microsoft.com/office/powerpoint/2010/main" val="118493464"/>
       </p:ext>
     </p:extLst>
   </p:cSld>
@@ -5871,7 +5871,7 @@
           <p:cNvPr id="19" name="">
             <a:extLst xmlns:a="http://schemas.openxmlformats.org/drawingml/2006/main">
               <a:ext uri="{FF2B5EF4-FFF2-40B4-BE49-F238E27FC236}">
-                <a16:creationId xmlns:a16="http://schemas.microsoft.com/office/drawing/2014/main" id="{9C716E3E-A054-4E3C-BDB6-C6CEBDD44A44}"/>
+                <a16:creationId xmlns:a16="http://schemas.microsoft.com/office/drawing/2014/main" id="{F6F5EDF7-F2AF-40DE-8BE6-5D07B126603A}"/>
               </a:ext>
             </a:extLst>
           </p:cNvPr>
@@ -5928,7 +5928,7 @@
           <p:cNvPr id="2" name="">
             <a:extLst xmlns:a="http://schemas.openxmlformats.org/drawingml/2006/main">
               <a:ext uri="{FF2B5EF4-FFF2-40B4-BE49-F238E27FC236}">
-                <a16:creationId xmlns:a16="http://schemas.microsoft.com/office/drawing/2014/main" id="{EB553EED-6E61-4982-8541-E52A0ED629F2}"/>
+                <a16:creationId xmlns:a16="http://schemas.microsoft.com/office/drawing/2014/main" id="{88A4AA50-1809-4BB4-BC29-85D3AF4644DB}"/>
               </a:ext>
             </a:extLst>
           </p:cNvPr>
@@ -5985,7 +5985,7 @@
           <p:cNvPr id="3" name="">
             <a:extLst xmlns:a="http://schemas.openxmlformats.org/drawingml/2006/main">
               <a:ext uri="{FF2B5EF4-FFF2-40B4-BE49-F238E27FC236}">
-                <a16:creationId xmlns:a16="http://schemas.microsoft.com/office/drawing/2014/main" id="{134312D7-7FEE-42EB-ADCC-15F7DCCC77B4}"/>
+                <a16:creationId xmlns:a16="http://schemas.microsoft.com/office/drawing/2014/main" id="{C43E630D-FEF9-4F9B-8B60-0755B8D383E9}"/>
               </a:ext>
             </a:extLst>
           </p:cNvPr>
@@ -6042,7 +6042,7 @@
           <p:cNvPr id="4" name="">
             <a:extLst xmlns:a="http://schemas.openxmlformats.org/drawingml/2006/main">
               <a:ext uri="{FF2B5EF4-FFF2-40B4-BE49-F238E27FC236}">
-                <a16:creationId xmlns:a16="http://schemas.microsoft.com/office/drawing/2014/main" id="{CA84E435-4FDA-401C-8569-8DF0C1E25EFC}"/>
+                <a16:creationId xmlns:a16="http://schemas.microsoft.com/office/drawing/2014/main" id="{34959376-114C-44C4-BC9B-EC3E895C8FA8}"/>
               </a:ext>
             </a:extLst>
           </p:cNvPr>
@@ -6099,7 +6099,7 @@
           <p:cNvPr id="5" name="">
             <a:extLst xmlns:a="http://schemas.openxmlformats.org/drawingml/2006/main">
               <a:ext uri="{FF2B5EF4-FFF2-40B4-BE49-F238E27FC236}">
-                <a16:creationId xmlns:a16="http://schemas.microsoft.com/office/drawing/2014/main" id="{DCB7FA2E-F396-445C-AAA1-42CF7F2742DA}"/>
+                <a16:creationId xmlns:a16="http://schemas.microsoft.com/office/drawing/2014/main" id="{485334F2-E288-4A45-984C-85026F6F6B4A}"/>
               </a:ext>
             </a:extLst>
           </p:cNvPr>
@@ -6156,7 +6156,7 @@
           <p:cNvPr id="6" name="">
             <a:extLst xmlns:a="http://schemas.openxmlformats.org/drawingml/2006/main">
               <a:ext uri="{FF2B5EF4-FFF2-40B4-BE49-F238E27FC236}">
-                <a16:creationId xmlns:a16="http://schemas.microsoft.com/office/drawing/2014/main" id="{4D93129A-C52E-442D-A7AC-41F3915914C1}"/>
+                <a16:creationId xmlns:a16="http://schemas.microsoft.com/office/drawing/2014/main" id="{947AE103-6A3C-4DE3-908D-39E6CBED39D5}"/>
               </a:ext>
             </a:extLst>
           </p:cNvPr>
@@ -6186,7 +6186,7 @@
           <p:cNvPr id="7" name="">
             <a:extLst xmlns:a="http://schemas.openxmlformats.org/drawingml/2006/main">
               <a:ext uri="{FF2B5EF4-FFF2-40B4-BE49-F238E27FC236}">
-                <a16:creationId xmlns:a16="http://schemas.microsoft.com/office/drawing/2014/main" id="{AF2B8676-7AFB-49DA-B58B-442D76162054}"/>
+                <a16:creationId xmlns:a16="http://schemas.microsoft.com/office/drawing/2014/main" id="{27B88895-4BB0-457E-94AF-29B1E7E69A66}"/>
               </a:ext>
             </a:extLst>
           </p:cNvPr>
@@ -6243,7 +6243,7 @@
           <p:cNvPr id="8" name="">
             <a:extLst xmlns:a="http://schemas.openxmlformats.org/drawingml/2006/main">
               <a:ext uri="{FF2B5EF4-FFF2-40B4-BE49-F238E27FC236}">
-                <a16:creationId xmlns:a16="http://schemas.microsoft.com/office/drawing/2014/main" id="{8FD3CBB7-2789-47C0-B777-9E43F81DE716}"/>
+                <a16:creationId xmlns:a16="http://schemas.microsoft.com/office/drawing/2014/main" id="{981C2976-71EC-470A-9EAE-A07B7E6D3E26}"/>
               </a:ext>
             </a:extLst>
           </p:cNvPr>
@@ -6300,7 +6300,7 @@
           <p:cNvPr id="9" name="">
             <a:extLst xmlns:a="http://schemas.openxmlformats.org/drawingml/2006/main">
               <a:ext uri="{FF2B5EF4-FFF2-40B4-BE49-F238E27FC236}">
-                <a16:creationId xmlns:a16="http://schemas.microsoft.com/office/drawing/2014/main" id="{C6123B4B-8751-420A-9972-81ADAB45E917}"/>
+                <a16:creationId xmlns:a16="http://schemas.microsoft.com/office/drawing/2014/main" id="{A96FFB49-8B71-42D8-AF22-B729CE16CF9D}"/>
               </a:ext>
             </a:extLst>
           </p:cNvPr>
@@ -6330,7 +6330,7 @@
           <p:cNvPr id="10" name="">
             <a:extLst xmlns:a="http://schemas.openxmlformats.org/drawingml/2006/main">
               <a:ext uri="{FF2B5EF4-FFF2-40B4-BE49-F238E27FC236}">
-                <a16:creationId xmlns:a16="http://schemas.microsoft.com/office/drawing/2014/main" id="{0DACBA83-6BEA-4377-B94C-776C2B95036B}"/>
+                <a16:creationId xmlns:a16="http://schemas.microsoft.com/office/drawing/2014/main" id="{656644EB-0562-4FD6-831D-3CA5C70C7350}"/>
               </a:ext>
             </a:extLst>
           </p:cNvPr>
@@ -6387,7 +6387,7 @@
           <p:cNvPr id="11" name="">
             <a:extLst xmlns:a="http://schemas.openxmlformats.org/drawingml/2006/main">
               <a:ext uri="{FF2B5EF4-FFF2-40B4-BE49-F238E27FC236}">
-                <a16:creationId xmlns:a16="http://schemas.microsoft.com/office/drawing/2014/main" id="{EF1DF094-1430-4A3E-885C-9DB74D836880}"/>
+                <a16:creationId xmlns:a16="http://schemas.microsoft.com/office/drawing/2014/main" id="{E194E9F0-4A7A-4D20-9667-5DFFF72435DD}"/>
               </a:ext>
             </a:extLst>
           </p:cNvPr>
@@ -6444,7 +6444,7 @@
           <p:cNvPr id="12" name="">
             <a:extLst xmlns:a="http://schemas.openxmlformats.org/drawingml/2006/main">
               <a:ext uri="{FF2B5EF4-FFF2-40B4-BE49-F238E27FC236}">
-                <a16:creationId xmlns:a16="http://schemas.microsoft.com/office/drawing/2014/main" id="{FEB1C0A4-FD4C-4BA5-A31C-6FFC806444DF}"/>
+                <a16:creationId xmlns:a16="http://schemas.microsoft.com/office/drawing/2014/main" id="{86BA24B6-DA9E-4B03-A925-23CF4718C655}"/>
               </a:ext>
             </a:extLst>
           </p:cNvPr>
@@ -6474,7 +6474,7 @@
           <p:cNvPr id="13" name="">
             <a:extLst xmlns:a="http://schemas.openxmlformats.org/drawingml/2006/main">
               <a:ext uri="{FF2B5EF4-FFF2-40B4-BE49-F238E27FC236}">
-                <a16:creationId xmlns:a16="http://schemas.microsoft.com/office/drawing/2014/main" id="{1E481A30-D065-4603-8138-0ED3D91786FD}"/>
+                <a16:creationId xmlns:a16="http://schemas.microsoft.com/office/drawing/2014/main" id="{3E708BF4-8D5D-4BF1-9245-4E59793050A3}"/>
               </a:ext>
             </a:extLst>
           </p:cNvPr>
@@ -6531,7 +6531,7 @@
           <p:cNvPr id="14" name="">
             <a:extLst xmlns:a="http://schemas.openxmlformats.org/drawingml/2006/main">
               <a:ext uri="{FF2B5EF4-FFF2-40B4-BE49-F238E27FC236}">
-                <a16:creationId xmlns:a16="http://schemas.microsoft.com/office/drawing/2014/main" id="{309DE97B-FB92-4261-BB86-DBC66C352D3D}"/>
+                <a16:creationId xmlns:a16="http://schemas.microsoft.com/office/drawing/2014/main" id="{B90CADD9-4ED6-41AD-8121-16423A837D59}"/>
               </a:ext>
             </a:extLst>
           </p:cNvPr>
@@ -6588,7 +6588,7 @@
           <p:cNvPr id="15" name="">
             <a:extLst xmlns:a="http://schemas.openxmlformats.org/drawingml/2006/main">
               <a:ext uri="{FF2B5EF4-FFF2-40B4-BE49-F238E27FC236}">
-                <a16:creationId xmlns:a16="http://schemas.microsoft.com/office/drawing/2014/main" id="{C6DB1C24-7CEC-4F99-A8F9-E5788B31F7B8}"/>
+                <a16:creationId xmlns:a16="http://schemas.microsoft.com/office/drawing/2014/main" id="{60C37421-4C7E-4E07-BFDB-5DC55A4E88FD}"/>
               </a:ext>
             </a:extLst>
           </p:cNvPr>
@@ -6645,7 +6645,7 @@
           <p:cNvPr id="16" name="">
             <a:extLst xmlns:a="http://schemas.openxmlformats.org/drawingml/2006/main">
               <a:ext uri="{FF2B5EF4-FFF2-40B4-BE49-F238E27FC236}">
-                <a16:creationId xmlns:a16="http://schemas.microsoft.com/office/drawing/2014/main" id="{BA5A4E83-E23A-4D1D-B969-CE6D860FB18E}"/>
+                <a16:creationId xmlns:a16="http://schemas.microsoft.com/office/drawing/2014/main" id="{65858383-AE40-450D-B895-4843014C016A}"/>
               </a:ext>
             </a:extLst>
           </p:cNvPr>
@@ -6675,7 +6675,7 @@
           <p:cNvPr id="17" name="">
             <a:extLst xmlns:a="http://schemas.openxmlformats.org/drawingml/2006/main">
               <a:ext uri="{FF2B5EF4-FFF2-40B4-BE49-F238E27FC236}">
-                <a16:creationId xmlns:a16="http://schemas.microsoft.com/office/drawing/2014/main" id="{866D645D-4C4B-4FC2-8581-0147DF579FE8}"/>
+                <a16:creationId xmlns:a16="http://schemas.microsoft.com/office/drawing/2014/main" id="{60431333-6046-4889-BDA8-4EF1BB62E1DF}"/>
               </a:ext>
             </a:extLst>
           </p:cNvPr>
@@ -6732,7 +6732,7 @@
           <p:cNvPr id="18" name="">
             <a:extLst xmlns:a="http://schemas.openxmlformats.org/drawingml/2006/main">
               <a:ext uri="{FF2B5EF4-FFF2-40B4-BE49-F238E27FC236}">
-                <a16:creationId xmlns:a16="http://schemas.microsoft.com/office/drawing/2014/main" id="{F5C12C70-2698-479A-8058-F9878B97ED6C}"/>
+                <a16:creationId xmlns:a16="http://schemas.microsoft.com/office/drawing/2014/main" id="{C5C807E7-1C91-4117-9914-E7B0F0C9EC85}"/>
               </a:ext>
             </a:extLst>
           </p:cNvPr>
@@ -6787,7 +6787,7 @@
     </p:spTree>
     <p:extLst>
       <p:ext uri="{BB962C8B-B14F-4D97-AF65-F5344CB8AC3E}">
-        <p14:creationId xmlns:p14="http://schemas.microsoft.com/office/powerpoint/2010/main" val="448888140"/>
+        <p14:creationId xmlns:p14="http://schemas.microsoft.com/office/powerpoint/2010/main" val="2129157067"/>
       </p:ext>
     </p:extLst>
   </p:cSld>
@@ -6818,7 +6818,7 @@
           <p:cNvPr id="19" name="">
             <a:extLst xmlns:a="http://schemas.openxmlformats.org/drawingml/2006/main">
               <a:ext uri="{FF2B5EF4-FFF2-40B4-BE49-F238E27FC236}">
-                <a16:creationId xmlns:a16="http://schemas.microsoft.com/office/drawing/2014/main" id="{A0739ABD-5389-42A1-B4F0-CA49F3701313}"/>
+                <a16:creationId xmlns:a16="http://schemas.microsoft.com/office/drawing/2014/main" id="{0762A533-FFE4-41D9-9A5B-3090F0620C2F}"/>
               </a:ext>
             </a:extLst>
           </p:cNvPr>
@@ -6875,7 +6875,7 @@
           <p:cNvPr id="2" name="">
             <a:extLst xmlns:a="http://schemas.openxmlformats.org/drawingml/2006/main">
               <a:ext uri="{FF2B5EF4-FFF2-40B4-BE49-F238E27FC236}">
-                <a16:creationId xmlns:a16="http://schemas.microsoft.com/office/drawing/2014/main" id="{F7996980-C2EE-4C50-A932-3C0E330899BF}"/>
+                <a16:creationId xmlns:a16="http://schemas.microsoft.com/office/drawing/2014/main" id="{8DF04990-8083-4F84-8104-2CF13D07B90C}"/>
               </a:ext>
             </a:extLst>
           </p:cNvPr>
@@ -6932,7 +6932,7 @@
           <p:cNvPr id="3" name="">
             <a:extLst xmlns:a="http://schemas.openxmlformats.org/drawingml/2006/main">
               <a:ext uri="{FF2B5EF4-FFF2-40B4-BE49-F238E27FC236}">
-                <a16:creationId xmlns:a16="http://schemas.microsoft.com/office/drawing/2014/main" id="{CA51E875-49D4-42C9-9F77-B101F8FF08FB}"/>
+                <a16:creationId xmlns:a16="http://schemas.microsoft.com/office/drawing/2014/main" id="{F7812DDA-105E-46EF-B710-C58AD304371A}"/>
               </a:ext>
             </a:extLst>
           </p:cNvPr>
@@ -6989,7 +6989,7 @@
           <p:cNvPr id="4" name="">
             <a:extLst xmlns:a="http://schemas.openxmlformats.org/drawingml/2006/main">
               <a:ext uri="{FF2B5EF4-FFF2-40B4-BE49-F238E27FC236}">
-                <a16:creationId xmlns:a16="http://schemas.microsoft.com/office/drawing/2014/main" id="{9483B084-B9AD-4AA4-8261-3A8708F72DF1}"/>
+                <a16:creationId xmlns:a16="http://schemas.microsoft.com/office/drawing/2014/main" id="{FE701ACB-F09B-44F5-A2DB-4AA6B50AEC11}"/>
               </a:ext>
             </a:extLst>
           </p:cNvPr>
@@ -7046,7 +7046,7 @@
           <p:cNvPr id="5" name="">
             <a:extLst xmlns:a="http://schemas.openxmlformats.org/drawingml/2006/main">
               <a:ext uri="{FF2B5EF4-FFF2-40B4-BE49-F238E27FC236}">
-                <a16:creationId xmlns:a16="http://schemas.microsoft.com/office/drawing/2014/main" id="{4802479D-BF90-4974-868D-1CB93A75DAE5}"/>
+                <a16:creationId xmlns:a16="http://schemas.microsoft.com/office/drawing/2014/main" id="{EC8D3B2B-F210-49D9-87EB-46BE08C4FAD1}"/>
               </a:ext>
             </a:extLst>
           </p:cNvPr>
@@ -7103,7 +7103,7 @@
           <p:cNvPr id="6" name="">
             <a:extLst xmlns:a="http://schemas.openxmlformats.org/drawingml/2006/main">
               <a:ext uri="{FF2B5EF4-FFF2-40B4-BE49-F238E27FC236}">
-                <a16:creationId xmlns:a16="http://schemas.microsoft.com/office/drawing/2014/main" id="{A335AE23-345F-4C3A-844B-E13C514F75FF}"/>
+                <a16:creationId xmlns:a16="http://schemas.microsoft.com/office/drawing/2014/main" id="{E890617F-72EA-4BE8-9A28-39AB7CD591E7}"/>
               </a:ext>
             </a:extLst>
           </p:cNvPr>
@@ -7133,7 +7133,7 @@
           <p:cNvPr id="7" name="">
             <a:extLst xmlns:a="http://schemas.openxmlformats.org/drawingml/2006/main">
               <a:ext uri="{FF2B5EF4-FFF2-40B4-BE49-F238E27FC236}">
-                <a16:creationId xmlns:a16="http://schemas.microsoft.com/office/drawing/2014/main" id="{7FB6E0FC-BB52-4ABE-8D8C-33CEC684B8A2}"/>
+                <a16:creationId xmlns:a16="http://schemas.microsoft.com/office/drawing/2014/main" id="{DCB8BC45-EBC0-47AF-B3D9-56B2AFA3C843}"/>
               </a:ext>
             </a:extLst>
           </p:cNvPr>
@@ -7190,7 +7190,7 @@
           <p:cNvPr id="8" name="">
             <a:extLst xmlns:a="http://schemas.openxmlformats.org/drawingml/2006/main">
               <a:ext uri="{FF2B5EF4-FFF2-40B4-BE49-F238E27FC236}">
-                <a16:creationId xmlns:a16="http://schemas.microsoft.com/office/drawing/2014/main" id="{BE7C9A79-7AAB-4F24-AB16-9018D2BCAD46}"/>
+                <a16:creationId xmlns:a16="http://schemas.microsoft.com/office/drawing/2014/main" id="{7DCCA81B-6AF3-4A7C-B5A5-0AFE0259EEE4}"/>
               </a:ext>
             </a:extLst>
           </p:cNvPr>
@@ -7247,7 +7247,7 @@
           <p:cNvPr id="9" name="">
             <a:extLst xmlns:a="http://schemas.openxmlformats.org/drawingml/2006/main">
               <a:ext uri="{FF2B5EF4-FFF2-40B4-BE49-F238E27FC236}">
-                <a16:creationId xmlns:a16="http://schemas.microsoft.com/office/drawing/2014/main" id="{8802473F-BF47-4EA9-8CBF-CEF43B918B3A}"/>
+                <a16:creationId xmlns:a16="http://schemas.microsoft.com/office/drawing/2014/main" id="{D7D95CBE-F33C-4020-9256-7E16954E435C}"/>
               </a:ext>
             </a:extLst>
           </p:cNvPr>
@@ -7277,7 +7277,7 @@
           <p:cNvPr id="10" name="">
             <a:extLst xmlns:a="http://schemas.openxmlformats.org/drawingml/2006/main">
               <a:ext uri="{FF2B5EF4-FFF2-40B4-BE49-F238E27FC236}">
-                <a16:creationId xmlns:a16="http://schemas.microsoft.com/office/drawing/2014/main" id="{C8B281DE-78A7-4FE6-82D1-F3C0DC11E09F}"/>
+                <a16:creationId xmlns:a16="http://schemas.microsoft.com/office/drawing/2014/main" id="{21FF42BF-A581-4CCC-8779-9E7C518E36FE}"/>
               </a:ext>
             </a:extLst>
           </p:cNvPr>
@@ -7334,7 +7334,7 @@
           <p:cNvPr id="11" name="">
             <a:extLst xmlns:a="http://schemas.openxmlformats.org/drawingml/2006/main">
               <a:ext uri="{FF2B5EF4-FFF2-40B4-BE49-F238E27FC236}">
-                <a16:creationId xmlns:a16="http://schemas.microsoft.com/office/drawing/2014/main" id="{1F0218FC-636F-41DA-BAE0-39E07115958C}"/>
+                <a16:creationId xmlns:a16="http://schemas.microsoft.com/office/drawing/2014/main" id="{88ECC197-B779-4452-81A3-620B09F56E95}"/>
               </a:ext>
             </a:extLst>
           </p:cNvPr>
@@ -7391,7 +7391,7 @@
           <p:cNvPr id="12" name="">
             <a:extLst xmlns:a="http://schemas.openxmlformats.org/drawingml/2006/main">
               <a:ext uri="{FF2B5EF4-FFF2-40B4-BE49-F238E27FC236}">
-                <a16:creationId xmlns:a16="http://schemas.microsoft.com/office/drawing/2014/main" id="{5469A757-42EF-4D21-943F-3C8C6C947751}"/>
+                <a16:creationId xmlns:a16="http://schemas.microsoft.com/office/drawing/2014/main" id="{4B97349D-303F-42B8-87FE-F00D2FF691EF}"/>
               </a:ext>
             </a:extLst>
           </p:cNvPr>
@@ -7421,7 +7421,7 @@
           <p:cNvPr id="13" name="">
             <a:extLst xmlns:a="http://schemas.openxmlformats.org/drawingml/2006/main">
               <a:ext uri="{FF2B5EF4-FFF2-40B4-BE49-F238E27FC236}">
-                <a16:creationId xmlns:a16="http://schemas.microsoft.com/office/drawing/2014/main" id="{7C0DE088-1CDA-4C0B-A151-EC03824503C6}"/>
+                <a16:creationId xmlns:a16="http://schemas.microsoft.com/office/drawing/2014/main" id="{273AF63F-19C8-4826-9726-11B061D522D4}"/>
               </a:ext>
             </a:extLst>
           </p:cNvPr>
@@ -7478,7 +7478,7 @@
           <p:cNvPr id="14" name="">
             <a:extLst xmlns:a="http://schemas.openxmlformats.org/drawingml/2006/main">
               <a:ext uri="{FF2B5EF4-FFF2-40B4-BE49-F238E27FC236}">
-                <a16:creationId xmlns:a16="http://schemas.microsoft.com/office/drawing/2014/main" id="{FC60F713-816C-4F9C-9A55-49F69EA1ECCE}"/>
+                <a16:creationId xmlns:a16="http://schemas.microsoft.com/office/drawing/2014/main" id="{9D54CFA3-A667-437E-A0D0-9951E56190A8}"/>
               </a:ext>
             </a:extLst>
           </p:cNvPr>
@@ -7535,7 +7535,7 @@
           <p:cNvPr id="15" name="">
             <a:extLst xmlns:a="http://schemas.openxmlformats.org/drawingml/2006/main">
               <a:ext uri="{FF2B5EF4-FFF2-40B4-BE49-F238E27FC236}">
-                <a16:creationId xmlns:a16="http://schemas.microsoft.com/office/drawing/2014/main" id="{712FE679-5904-4DC8-AC1C-98D464295942}"/>
+                <a16:creationId xmlns:a16="http://schemas.microsoft.com/office/drawing/2014/main" id="{05F6DB0A-9F02-412F-87A3-A7E5825F16AA}"/>
               </a:ext>
             </a:extLst>
           </p:cNvPr>
@@ -7592,7 +7592,7 @@
           <p:cNvPr id="16" name="">
             <a:extLst xmlns:a="http://schemas.openxmlformats.org/drawingml/2006/main">
               <a:ext uri="{FF2B5EF4-FFF2-40B4-BE49-F238E27FC236}">
-                <a16:creationId xmlns:a16="http://schemas.microsoft.com/office/drawing/2014/main" id="{11C490F3-CBC6-4B6A-887E-4E1F1B6116CD}"/>
+                <a16:creationId xmlns:a16="http://schemas.microsoft.com/office/drawing/2014/main" id="{2CDCDB91-655E-40FC-B563-E10F315447C2}"/>
               </a:ext>
             </a:extLst>
           </p:cNvPr>
@@ -7622,7 +7622,7 @@
           <p:cNvPr id="17" name="">
             <a:extLst xmlns:a="http://schemas.openxmlformats.org/drawingml/2006/main">
               <a:ext uri="{FF2B5EF4-FFF2-40B4-BE49-F238E27FC236}">
-                <a16:creationId xmlns:a16="http://schemas.microsoft.com/office/drawing/2014/main" id="{6EA4F09D-0A2B-4AB1-B736-9DD96A7EDAB6}"/>
+                <a16:creationId xmlns:a16="http://schemas.microsoft.com/office/drawing/2014/main" id="{45514C8F-C88B-4D8B-ADA7-3294CE9DBDBD}"/>
               </a:ext>
             </a:extLst>
           </p:cNvPr>
@@ -7679,7 +7679,7 @@
           <p:cNvPr id="18" name="">
             <a:extLst xmlns:a="http://schemas.openxmlformats.org/drawingml/2006/main">
               <a:ext uri="{FF2B5EF4-FFF2-40B4-BE49-F238E27FC236}">
-                <a16:creationId xmlns:a16="http://schemas.microsoft.com/office/drawing/2014/main" id="{F29A7B34-508A-40ED-801C-6E01E75E3DB3}"/>
+                <a16:creationId xmlns:a16="http://schemas.microsoft.com/office/drawing/2014/main" id="{EAC5EE86-D566-4CEC-B7BB-0B44E57E24F2}"/>
               </a:ext>
             </a:extLst>
           </p:cNvPr>
@@ -7734,7 +7734,7 @@
     </p:spTree>
     <p:extLst>
       <p:ext uri="{BB962C8B-B14F-4D97-AF65-F5344CB8AC3E}">
-        <p14:creationId xmlns:p14="http://schemas.microsoft.com/office/powerpoint/2010/main" val="634439994"/>
+        <p14:creationId xmlns:p14="http://schemas.microsoft.com/office/powerpoint/2010/main" val="1060397197"/>
       </p:ext>
     </p:extLst>
   </p:cSld>
@@ -7765,7 +7765,7 @@
           <p:cNvPr id="19" name="">
             <a:extLst xmlns:a="http://schemas.openxmlformats.org/drawingml/2006/main">
               <a:ext uri="{FF2B5EF4-FFF2-40B4-BE49-F238E27FC236}">
-                <a16:creationId xmlns:a16="http://schemas.microsoft.com/office/drawing/2014/main" id="{E7D6D29B-A873-4140-81B4-415AA67ADBB6}"/>
+                <a16:creationId xmlns:a16="http://schemas.microsoft.com/office/drawing/2014/main" id="{81BFA522-8B43-4EC6-BA18-5D378B98C104}"/>
               </a:ext>
             </a:extLst>
           </p:cNvPr>
@@ -7822,7 +7822,7 @@
           <p:cNvPr id="2" name="">
             <a:extLst xmlns:a="http://schemas.openxmlformats.org/drawingml/2006/main">
               <a:ext uri="{FF2B5EF4-FFF2-40B4-BE49-F238E27FC236}">
-                <a16:creationId xmlns:a16="http://schemas.microsoft.com/office/drawing/2014/main" id="{83273D5F-223D-4F28-B1F1-15F585355498}"/>
+                <a16:creationId xmlns:a16="http://schemas.microsoft.com/office/drawing/2014/main" id="{F0BDC2F1-54B4-4C1F-884E-E65D54056ADF}"/>
               </a:ext>
             </a:extLst>
           </p:cNvPr>
@@ -7879,7 +7879,7 @@
           <p:cNvPr id="3" name="">
             <a:extLst xmlns:a="http://schemas.openxmlformats.org/drawingml/2006/main">
               <a:ext uri="{FF2B5EF4-FFF2-40B4-BE49-F238E27FC236}">
-                <a16:creationId xmlns:a16="http://schemas.microsoft.com/office/drawing/2014/main" id="{C2C818B3-5D4F-4949-9009-091856E30878}"/>
+                <a16:creationId xmlns:a16="http://schemas.microsoft.com/office/drawing/2014/main" id="{14C781AA-C558-463C-AFA3-929783D428AF}"/>
               </a:ext>
             </a:extLst>
           </p:cNvPr>
@@ -7936,7 +7936,7 @@
           <p:cNvPr id="4" name="">
             <a:extLst xmlns:a="http://schemas.openxmlformats.org/drawingml/2006/main">
               <a:ext uri="{FF2B5EF4-FFF2-40B4-BE49-F238E27FC236}">
-                <a16:creationId xmlns:a16="http://schemas.microsoft.com/office/drawing/2014/main" id="{4B8B875B-0582-44F1-B824-69DB92535043}"/>
+                <a16:creationId xmlns:a16="http://schemas.microsoft.com/office/drawing/2014/main" id="{FDB4BD4F-3E10-44E5-8EE9-8B786799C4C0}"/>
               </a:ext>
             </a:extLst>
           </p:cNvPr>
@@ -7993,7 +7993,7 @@
           <p:cNvPr id="5" name="">
             <a:extLst xmlns:a="http://schemas.openxmlformats.org/drawingml/2006/main">
               <a:ext uri="{FF2B5EF4-FFF2-40B4-BE49-F238E27FC236}">
-                <a16:creationId xmlns:a16="http://schemas.microsoft.com/office/drawing/2014/main" id="{AC52AB87-01D4-41C4-8025-2BB80A695448}"/>
+                <a16:creationId xmlns:a16="http://schemas.microsoft.com/office/drawing/2014/main" id="{13E5E6A7-5B17-42A3-9AA7-4152FBC8C25D}"/>
               </a:ext>
             </a:extLst>
           </p:cNvPr>
@@ -8050,7 +8050,7 @@
           <p:cNvPr id="6" name="">
             <a:extLst xmlns:a="http://schemas.openxmlformats.org/drawingml/2006/main">
               <a:ext uri="{FF2B5EF4-FFF2-40B4-BE49-F238E27FC236}">
-                <a16:creationId xmlns:a16="http://schemas.microsoft.com/office/drawing/2014/main" id="{4D99CC7E-3035-493A-8185-A3575EA4CAF1}"/>
+                <a16:creationId xmlns:a16="http://schemas.microsoft.com/office/drawing/2014/main" id="{D97869D7-95C0-4FBC-BEF3-8A09F8EFA094}"/>
               </a:ext>
             </a:extLst>
           </p:cNvPr>
@@ -8080,7 +8080,7 @@
           <p:cNvPr id="7" name="">
             <a:extLst xmlns:a="http://schemas.openxmlformats.org/drawingml/2006/main">
               <a:ext uri="{FF2B5EF4-FFF2-40B4-BE49-F238E27FC236}">
-                <a16:creationId xmlns:a16="http://schemas.microsoft.com/office/drawing/2014/main" id="{91F9E7AB-13CD-40EE-B231-B5BB298FED3D}"/>
+                <a16:creationId xmlns:a16="http://schemas.microsoft.com/office/drawing/2014/main" id="{D12B37F0-78AB-4DCE-88A5-4483513AE9AF}"/>
               </a:ext>
             </a:extLst>
           </p:cNvPr>
@@ -8137,7 +8137,7 @@
           <p:cNvPr id="8" name="">
             <a:extLst xmlns:a="http://schemas.openxmlformats.org/drawingml/2006/main">
               <a:ext uri="{FF2B5EF4-FFF2-40B4-BE49-F238E27FC236}">
-                <a16:creationId xmlns:a16="http://schemas.microsoft.com/office/drawing/2014/main" id="{FC197A74-F4A0-4049-9E97-080D6584FE56}"/>
+                <a16:creationId xmlns:a16="http://schemas.microsoft.com/office/drawing/2014/main" id="{87BA9D7E-7BE9-4476-A2FB-C8EB5A531475}"/>
               </a:ext>
             </a:extLst>
           </p:cNvPr>
@@ -8194,7 +8194,7 @@
           <p:cNvPr id="9" name="">
             <a:extLst xmlns:a="http://schemas.openxmlformats.org/drawingml/2006/main">
               <a:ext uri="{FF2B5EF4-FFF2-40B4-BE49-F238E27FC236}">
-                <a16:creationId xmlns:a16="http://schemas.microsoft.com/office/drawing/2014/main" id="{4E7A9068-688F-47B5-B145-2297BE156031}"/>
+                <a16:creationId xmlns:a16="http://schemas.microsoft.com/office/drawing/2014/main" id="{221EC97B-7BC1-4304-8548-0CB4BE4401F3}"/>
               </a:ext>
             </a:extLst>
           </p:cNvPr>
@@ -8224,7 +8224,7 @@
           <p:cNvPr id="10" name="">
             <a:extLst xmlns:a="http://schemas.openxmlformats.org/drawingml/2006/main">
               <a:ext uri="{FF2B5EF4-FFF2-40B4-BE49-F238E27FC236}">
-                <a16:creationId xmlns:a16="http://schemas.microsoft.com/office/drawing/2014/main" id="{ACC1773D-1723-4493-AD0B-A47433EE4EBD}"/>
+                <a16:creationId xmlns:a16="http://schemas.microsoft.com/office/drawing/2014/main" id="{08FE5010-5DAD-4ECC-B95A-4FD335EDF45E}"/>
               </a:ext>
             </a:extLst>
           </p:cNvPr>
@@ -8281,7 +8281,7 @@
           <p:cNvPr id="11" name="">
             <a:extLst xmlns:a="http://schemas.openxmlformats.org/drawingml/2006/main">
               <a:ext uri="{FF2B5EF4-FFF2-40B4-BE49-F238E27FC236}">
-                <a16:creationId xmlns:a16="http://schemas.microsoft.com/office/drawing/2014/main" id="{E3FE33AC-5CC1-4393-87FE-ABA7BACDD35F}"/>
+                <a16:creationId xmlns:a16="http://schemas.microsoft.com/office/drawing/2014/main" id="{9EF51E68-7FE1-4B2C-ADB3-F14DEAA86C40}"/>
               </a:ext>
             </a:extLst>
           </p:cNvPr>
@@ -8338,7 +8338,7 @@
           <p:cNvPr id="12" name="">
             <a:extLst xmlns:a="http://schemas.openxmlformats.org/drawingml/2006/main">
               <a:ext uri="{FF2B5EF4-FFF2-40B4-BE49-F238E27FC236}">
-                <a16:creationId xmlns:a16="http://schemas.microsoft.com/office/drawing/2014/main" id="{8A79B2E9-272F-4200-8934-BEAA5C0C791C}"/>
+                <a16:creationId xmlns:a16="http://schemas.microsoft.com/office/drawing/2014/main" id="{FC209666-2841-4834-A07E-559BB2271570}"/>
               </a:ext>
             </a:extLst>
           </p:cNvPr>
@@ -8368,7 +8368,7 @@
           <p:cNvPr id="13" name="">
             <a:extLst xmlns:a="http://schemas.openxmlformats.org/drawingml/2006/main">
               <a:ext uri="{FF2B5EF4-FFF2-40B4-BE49-F238E27FC236}">
-                <a16:creationId xmlns:a16="http://schemas.microsoft.com/office/drawing/2014/main" id="{DF2618DA-E9FA-4DF1-BB71-659924747266}"/>
+                <a16:creationId xmlns:a16="http://schemas.microsoft.com/office/drawing/2014/main" id="{BECE78E5-C3AE-49F4-B091-53C288EF4DB0}"/>
               </a:ext>
             </a:extLst>
           </p:cNvPr>
@@ -8425,7 +8425,7 @@
           <p:cNvPr id="14" name="">
             <a:extLst xmlns:a="http://schemas.openxmlformats.org/drawingml/2006/main">
               <a:ext uri="{FF2B5EF4-FFF2-40B4-BE49-F238E27FC236}">
-                <a16:creationId xmlns:a16="http://schemas.microsoft.com/office/drawing/2014/main" id="{8ED948FE-B980-4A98-B9A8-293689D2B2D9}"/>
+                <a16:creationId xmlns:a16="http://schemas.microsoft.com/office/drawing/2014/main" id="{B5D6A1FE-3FBC-44E9-A351-776AD66E9ACE}"/>
               </a:ext>
             </a:extLst>
           </p:cNvPr>
@@ -8482,7 +8482,7 @@
           <p:cNvPr id="15" name="">
             <a:extLst xmlns:a="http://schemas.openxmlformats.org/drawingml/2006/main">
               <a:ext uri="{FF2B5EF4-FFF2-40B4-BE49-F238E27FC236}">
-                <a16:creationId xmlns:a16="http://schemas.microsoft.com/office/drawing/2014/main" id="{BFD23AFD-2532-4420-B9F0-40ADFE5DFF74}"/>
+                <a16:creationId xmlns:a16="http://schemas.microsoft.com/office/drawing/2014/main" id="{EF89AA3D-975E-428E-AFE1-05E80957AFF3}"/>
               </a:ext>
             </a:extLst>
           </p:cNvPr>
@@ -8539,7 +8539,7 @@
           <p:cNvPr id="16" name="">
             <a:extLst xmlns:a="http://schemas.openxmlformats.org/drawingml/2006/main">
               <a:ext uri="{FF2B5EF4-FFF2-40B4-BE49-F238E27FC236}">
-                <a16:creationId xmlns:a16="http://schemas.microsoft.com/office/drawing/2014/main" id="{E1E93B8B-48BA-443D-9C54-AC2C4E75557B}"/>
+                <a16:creationId xmlns:a16="http://schemas.microsoft.com/office/drawing/2014/main" id="{B5F2F757-EE21-45B1-BB92-867F65C75C68}"/>
               </a:ext>
             </a:extLst>
           </p:cNvPr>
@@ -8569,7 +8569,7 @@
           <p:cNvPr id="17" name="">
             <a:extLst xmlns:a="http://schemas.openxmlformats.org/drawingml/2006/main">
               <a:ext uri="{FF2B5EF4-FFF2-40B4-BE49-F238E27FC236}">
-                <a16:creationId xmlns:a16="http://schemas.microsoft.com/office/drawing/2014/main" id="{9F62783F-D89D-408C-A6AC-3A88648B34F4}"/>
+                <a16:creationId xmlns:a16="http://schemas.microsoft.com/office/drawing/2014/main" id="{8956B8C9-2E03-4E20-A71E-B37E6919797A}"/>
               </a:ext>
             </a:extLst>
           </p:cNvPr>
@@ -8626,7 +8626,7 @@
           <p:cNvPr id="18" name="">
             <a:extLst xmlns:a="http://schemas.openxmlformats.org/drawingml/2006/main">
               <a:ext uri="{FF2B5EF4-FFF2-40B4-BE49-F238E27FC236}">
-                <a16:creationId xmlns:a16="http://schemas.microsoft.com/office/drawing/2014/main" id="{D908BED5-410C-47A5-A26F-F5D43FC3DCFA}"/>
+                <a16:creationId xmlns:a16="http://schemas.microsoft.com/office/drawing/2014/main" id="{5095E62E-6320-4E20-884A-22B9CD33D06D}"/>
               </a:ext>
             </a:extLst>
           </p:cNvPr>
@@ -8681,7 +8681,7 @@
     </p:spTree>
     <p:extLst>
       <p:ext uri="{BB962C8B-B14F-4D97-AF65-F5344CB8AC3E}">
-        <p14:creationId xmlns:p14="http://schemas.microsoft.com/office/powerpoint/2010/main" val="1765508779"/>
+        <p14:creationId xmlns:p14="http://schemas.microsoft.com/office/powerpoint/2010/main" val="214153370"/>
       </p:ext>
     </p:extLst>
   </p:cSld>
@@ -8712,7 +8712,7 @@
           <p:cNvPr id="20" name="">
             <a:extLst xmlns:a="http://schemas.openxmlformats.org/drawingml/2006/main">
               <a:ext uri="{FF2B5EF4-FFF2-40B4-BE49-F238E27FC236}">
-                <a16:creationId xmlns:a16="http://schemas.microsoft.com/office/drawing/2014/main" id="{B584B0D3-447C-4D9A-AEEF-F61FBA58AAEE}"/>
+                <a16:creationId xmlns:a16="http://schemas.microsoft.com/office/drawing/2014/main" id="{B4047E04-BCAE-4FF0-B2EC-949278A69BE5}"/>
               </a:ext>
             </a:extLst>
           </p:cNvPr>
@@ -8769,7 +8769,7 @@
           <p:cNvPr id="2" name="">
             <a:extLst xmlns:a="http://schemas.openxmlformats.org/drawingml/2006/main">
               <a:ext uri="{FF2B5EF4-FFF2-40B4-BE49-F238E27FC236}">
-                <a16:creationId xmlns:a16="http://schemas.microsoft.com/office/drawing/2014/main" id="{A44EC093-7BE0-4B25-AA4B-F045A6F610A1}"/>
+                <a16:creationId xmlns:a16="http://schemas.microsoft.com/office/drawing/2014/main" id="{06D35679-AB40-4738-B12F-9CC4880C9165}"/>
               </a:ext>
             </a:extLst>
           </p:cNvPr>
@@ -8826,7 +8826,7 @@
           <p:cNvPr id="3" name="">
             <a:extLst xmlns:a="http://schemas.openxmlformats.org/drawingml/2006/main">
               <a:ext uri="{FF2B5EF4-FFF2-40B4-BE49-F238E27FC236}">
-                <a16:creationId xmlns:a16="http://schemas.microsoft.com/office/drawing/2014/main" id="{4E899C14-467C-4E25-B6EC-22F489FA7DF0}"/>
+                <a16:creationId xmlns:a16="http://schemas.microsoft.com/office/drawing/2014/main" id="{5A1C9BE5-1F49-4117-AE41-651629246C6B}"/>
               </a:ext>
             </a:extLst>
           </p:cNvPr>
@@ -8883,7 +8883,7 @@
           <p:cNvPr id="4" name="">
             <a:extLst xmlns:a="http://schemas.openxmlformats.org/drawingml/2006/main">
               <a:ext uri="{FF2B5EF4-FFF2-40B4-BE49-F238E27FC236}">
-                <a16:creationId xmlns:a16="http://schemas.microsoft.com/office/drawing/2014/main" id="{6F22F826-ECF4-430F-B90D-8A3905DE669E}"/>
+                <a16:creationId xmlns:a16="http://schemas.microsoft.com/office/drawing/2014/main" id="{76518DE0-0F0D-4785-A48A-C853009CD036}"/>
               </a:ext>
             </a:extLst>
           </p:cNvPr>
@@ -8940,7 +8940,7 @@
           <p:cNvPr id="5" name="">
             <a:extLst xmlns:a="http://schemas.openxmlformats.org/drawingml/2006/main">
               <a:ext uri="{FF2B5EF4-FFF2-40B4-BE49-F238E27FC236}">
-                <a16:creationId xmlns:a16="http://schemas.microsoft.com/office/drawing/2014/main" id="{D6F80588-18CC-49B4-B4AE-495BFCF65D10}"/>
+                <a16:creationId xmlns:a16="http://schemas.microsoft.com/office/drawing/2014/main" id="{9EBBA125-7E8B-4A01-B10C-3051BD6A76D9}"/>
               </a:ext>
             </a:extLst>
           </p:cNvPr>
@@ -8997,7 +8997,7 @@
           <p:cNvPr id="6" name="">
             <a:extLst xmlns:a="http://schemas.openxmlformats.org/drawingml/2006/main">
               <a:ext uri="{FF2B5EF4-FFF2-40B4-BE49-F238E27FC236}">
-                <a16:creationId xmlns:a16="http://schemas.microsoft.com/office/drawing/2014/main" id="{6DB6B4DD-D762-457B-8DA3-394096205492}"/>
+                <a16:creationId xmlns:a16="http://schemas.microsoft.com/office/drawing/2014/main" id="{7137A4B6-05F7-47C4-BC90-E93C971D2CD1}"/>
               </a:ext>
             </a:extLst>
           </p:cNvPr>
@@ -9027,7 +9027,7 @@
           <p:cNvPr id="7" name="">
             <a:extLst xmlns:a="http://schemas.openxmlformats.org/drawingml/2006/main">
               <a:ext uri="{FF2B5EF4-FFF2-40B4-BE49-F238E27FC236}">
-                <a16:creationId xmlns:a16="http://schemas.microsoft.com/office/drawing/2014/main" id="{F54E5278-B618-4354-B05A-2C5EFA736C3D}"/>
+                <a16:creationId xmlns:a16="http://schemas.microsoft.com/office/drawing/2014/main" id="{631A4BB2-3368-4328-A5E6-B0E5DFCD445D}"/>
               </a:ext>
             </a:extLst>
           </p:cNvPr>
@@ -9084,7 +9084,7 @@
           <p:cNvPr id="8" name="">
             <a:extLst xmlns:a="http://schemas.openxmlformats.org/drawingml/2006/main">
               <a:ext uri="{FF2B5EF4-FFF2-40B4-BE49-F238E27FC236}">
-                <a16:creationId xmlns:a16="http://schemas.microsoft.com/office/drawing/2014/main" id="{90984F8D-295D-45E7-B4B4-192A98825638}"/>
+                <a16:creationId xmlns:a16="http://schemas.microsoft.com/office/drawing/2014/main" id="{4E503B54-2423-42E8-B0BB-3FD7FA314134}"/>
               </a:ext>
             </a:extLst>
           </p:cNvPr>
@@ -9141,7 +9141,7 @@
           <p:cNvPr id="9" name="">
             <a:extLst xmlns:a="http://schemas.openxmlformats.org/drawingml/2006/main">
               <a:ext uri="{FF2B5EF4-FFF2-40B4-BE49-F238E27FC236}">
-                <a16:creationId xmlns:a16="http://schemas.microsoft.com/office/drawing/2014/main" id="{86424827-274C-4BF2-A830-D6AE1D306919}"/>
+                <a16:creationId xmlns:a16="http://schemas.microsoft.com/office/drawing/2014/main" id="{60BD8F77-37F4-40E4-AA0B-A2D1DFFE746B}"/>
               </a:ext>
             </a:extLst>
           </p:cNvPr>
@@ -9171,7 +9171,7 @@
           <p:cNvPr id="10" name="">
             <a:extLst xmlns:a="http://schemas.openxmlformats.org/drawingml/2006/main">
               <a:ext uri="{FF2B5EF4-FFF2-40B4-BE49-F238E27FC236}">
-                <a16:creationId xmlns:a16="http://schemas.microsoft.com/office/drawing/2014/main" id="{5693FC2F-9698-4144-95BB-82C57A401939}"/>
+                <a16:creationId xmlns:a16="http://schemas.microsoft.com/office/drawing/2014/main" id="{F9393226-3912-44F7-9BC9-D9BECE9AD2E2}"/>
               </a:ext>
             </a:extLst>
           </p:cNvPr>
@@ -9228,7 +9228,7 @@
           <p:cNvPr id="11" name="">
             <a:extLst xmlns:a="http://schemas.openxmlformats.org/drawingml/2006/main">
               <a:ext uri="{FF2B5EF4-FFF2-40B4-BE49-F238E27FC236}">
-                <a16:creationId xmlns:a16="http://schemas.microsoft.com/office/drawing/2014/main" id="{2CF1F41F-0F51-414D-89CA-B6DC6C66B73A}"/>
+                <a16:creationId xmlns:a16="http://schemas.microsoft.com/office/drawing/2014/main" id="{E3F5C796-F596-4D83-B913-8E88CCCD806E}"/>
               </a:ext>
             </a:extLst>
           </p:cNvPr>
@@ -9285,7 +9285,7 @@
           <p:cNvPr id="12" name="">
             <a:extLst xmlns:a="http://schemas.openxmlformats.org/drawingml/2006/main">
               <a:ext uri="{FF2B5EF4-FFF2-40B4-BE49-F238E27FC236}">
-                <a16:creationId xmlns:a16="http://schemas.microsoft.com/office/drawing/2014/main" id="{847B9084-481F-4D56-AEF8-7FC15130A812}"/>
+                <a16:creationId xmlns:a16="http://schemas.microsoft.com/office/drawing/2014/main" id="{845D0735-3019-4221-A25D-1C87B28B9B98}"/>
               </a:ext>
             </a:extLst>
           </p:cNvPr>
@@ -9315,7 +9315,7 @@
           <p:cNvPr id="13" name="">
             <a:extLst xmlns:a="http://schemas.openxmlformats.org/drawingml/2006/main">
               <a:ext uri="{FF2B5EF4-FFF2-40B4-BE49-F238E27FC236}">
-                <a16:creationId xmlns:a16="http://schemas.microsoft.com/office/drawing/2014/main" id="{BFF6359A-0F03-4D56-8C76-CE6D72696850}"/>
+                <a16:creationId xmlns:a16="http://schemas.microsoft.com/office/drawing/2014/main" id="{F13C338F-5072-412D-B879-7378B440FC51}"/>
               </a:ext>
             </a:extLst>
           </p:cNvPr>
@@ -9372,7 +9372,7 @@
           <p:cNvPr id="14" name="">
             <a:extLst xmlns:a="http://schemas.openxmlformats.org/drawingml/2006/main">
               <a:ext uri="{FF2B5EF4-FFF2-40B4-BE49-F238E27FC236}">
-                <a16:creationId xmlns:a16="http://schemas.microsoft.com/office/drawing/2014/main" id="{29BBF9B7-4BB1-4E33-B909-D3E028A9A6A6}"/>
+                <a16:creationId xmlns:a16="http://schemas.microsoft.com/office/drawing/2014/main" id="{CF97B278-3CA6-4A9B-B8BF-0A2DD103B8D5}"/>
               </a:ext>
             </a:extLst>
           </p:cNvPr>
@@ -9429,7 +9429,7 @@
           <p:cNvPr id="15" name="">
             <a:extLst xmlns:a="http://schemas.openxmlformats.org/drawingml/2006/main">
               <a:ext uri="{FF2B5EF4-FFF2-40B4-BE49-F238E27FC236}">
-                <a16:creationId xmlns:a16="http://schemas.microsoft.com/office/drawing/2014/main" id="{B455A8B4-1A66-455A-BE84-4ACE0B013337}"/>
+                <a16:creationId xmlns:a16="http://schemas.microsoft.com/office/drawing/2014/main" id="{267C587A-1E67-4331-BE4F-827FCE2D4E28}"/>
               </a:ext>
             </a:extLst>
           </p:cNvPr>
@@ -9486,7 +9486,7 @@
           <p:cNvPr id="16" name="">
             <a:extLst xmlns:a="http://schemas.openxmlformats.org/drawingml/2006/main">
               <a:ext uri="{FF2B5EF4-FFF2-40B4-BE49-F238E27FC236}">
-                <a16:creationId xmlns:a16="http://schemas.microsoft.com/office/drawing/2014/main" id="{BF4709C4-08F2-42E6-8664-3C2443EB1790}"/>
+                <a16:creationId xmlns:a16="http://schemas.microsoft.com/office/drawing/2014/main" id="{746855C6-FBB5-47B2-A256-4DCDF5025741}"/>
               </a:ext>
             </a:extLst>
           </p:cNvPr>
@@ -9543,7 +9543,7 @@
           <p:cNvPr id="17" name="">
             <a:extLst xmlns:a="http://schemas.openxmlformats.org/drawingml/2006/main">
               <a:ext uri="{FF2B5EF4-FFF2-40B4-BE49-F238E27FC236}">
-                <a16:creationId xmlns:a16="http://schemas.microsoft.com/office/drawing/2014/main" id="{D3A012F3-8C4F-448B-A31F-0C501DE6AFD0}"/>
+                <a16:creationId xmlns:a16="http://schemas.microsoft.com/office/drawing/2014/main" id="{A6F7BBA7-12A1-4EA4-986D-7A4141D73017}"/>
               </a:ext>
             </a:extLst>
           </p:cNvPr>
@@ -9573,7 +9573,7 @@
           <p:cNvPr id="18" name="">
             <a:extLst xmlns:a="http://schemas.openxmlformats.org/drawingml/2006/main">
               <a:ext uri="{FF2B5EF4-FFF2-40B4-BE49-F238E27FC236}">
-                <a16:creationId xmlns:a16="http://schemas.microsoft.com/office/drawing/2014/main" id="{23232DAD-8B6D-430C-9763-1C6087A93C69}"/>
+                <a16:creationId xmlns:a16="http://schemas.microsoft.com/office/drawing/2014/main" id="{939B9609-0E44-4BFA-B4AB-63B0408A5A37}"/>
               </a:ext>
             </a:extLst>
           </p:cNvPr>
@@ -9630,7 +9630,7 @@
           <p:cNvPr id="19" name="">
             <a:extLst xmlns:a="http://schemas.openxmlformats.org/drawingml/2006/main">
               <a:ext uri="{FF2B5EF4-FFF2-40B4-BE49-F238E27FC236}">
-                <a16:creationId xmlns:a16="http://schemas.microsoft.com/office/drawing/2014/main" id="{05A0493A-F80A-4325-B9FA-77E369FBC3E4}"/>
+                <a16:creationId xmlns:a16="http://schemas.microsoft.com/office/drawing/2014/main" id="{7AB0B074-0B4D-4009-99CB-F554157DFD1D}"/>
               </a:ext>
             </a:extLst>
           </p:cNvPr>
@@ -9685,7 +9685,7 @@
     </p:spTree>
     <p:extLst>
       <p:ext uri="{BB962C8B-B14F-4D97-AF65-F5344CB8AC3E}">
-        <p14:creationId xmlns:p14="http://schemas.microsoft.com/office/powerpoint/2010/main" val="798071238"/>
+        <p14:creationId xmlns:p14="http://schemas.microsoft.com/office/powerpoint/2010/main" val="511965153"/>
       </p:ext>
     </p:extLst>
   </p:cSld>
@@ -9716,7 +9716,7 @@
           <p:cNvPr id="12" name="">
             <a:extLst xmlns:a="http://schemas.openxmlformats.org/drawingml/2006/main">
               <a:ext uri="{FF2B5EF4-FFF2-40B4-BE49-F238E27FC236}">
-                <a16:creationId xmlns:a16="http://schemas.microsoft.com/office/drawing/2014/main" id="{BF3BF19C-5CFF-4007-AB17-A2AD65135C33}"/>
+                <a16:creationId xmlns:a16="http://schemas.microsoft.com/office/drawing/2014/main" id="{18039B61-7C55-4FDB-9199-BA55DDB2C972}"/>
               </a:ext>
             </a:extLst>
           </p:cNvPr>
@@ -9773,7 +9773,7 @@
           <p:cNvPr id="2" name="">
             <a:extLst xmlns:a="http://schemas.openxmlformats.org/drawingml/2006/main">
               <a:ext uri="{FF2B5EF4-FFF2-40B4-BE49-F238E27FC236}">
-                <a16:creationId xmlns:a16="http://schemas.microsoft.com/office/drawing/2014/main" id="{5AF342FF-7607-4FCF-AB7D-0C242A0E7E72}"/>
+                <a16:creationId xmlns:a16="http://schemas.microsoft.com/office/drawing/2014/main" id="{FFC6116F-A676-4615-8709-55F764F7D8AA}"/>
               </a:ext>
             </a:extLst>
           </p:cNvPr>
@@ -9830,7 +9830,7 @@
           <p:cNvPr id="3" name="">
             <a:extLst xmlns:a="http://schemas.openxmlformats.org/drawingml/2006/main">
               <a:ext uri="{FF2B5EF4-FFF2-40B4-BE49-F238E27FC236}">
-                <a16:creationId xmlns:a16="http://schemas.microsoft.com/office/drawing/2014/main" id="{5460BFED-E28C-4AB0-A396-2B695DEF9C57}"/>
+                <a16:creationId xmlns:a16="http://schemas.microsoft.com/office/drawing/2014/main" id="{36BB6508-54D5-427D-9D5C-D1524CA7FDF6}"/>
               </a:ext>
             </a:extLst>
           </p:cNvPr>
@@ -9891,7 +9891,7 @@
           <p:nvPr/>
         </p:nvPicPr>
         <p:blipFill>
-          <a:blip xmlns:r="http://schemas.openxmlformats.org/officeDocument/2006/relationships" xmlns:a="http://schemas.openxmlformats.org/drawingml/2006/main" r:embed="R643909c0744d40f9"/>
+          <a:blip xmlns:r="http://schemas.openxmlformats.org/officeDocument/2006/relationships" xmlns:a="http://schemas.openxmlformats.org/drawingml/2006/main" r:embed="R62dd8ae1cee946c1"/>
           <a:stretch xmlns:a="http://schemas.openxmlformats.org/drawingml/2006/main"/>
         </p:blipFill>
         <p:spPr>
@@ -9909,7 +9909,7 @@
           <p:cNvPr id="5" name="">
             <a:extLst xmlns:a="http://schemas.openxmlformats.org/drawingml/2006/main">
               <a:ext uri="{FF2B5EF4-FFF2-40B4-BE49-F238E27FC236}">
-                <a16:creationId xmlns:a16="http://schemas.microsoft.com/office/drawing/2014/main" id="{E308BE80-05D8-417F-9843-EFC89F07759C}"/>
+                <a16:creationId xmlns:a16="http://schemas.microsoft.com/office/drawing/2014/main" id="{A02BB03A-D599-4898-8855-3AE562E9E848}"/>
               </a:ext>
             </a:extLst>
           </p:cNvPr>
@@ -9966,7 +9966,7 @@
           <p:cNvPr id="6" name="">
             <a:extLst xmlns:a="http://schemas.openxmlformats.org/drawingml/2006/main">
               <a:ext uri="{FF2B5EF4-FFF2-40B4-BE49-F238E27FC236}">
-                <a16:creationId xmlns:a16="http://schemas.microsoft.com/office/drawing/2014/main" id="{DA082912-E7E2-40A0-842D-28DC662860C5}"/>
+                <a16:creationId xmlns:a16="http://schemas.microsoft.com/office/drawing/2014/main" id="{78BE772D-2922-4923-8B45-B02EBEC2EC56}"/>
               </a:ext>
             </a:extLst>
           </p:cNvPr>
@@ -10023,7 +10023,7 @@
           <p:cNvPr id="7" name="">
             <a:extLst xmlns:a="http://schemas.openxmlformats.org/drawingml/2006/main">
               <a:ext uri="{FF2B5EF4-FFF2-40B4-BE49-F238E27FC236}">
-                <a16:creationId xmlns:a16="http://schemas.microsoft.com/office/drawing/2014/main" id="{D8E4DA41-F43F-44B3-886B-1A6DF1872C8B}"/>
+                <a16:creationId xmlns:a16="http://schemas.microsoft.com/office/drawing/2014/main" id="{7A05B768-1447-4D07-920A-D883D462DDE0}"/>
               </a:ext>
             </a:extLst>
           </p:cNvPr>
@@ -10080,7 +10080,7 @@
           <p:cNvPr id="8" name="">
             <a:extLst xmlns:a="http://schemas.openxmlformats.org/drawingml/2006/main">
               <a:ext uri="{FF2B5EF4-FFF2-40B4-BE49-F238E27FC236}">
-                <a16:creationId xmlns:a16="http://schemas.microsoft.com/office/drawing/2014/main" id="{46580D92-CE0E-4A49-ADB4-32857C5F441B}"/>
+                <a16:creationId xmlns:a16="http://schemas.microsoft.com/office/drawing/2014/main" id="{46614A2F-0C88-4D5F-8D84-D4A799A6ED46}"/>
               </a:ext>
             </a:extLst>
           </p:cNvPr>
@@ -10137,7 +10137,7 @@
           <p:cNvPr id="9" name="">
             <a:extLst xmlns:a="http://schemas.openxmlformats.org/drawingml/2006/main">
               <a:ext uri="{FF2B5EF4-FFF2-40B4-BE49-F238E27FC236}">
-                <a16:creationId xmlns:a16="http://schemas.microsoft.com/office/drawing/2014/main" id="{717B9B03-24AE-44A2-AE93-934D522350C6}"/>
+                <a16:creationId xmlns:a16="http://schemas.microsoft.com/office/drawing/2014/main" id="{26506757-D694-4ABA-B3F9-DDEA00AB9BB1}"/>
               </a:ext>
             </a:extLst>
           </p:cNvPr>
@@ -10167,7 +10167,7 @@
           <p:cNvPr id="10" name="">
             <a:extLst xmlns:a="http://schemas.openxmlformats.org/drawingml/2006/main">
               <a:ext uri="{FF2B5EF4-FFF2-40B4-BE49-F238E27FC236}">
-                <a16:creationId xmlns:a16="http://schemas.microsoft.com/office/drawing/2014/main" id="{BA8FEA7D-DC24-423B-828A-2D552D620420}"/>
+                <a16:creationId xmlns:a16="http://schemas.microsoft.com/office/drawing/2014/main" id="{ABACDDAE-F6FA-4B51-97DF-691B938AAC80}"/>
               </a:ext>
             </a:extLst>
           </p:cNvPr>
@@ -10224,7 +10224,7 @@
           <p:cNvPr id="11" name="">
             <a:extLst xmlns:a="http://schemas.openxmlformats.org/drawingml/2006/main">
               <a:ext uri="{FF2B5EF4-FFF2-40B4-BE49-F238E27FC236}">
-                <a16:creationId xmlns:a16="http://schemas.microsoft.com/office/drawing/2014/main" id="{CF83D11C-4FDF-404E-AA01-1FC21F501930}"/>
+                <a16:creationId xmlns:a16="http://schemas.microsoft.com/office/drawing/2014/main" id="{3D20DFC5-39FA-46C6-B386-83C7182E2C77}"/>
               </a:ext>
             </a:extLst>
           </p:cNvPr>
@@ -10279,7 +10279,7 @@
     </p:spTree>
     <p:extLst>
       <p:ext uri="{BB962C8B-B14F-4D97-AF65-F5344CB8AC3E}">
-        <p14:creationId xmlns:p14="http://schemas.microsoft.com/office/powerpoint/2010/main" val="1584124394"/>
+        <p14:creationId xmlns:p14="http://schemas.microsoft.com/office/powerpoint/2010/main" val="170835466"/>
       </p:ext>
     </p:extLst>
   </p:cSld>
@@ -10310,7 +10310,7 @@
           <p:cNvPr id="19" name="">
             <a:extLst xmlns:a="http://schemas.openxmlformats.org/drawingml/2006/main">
               <a:ext uri="{FF2B5EF4-FFF2-40B4-BE49-F238E27FC236}">
-                <a16:creationId xmlns:a16="http://schemas.microsoft.com/office/drawing/2014/main" id="{B5DE22B8-5B59-46F6-ADDF-FF39E659C6E5}"/>
+                <a16:creationId xmlns:a16="http://schemas.microsoft.com/office/drawing/2014/main" id="{BEA70FD2-D671-4AD2-A963-3978CB457612}"/>
               </a:ext>
             </a:extLst>
           </p:cNvPr>
@@ -10367,7 +10367,7 @@
           <p:cNvPr id="2" name="">
             <a:extLst xmlns:a="http://schemas.openxmlformats.org/drawingml/2006/main">
               <a:ext uri="{FF2B5EF4-FFF2-40B4-BE49-F238E27FC236}">
-                <a16:creationId xmlns:a16="http://schemas.microsoft.com/office/drawing/2014/main" id="{9BF65C7A-8975-438C-8ED5-165FA2DB1BDF}"/>
+                <a16:creationId xmlns:a16="http://schemas.microsoft.com/office/drawing/2014/main" id="{53A18906-A85D-409A-8B91-01D01310552E}"/>
               </a:ext>
             </a:extLst>
           </p:cNvPr>
@@ -10424,7 +10424,7 @@
           <p:cNvPr id="3" name="">
             <a:extLst xmlns:a="http://schemas.openxmlformats.org/drawingml/2006/main">
               <a:ext uri="{FF2B5EF4-FFF2-40B4-BE49-F238E27FC236}">
-                <a16:creationId xmlns:a16="http://schemas.microsoft.com/office/drawing/2014/main" id="{A981E7EC-C8C2-4F4D-BD23-2C4B9E15F85C}"/>
+                <a16:creationId xmlns:a16="http://schemas.microsoft.com/office/drawing/2014/main" id="{45BB6B0E-CDC6-496E-9835-6885D5AED913}"/>
               </a:ext>
             </a:extLst>
           </p:cNvPr>
@@ -10481,7 +10481,7 @@
           <p:cNvPr id="4" name="">
             <a:extLst xmlns:a="http://schemas.openxmlformats.org/drawingml/2006/main">
               <a:ext uri="{FF2B5EF4-FFF2-40B4-BE49-F238E27FC236}">
-                <a16:creationId xmlns:a16="http://schemas.microsoft.com/office/drawing/2014/main" id="{80243741-FA4C-4F40-999F-9533A3D0BA34}"/>
+                <a16:creationId xmlns:a16="http://schemas.microsoft.com/office/drawing/2014/main" id="{4BEB09AF-0132-413D-895F-E247D4E981C2}"/>
               </a:ext>
             </a:extLst>
           </p:cNvPr>
@@ -10511,7 +10511,7 @@
           <p:cNvPr id="5" name="">
             <a:extLst xmlns:a="http://schemas.openxmlformats.org/drawingml/2006/main">
               <a:ext uri="{FF2B5EF4-FFF2-40B4-BE49-F238E27FC236}">
-                <a16:creationId xmlns:a16="http://schemas.microsoft.com/office/drawing/2014/main" id="{3A42248F-EA13-4D2D-8E03-A56F0A0CC64A}"/>
+                <a16:creationId xmlns:a16="http://schemas.microsoft.com/office/drawing/2014/main" id="{B2B0BB7C-21D8-45D8-A706-3BA7ED893575}"/>
               </a:ext>
             </a:extLst>
           </p:cNvPr>
@@ -10568,7 +10568,7 @@
           <p:cNvPr id="6" name="">
             <a:extLst xmlns:a="http://schemas.openxmlformats.org/drawingml/2006/main">
               <a:ext uri="{FF2B5EF4-FFF2-40B4-BE49-F238E27FC236}">
-                <a16:creationId xmlns:a16="http://schemas.microsoft.com/office/drawing/2014/main" id="{DAB8882B-F711-42AC-A1F9-856FE31BC77C}"/>
+                <a16:creationId xmlns:a16="http://schemas.microsoft.com/office/drawing/2014/main" id="{863501CB-30AC-4720-AF5E-403EA3C06FA5}"/>
               </a:ext>
             </a:extLst>
           </p:cNvPr>
@@ -10598,7 +10598,7 @@
           <p:cNvPr id="7" name="">
             <a:extLst xmlns:a="http://schemas.openxmlformats.org/drawingml/2006/main">
               <a:ext uri="{FF2B5EF4-FFF2-40B4-BE49-F238E27FC236}">
-                <a16:creationId xmlns:a16="http://schemas.microsoft.com/office/drawing/2014/main" id="{DE3E1C11-E583-4174-8189-067AC57C0E4F}"/>
+                <a16:creationId xmlns:a16="http://schemas.microsoft.com/office/drawing/2014/main" id="{AF83CCE6-AA06-4D64-9EAE-4FADF54B415D}"/>
               </a:ext>
             </a:extLst>
           </p:cNvPr>
@@ -10655,7 +10655,7 @@
           <p:cNvPr id="8" name="">
             <a:extLst xmlns:a="http://schemas.openxmlformats.org/drawingml/2006/main">
               <a:ext uri="{FF2B5EF4-FFF2-40B4-BE49-F238E27FC236}">
-                <a16:creationId xmlns:a16="http://schemas.microsoft.com/office/drawing/2014/main" id="{E459B21E-015D-4573-AF45-25BD0EA6396A}"/>
+                <a16:creationId xmlns:a16="http://schemas.microsoft.com/office/drawing/2014/main" id="{F9E8080B-789F-4699-85DD-163AB90C2279}"/>
               </a:ext>
             </a:extLst>
           </p:cNvPr>
@@ -10685,7 +10685,7 @@
           <p:cNvPr id="9" name="">
             <a:extLst xmlns:a="http://schemas.openxmlformats.org/drawingml/2006/main">
               <a:ext uri="{FF2B5EF4-FFF2-40B4-BE49-F238E27FC236}">
-                <a16:creationId xmlns:a16="http://schemas.microsoft.com/office/drawing/2014/main" id="{DF886AAC-81BB-4291-BB7C-2D9D7DF75237}"/>
+                <a16:creationId xmlns:a16="http://schemas.microsoft.com/office/drawing/2014/main" id="{68F3511C-4872-456D-8436-32C5B8D36110}"/>
               </a:ext>
             </a:extLst>
           </p:cNvPr>
@@ -10742,7 +10742,7 @@
           <p:cNvPr id="10" name="">
             <a:extLst xmlns:a="http://schemas.openxmlformats.org/drawingml/2006/main">
               <a:ext uri="{FF2B5EF4-FFF2-40B4-BE49-F238E27FC236}">
-                <a16:creationId xmlns:a16="http://schemas.microsoft.com/office/drawing/2014/main" id="{92BF92DC-820E-4D85-ADB8-22C926AAF25F}"/>
+                <a16:creationId xmlns:a16="http://schemas.microsoft.com/office/drawing/2014/main" id="{2D5E16B2-C5F2-4BF1-ADA8-D5605C6D2577}"/>
               </a:ext>
             </a:extLst>
           </p:cNvPr>
@@ -10772,7 +10772,7 @@
           <p:cNvPr id="11" name="">
             <a:extLst xmlns:a="http://schemas.openxmlformats.org/drawingml/2006/main">
               <a:ext uri="{FF2B5EF4-FFF2-40B4-BE49-F238E27FC236}">
-                <a16:creationId xmlns:a16="http://schemas.microsoft.com/office/drawing/2014/main" id="{43D23D54-CF24-442E-8255-0391E86D185E}"/>
+                <a16:creationId xmlns:a16="http://schemas.microsoft.com/office/drawing/2014/main" id="{34A2AD85-FE1F-4B22-A7C5-D928A82F6108}"/>
               </a:ext>
             </a:extLst>
           </p:cNvPr>
@@ -10829,7 +10829,7 @@
           <p:cNvPr id="12" name="">
             <a:extLst xmlns:a="http://schemas.openxmlformats.org/drawingml/2006/main">
               <a:ext uri="{FF2B5EF4-FFF2-40B4-BE49-F238E27FC236}">
-                <a16:creationId xmlns:a16="http://schemas.microsoft.com/office/drawing/2014/main" id="{4244B959-DF45-4ABC-BD5F-5F09327519FE}"/>
+                <a16:creationId xmlns:a16="http://schemas.microsoft.com/office/drawing/2014/main" id="{40CBE0B8-5828-48FF-8C51-80FB40BF37A9}"/>
               </a:ext>
             </a:extLst>
           </p:cNvPr>
@@ -10886,7 +10886,7 @@
           <p:cNvPr id="13" name="">
             <a:extLst xmlns:a="http://schemas.openxmlformats.org/drawingml/2006/main">
               <a:ext uri="{FF2B5EF4-FFF2-40B4-BE49-F238E27FC236}">
-                <a16:creationId xmlns:a16="http://schemas.microsoft.com/office/drawing/2014/main" id="{1CC1E020-3816-4EDC-95E7-3C3301D4844B}"/>
+                <a16:creationId xmlns:a16="http://schemas.microsoft.com/office/drawing/2014/main" id="{4663CE83-28D8-4CB1-8B53-DA49FC8089FB}"/>
               </a:ext>
             </a:extLst>
           </p:cNvPr>
@@ -10943,7 +10943,7 @@
           <p:cNvPr id="14" name="">
             <a:extLst xmlns:a="http://schemas.openxmlformats.org/drawingml/2006/main">
               <a:ext uri="{FF2B5EF4-FFF2-40B4-BE49-F238E27FC236}">
-                <a16:creationId xmlns:a16="http://schemas.microsoft.com/office/drawing/2014/main" id="{0009E5C2-FCF6-451C-9273-4BA52D7DF31C}"/>
+                <a16:creationId xmlns:a16="http://schemas.microsoft.com/office/drawing/2014/main" id="{EEB4AD6A-7B6A-41DE-9287-08D3196BB463}"/>
               </a:ext>
             </a:extLst>
           </p:cNvPr>
@@ -11000,7 +11000,7 @@
           <p:cNvPr id="15" name="">
             <a:extLst xmlns:a="http://schemas.openxmlformats.org/drawingml/2006/main">
               <a:ext uri="{FF2B5EF4-FFF2-40B4-BE49-F238E27FC236}">
-                <a16:creationId xmlns:a16="http://schemas.microsoft.com/office/drawing/2014/main" id="{67EA2433-CA78-4998-994A-2614668AB833}"/>
+                <a16:creationId xmlns:a16="http://schemas.microsoft.com/office/drawing/2014/main" id="{24B94373-C79D-4D21-9FEE-2D0CD416277B}"/>
               </a:ext>
             </a:extLst>
           </p:cNvPr>
@@ -11057,7 +11057,7 @@
           <p:cNvPr id="16" name="">
             <a:extLst xmlns:a="http://schemas.openxmlformats.org/drawingml/2006/main">
               <a:ext uri="{FF2B5EF4-FFF2-40B4-BE49-F238E27FC236}">
-                <a16:creationId xmlns:a16="http://schemas.microsoft.com/office/drawing/2014/main" id="{CAA4929E-912C-4066-8411-23DD312B27DB}"/>
+                <a16:creationId xmlns:a16="http://schemas.microsoft.com/office/drawing/2014/main" id="{2682BD17-65B1-4B6E-800E-4C78D51A1906}"/>
               </a:ext>
             </a:extLst>
           </p:cNvPr>
@@ -11087,7 +11087,7 @@
           <p:cNvPr id="17" name="">
             <a:extLst xmlns:a="http://schemas.openxmlformats.org/drawingml/2006/main">
               <a:ext uri="{FF2B5EF4-FFF2-40B4-BE49-F238E27FC236}">
-                <a16:creationId xmlns:a16="http://schemas.microsoft.com/office/drawing/2014/main" id="{0BA175AD-043A-4253-9DBE-A5AA71105895}"/>
+                <a16:creationId xmlns:a16="http://schemas.microsoft.com/office/drawing/2014/main" id="{BEB22C83-F967-4F90-8163-387394C87934}"/>
               </a:ext>
             </a:extLst>
           </p:cNvPr>
@@ -11144,7 +11144,7 @@
           <p:cNvPr id="18" name="">
             <a:extLst xmlns:a="http://schemas.openxmlformats.org/drawingml/2006/main">
               <a:ext uri="{FF2B5EF4-FFF2-40B4-BE49-F238E27FC236}">
-                <a16:creationId xmlns:a16="http://schemas.microsoft.com/office/drawing/2014/main" id="{E1BF8AD9-3037-4D00-B1B8-11A4E3C7DDE3}"/>
+                <a16:creationId xmlns:a16="http://schemas.microsoft.com/office/drawing/2014/main" id="{AE24580C-D531-41A9-9BD3-292329EBE539}"/>
               </a:ext>
             </a:extLst>
           </p:cNvPr>
@@ -11199,7 +11199,7 @@
     </p:spTree>
     <p:extLst>
       <p:ext uri="{BB962C8B-B14F-4D97-AF65-F5344CB8AC3E}">
-        <p14:creationId xmlns:p14="http://schemas.microsoft.com/office/powerpoint/2010/main" val="1733874778"/>
+        <p14:creationId xmlns:p14="http://schemas.microsoft.com/office/powerpoint/2010/main" val="234563898"/>
       </p:ext>
     </p:extLst>
   </p:cSld>
@@ -11230,7 +11230,7 @@
           <p:cNvPr id="17" name="">
             <a:extLst xmlns:a="http://schemas.openxmlformats.org/drawingml/2006/main">
               <a:ext uri="{FF2B5EF4-FFF2-40B4-BE49-F238E27FC236}">
-                <a16:creationId xmlns:a16="http://schemas.microsoft.com/office/drawing/2014/main" id="{52CFAA3F-00CE-4F5E-94F3-B60A6D40C47C}"/>
+                <a16:creationId xmlns:a16="http://schemas.microsoft.com/office/drawing/2014/main" id="{1CE0054C-ED32-402A-9E32-97FD95B3A831}"/>
               </a:ext>
             </a:extLst>
           </p:cNvPr>
@@ -11287,7 +11287,7 @@
           <p:cNvPr id="2" name="">
             <a:extLst xmlns:a="http://schemas.openxmlformats.org/drawingml/2006/main">
               <a:ext uri="{FF2B5EF4-FFF2-40B4-BE49-F238E27FC236}">
-                <a16:creationId xmlns:a16="http://schemas.microsoft.com/office/drawing/2014/main" id="{6C5E8A44-0C65-4EFA-B704-A18676E3E12A}"/>
+                <a16:creationId xmlns:a16="http://schemas.microsoft.com/office/drawing/2014/main" id="{208BD9F2-E687-402F-9AB7-156206985A2B}"/>
               </a:ext>
             </a:extLst>
           </p:cNvPr>
@@ -11344,7 +11344,7 @@
           <p:cNvPr id="3" name="">
             <a:extLst xmlns:a="http://schemas.openxmlformats.org/drawingml/2006/main">
               <a:ext uri="{FF2B5EF4-FFF2-40B4-BE49-F238E27FC236}">
-                <a16:creationId xmlns:a16="http://schemas.microsoft.com/office/drawing/2014/main" id="{4E0E8147-8C13-4305-9E8A-E63041A3BD1A}"/>
+                <a16:creationId xmlns:a16="http://schemas.microsoft.com/office/drawing/2014/main" id="{E7F4AAC7-1323-432A-B77D-59E61CB69D16}"/>
               </a:ext>
             </a:extLst>
           </p:cNvPr>
@@ -11401,7 +11401,7 @@
           <p:cNvPr id="4" name="">
             <a:extLst xmlns:a="http://schemas.openxmlformats.org/drawingml/2006/main">
               <a:ext uri="{FF2B5EF4-FFF2-40B4-BE49-F238E27FC236}">
-                <a16:creationId xmlns:a16="http://schemas.microsoft.com/office/drawing/2014/main" id="{A2F73F09-31ED-4DF4-BF4E-2DA972FA7775}"/>
+                <a16:creationId xmlns:a16="http://schemas.microsoft.com/office/drawing/2014/main" id="{341FBD09-8B1B-4D6B-9582-7EF165F2E66E}"/>
               </a:ext>
             </a:extLst>
           </p:cNvPr>
@@ -11431,7 +11431,7 @@
           <p:cNvPr id="5" name="">
             <a:extLst xmlns:a="http://schemas.openxmlformats.org/drawingml/2006/main">
               <a:ext uri="{FF2B5EF4-FFF2-40B4-BE49-F238E27FC236}">
-                <a16:creationId xmlns:a16="http://schemas.microsoft.com/office/drawing/2014/main" id="{537FEB2D-6E63-44B9-B4D3-9CB693E69AF2}"/>
+                <a16:creationId xmlns:a16="http://schemas.microsoft.com/office/drawing/2014/main" id="{533B813C-D8D7-433E-8F83-A4BCA872C440}"/>
               </a:ext>
             </a:extLst>
           </p:cNvPr>
@@ -11488,7 +11488,7 @@
           <p:cNvPr id="6" name="">
             <a:extLst xmlns:a="http://schemas.openxmlformats.org/drawingml/2006/main">
               <a:ext uri="{FF2B5EF4-FFF2-40B4-BE49-F238E27FC236}">
-                <a16:creationId xmlns:a16="http://schemas.microsoft.com/office/drawing/2014/main" id="{A9502C63-AB1B-4948-9B81-EF65AA3BE552}"/>
+                <a16:creationId xmlns:a16="http://schemas.microsoft.com/office/drawing/2014/main" id="{ED4F2B4A-2856-45EC-A357-48E070C1BBF3}"/>
               </a:ext>
             </a:extLst>
           </p:cNvPr>
@@ -11518,7 +11518,7 @@
           <p:cNvPr id="7" name="">
             <a:extLst xmlns:a="http://schemas.openxmlformats.org/drawingml/2006/main">
               <a:ext uri="{FF2B5EF4-FFF2-40B4-BE49-F238E27FC236}">
-                <a16:creationId xmlns:a16="http://schemas.microsoft.com/office/drawing/2014/main" id="{B6364E29-E3D8-461A-8CD3-BBF9B02F572F}"/>
+                <a16:creationId xmlns:a16="http://schemas.microsoft.com/office/drawing/2014/main" id="{EB1CCE65-3EC1-4C98-8C51-58D843DFF479}"/>
               </a:ext>
             </a:extLst>
           </p:cNvPr>
@@ -11575,7 +11575,7 @@
           <p:cNvPr id="8" name="">
             <a:extLst xmlns:a="http://schemas.openxmlformats.org/drawingml/2006/main">
               <a:ext uri="{FF2B5EF4-FFF2-40B4-BE49-F238E27FC236}">
-                <a16:creationId xmlns:a16="http://schemas.microsoft.com/office/drawing/2014/main" id="{7116281C-902B-41AC-B863-0AF3E87BBE1A}"/>
+                <a16:creationId xmlns:a16="http://schemas.microsoft.com/office/drawing/2014/main" id="{53DE073C-2872-4872-8EBD-CB5D1073F6C8}"/>
               </a:ext>
             </a:extLst>
           </p:cNvPr>
@@ -11605,7 +11605,7 @@
           <p:cNvPr id="9" name="">
             <a:extLst xmlns:a="http://schemas.openxmlformats.org/drawingml/2006/main">
               <a:ext uri="{FF2B5EF4-FFF2-40B4-BE49-F238E27FC236}">
-                <a16:creationId xmlns:a16="http://schemas.microsoft.com/office/drawing/2014/main" id="{8E5F151B-5413-4BF5-BF89-88817A9B1CF6}"/>
+                <a16:creationId xmlns:a16="http://schemas.microsoft.com/office/drawing/2014/main" id="{D7A2D7B4-D2AB-446D-B480-CDB8B2A49B71}"/>
               </a:ext>
             </a:extLst>
           </p:cNvPr>
@@ -11662,7 +11662,7 @@
           <p:cNvPr id="10" name="">
             <a:extLst xmlns:a="http://schemas.openxmlformats.org/drawingml/2006/main">
               <a:ext uri="{FF2B5EF4-FFF2-40B4-BE49-F238E27FC236}">
-                <a16:creationId xmlns:a16="http://schemas.microsoft.com/office/drawing/2014/main" id="{3F2A7002-426B-4B66-88F4-91B00AB6B993}"/>
+                <a16:creationId xmlns:a16="http://schemas.microsoft.com/office/drawing/2014/main" id="{FD03AED6-3C0D-4FDC-BAFD-EBE21C214717}"/>
               </a:ext>
             </a:extLst>
           </p:cNvPr>
@@ -11719,7 +11719,7 @@
           <p:cNvPr id="11" name="">
             <a:extLst xmlns:a="http://schemas.openxmlformats.org/drawingml/2006/main">
               <a:ext uri="{FF2B5EF4-FFF2-40B4-BE49-F238E27FC236}">
-                <a16:creationId xmlns:a16="http://schemas.microsoft.com/office/drawing/2014/main" id="{178160D2-EB26-4DE3-B9AB-0967AC4E2D99}"/>
+                <a16:creationId xmlns:a16="http://schemas.microsoft.com/office/drawing/2014/main" id="{C1F199E7-A744-4175-80E1-55D40324782B}"/>
               </a:ext>
             </a:extLst>
           </p:cNvPr>
@@ -11776,7 +11776,7 @@
           <p:cNvPr id="12" name="">
             <a:extLst xmlns:a="http://schemas.openxmlformats.org/drawingml/2006/main">
               <a:ext uri="{FF2B5EF4-FFF2-40B4-BE49-F238E27FC236}">
-                <a16:creationId xmlns:a16="http://schemas.microsoft.com/office/drawing/2014/main" id="{2A56E391-A672-400E-A2AC-BFB23F75BB3A}"/>
+                <a16:creationId xmlns:a16="http://schemas.microsoft.com/office/drawing/2014/main" id="{0B4E7C5C-E826-494B-940F-77CC7B80548F}"/>
               </a:ext>
             </a:extLst>
           </p:cNvPr>
@@ -11833,7 +11833,7 @@
           <p:cNvPr id="13" name="">
             <a:extLst xmlns:a="http://schemas.openxmlformats.org/drawingml/2006/main">
               <a:ext uri="{FF2B5EF4-FFF2-40B4-BE49-F238E27FC236}">
-                <a16:creationId xmlns:a16="http://schemas.microsoft.com/office/drawing/2014/main" id="{858DCC19-1E7C-473F-8BF1-81408E1EF47D}"/>
+                <a16:creationId xmlns:a16="http://schemas.microsoft.com/office/drawing/2014/main" id="{C5A29171-F776-45C7-B6EB-2CB6C316F514}"/>
               </a:ext>
             </a:extLst>
           </p:cNvPr>
@@ -11890,7 +11890,7 @@
           <p:cNvPr id="14" name="">
             <a:extLst xmlns:a="http://schemas.openxmlformats.org/drawingml/2006/main">
               <a:ext uri="{FF2B5EF4-FFF2-40B4-BE49-F238E27FC236}">
-                <a16:creationId xmlns:a16="http://schemas.microsoft.com/office/drawing/2014/main" id="{0AB07839-6D85-420A-828B-9C42701A702C}"/>
+                <a16:creationId xmlns:a16="http://schemas.microsoft.com/office/drawing/2014/main" id="{F5E94815-425B-4AFD-8278-FFB586F2B098}"/>
               </a:ext>
             </a:extLst>
           </p:cNvPr>
@@ -11920,7 +11920,7 @@
           <p:cNvPr id="15" name="">
             <a:extLst xmlns:a="http://schemas.openxmlformats.org/drawingml/2006/main">
               <a:ext uri="{FF2B5EF4-FFF2-40B4-BE49-F238E27FC236}">
-                <a16:creationId xmlns:a16="http://schemas.microsoft.com/office/drawing/2014/main" id="{87265603-D18E-4C93-BB36-0908E2E47072}"/>
+                <a16:creationId xmlns:a16="http://schemas.microsoft.com/office/drawing/2014/main" id="{C0D5E29B-029C-4EF5-8D78-E16270E93EED}"/>
               </a:ext>
             </a:extLst>
           </p:cNvPr>
@@ -11977,7 +11977,7 @@
           <p:cNvPr id="16" name="">
             <a:extLst xmlns:a="http://schemas.openxmlformats.org/drawingml/2006/main">
               <a:ext uri="{FF2B5EF4-FFF2-40B4-BE49-F238E27FC236}">
-                <a16:creationId xmlns:a16="http://schemas.microsoft.com/office/drawing/2014/main" id="{FEAAEFA3-61B9-42D7-8143-7885A2E6C5D7}"/>
+                <a16:creationId xmlns:a16="http://schemas.microsoft.com/office/drawing/2014/main" id="{FE7BAEC7-CAEC-4E75-84F2-45728497D775}"/>
               </a:ext>
             </a:extLst>
           </p:cNvPr>
@@ -12032,7 +12032,7 @@
     </p:spTree>
     <p:extLst>
       <p:ext uri="{BB962C8B-B14F-4D97-AF65-F5344CB8AC3E}">
-        <p14:creationId xmlns:p14="http://schemas.microsoft.com/office/powerpoint/2010/main" val="1436280024"/>
+        <p14:creationId xmlns:p14="http://schemas.microsoft.com/office/powerpoint/2010/main" val="1852698322"/>
       </p:ext>
     </p:extLst>
   </p:cSld>
@@ -12063,7 +12063,7 @@
           <p:cNvPr id="12" name="">
             <a:extLst xmlns:a="http://schemas.openxmlformats.org/drawingml/2006/main">
               <a:ext uri="{FF2B5EF4-FFF2-40B4-BE49-F238E27FC236}">
-                <a16:creationId xmlns:a16="http://schemas.microsoft.com/office/drawing/2014/main" id="{96DAAFE0-9F01-4887-814A-CFCD583BCCC9}"/>
+                <a16:creationId xmlns:a16="http://schemas.microsoft.com/office/drawing/2014/main" id="{731BA5A6-0BDA-40CA-A3E1-3C4807CFC214}"/>
               </a:ext>
             </a:extLst>
           </p:cNvPr>
@@ -12120,7 +12120,7 @@
           <p:cNvPr id="2" name="">
             <a:extLst xmlns:a="http://schemas.openxmlformats.org/drawingml/2006/main">
               <a:ext uri="{FF2B5EF4-FFF2-40B4-BE49-F238E27FC236}">
-                <a16:creationId xmlns:a16="http://schemas.microsoft.com/office/drawing/2014/main" id="{2D6E7D7B-535F-4814-999A-DCE0BD770F67}"/>
+                <a16:creationId xmlns:a16="http://schemas.microsoft.com/office/drawing/2014/main" id="{C57404FD-2369-46EF-B596-2739EE747A6B}"/>
               </a:ext>
             </a:extLst>
           </p:cNvPr>
@@ -12177,7 +12177,7 @@
           <p:cNvPr id="3" name="">
             <a:extLst xmlns:a="http://schemas.openxmlformats.org/drawingml/2006/main">
               <a:ext uri="{FF2B5EF4-FFF2-40B4-BE49-F238E27FC236}">
-                <a16:creationId xmlns:a16="http://schemas.microsoft.com/office/drawing/2014/main" id="{77BBE7CA-F732-4E51-AD22-732342144C4E}"/>
+                <a16:creationId xmlns:a16="http://schemas.microsoft.com/office/drawing/2014/main" id="{54827377-80BB-4CCB-BB2D-3EE744351398}"/>
               </a:ext>
             </a:extLst>
           </p:cNvPr>
@@ -12238,7 +12238,7 @@
           <p:nvPr/>
         </p:nvPicPr>
         <p:blipFill>
-          <a:blip xmlns:r="http://schemas.openxmlformats.org/officeDocument/2006/relationships" xmlns:a="http://schemas.openxmlformats.org/drawingml/2006/main" r:embed="Rbda1353128d64f5b"/>
+          <a:blip xmlns:r="http://schemas.openxmlformats.org/officeDocument/2006/relationships" xmlns:a="http://schemas.openxmlformats.org/drawingml/2006/main" r:embed="R8348a61c6cac4e6c"/>
           <a:stretch xmlns:a="http://schemas.openxmlformats.org/drawingml/2006/main"/>
         </p:blipFill>
         <p:spPr>
@@ -12256,7 +12256,7 @@
           <p:cNvPr id="5" name="">
             <a:extLst xmlns:a="http://schemas.openxmlformats.org/drawingml/2006/main">
               <a:ext uri="{FF2B5EF4-FFF2-40B4-BE49-F238E27FC236}">
-                <a16:creationId xmlns:a16="http://schemas.microsoft.com/office/drawing/2014/main" id="{524599DB-3274-4696-B2E0-A66ABCABA470}"/>
+                <a16:creationId xmlns:a16="http://schemas.microsoft.com/office/drawing/2014/main" id="{BBE5DE38-E18D-4BB8-9BA6-DF495E7BACA7}"/>
               </a:ext>
             </a:extLst>
           </p:cNvPr>
@@ -12313,7 +12313,7 @@
           <p:cNvPr id="6" name="">
             <a:extLst xmlns:a="http://schemas.openxmlformats.org/drawingml/2006/main">
               <a:ext uri="{FF2B5EF4-FFF2-40B4-BE49-F238E27FC236}">
-                <a16:creationId xmlns:a16="http://schemas.microsoft.com/office/drawing/2014/main" id="{0191BEE7-F351-49D0-87F8-0E8C2B18B63C}"/>
+                <a16:creationId xmlns:a16="http://schemas.microsoft.com/office/drawing/2014/main" id="{839D9563-1AE4-44C8-9E47-2D9A42404ECC}"/>
               </a:ext>
             </a:extLst>
           </p:cNvPr>
@@ -12370,7 +12370,7 @@
           <p:cNvPr id="7" name="">
             <a:extLst xmlns:a="http://schemas.openxmlformats.org/drawingml/2006/main">
               <a:ext uri="{FF2B5EF4-FFF2-40B4-BE49-F238E27FC236}">
-                <a16:creationId xmlns:a16="http://schemas.microsoft.com/office/drawing/2014/main" id="{B4A225EA-DB05-419A-A8FD-D0DE636C3191}"/>
+                <a16:creationId xmlns:a16="http://schemas.microsoft.com/office/drawing/2014/main" id="{88943F44-757B-4FF9-8631-B8B6F2A6A801}"/>
               </a:ext>
             </a:extLst>
           </p:cNvPr>
@@ -12427,7 +12427,7 @@
           <p:cNvPr id="8" name="">
             <a:extLst xmlns:a="http://schemas.openxmlformats.org/drawingml/2006/main">
               <a:ext uri="{FF2B5EF4-FFF2-40B4-BE49-F238E27FC236}">
-                <a16:creationId xmlns:a16="http://schemas.microsoft.com/office/drawing/2014/main" id="{17F26C85-38FD-4854-BEFB-169693F64E7B}"/>
+                <a16:creationId xmlns:a16="http://schemas.microsoft.com/office/drawing/2014/main" id="{02734539-2EE1-4F50-B3D8-9C10AC299A5D}"/>
               </a:ext>
             </a:extLst>
           </p:cNvPr>
@@ -12484,7 +12484,7 @@
           <p:cNvPr id="9" name="">
             <a:extLst xmlns:a="http://schemas.openxmlformats.org/drawingml/2006/main">
               <a:ext uri="{FF2B5EF4-FFF2-40B4-BE49-F238E27FC236}">
-                <a16:creationId xmlns:a16="http://schemas.microsoft.com/office/drawing/2014/main" id="{5A778AE2-F919-4A45-82E8-9C77DC91743F}"/>
+                <a16:creationId xmlns:a16="http://schemas.microsoft.com/office/drawing/2014/main" id="{2D8A496F-ED8A-49C3-B4BC-E191F1170B78}"/>
               </a:ext>
             </a:extLst>
           </p:cNvPr>
@@ -12514,7 +12514,7 @@
           <p:cNvPr id="10" name="">
             <a:extLst xmlns:a="http://schemas.openxmlformats.org/drawingml/2006/main">
               <a:ext uri="{FF2B5EF4-FFF2-40B4-BE49-F238E27FC236}">
-                <a16:creationId xmlns:a16="http://schemas.microsoft.com/office/drawing/2014/main" id="{FF6C6A8A-B13A-48B1-98BE-D19BC30115BA}"/>
+                <a16:creationId xmlns:a16="http://schemas.microsoft.com/office/drawing/2014/main" id="{BF7FC6BA-701D-4C6B-8639-38E801CF62A3}"/>
               </a:ext>
             </a:extLst>
           </p:cNvPr>
@@ -12571,7 +12571,7 @@
           <p:cNvPr id="11" name="">
             <a:extLst xmlns:a="http://schemas.openxmlformats.org/drawingml/2006/main">
               <a:ext uri="{FF2B5EF4-FFF2-40B4-BE49-F238E27FC236}">
-                <a16:creationId xmlns:a16="http://schemas.microsoft.com/office/drawing/2014/main" id="{2613096B-6822-47EE-946F-719BA3C4E9FB}"/>
+                <a16:creationId xmlns:a16="http://schemas.microsoft.com/office/drawing/2014/main" id="{DBD36648-38DC-4EFF-B5EF-8F734E05C7D6}"/>
               </a:ext>
             </a:extLst>
           </p:cNvPr>
@@ -12626,7 +12626,7 @@
     </p:spTree>
     <p:extLst>
       <p:ext uri="{BB962C8B-B14F-4D97-AF65-F5344CB8AC3E}">
-        <p14:creationId xmlns:p14="http://schemas.microsoft.com/office/powerpoint/2010/main" val="649338664"/>
+        <p14:creationId xmlns:p14="http://schemas.microsoft.com/office/powerpoint/2010/main" val="1797722384"/>
       </p:ext>
     </p:extLst>
   </p:cSld>
@@ -12657,7 +12657,7 @@
           <p:cNvPr id="53" name="">
             <a:extLst xmlns:a="http://schemas.openxmlformats.org/drawingml/2006/main">
               <a:ext uri="{FF2B5EF4-FFF2-40B4-BE49-F238E27FC236}">
-                <a16:creationId xmlns:a16="http://schemas.microsoft.com/office/drawing/2014/main" id="{0B516E78-D3EF-4DBD-B530-0B9D36738877}"/>
+                <a16:creationId xmlns:a16="http://schemas.microsoft.com/office/drawing/2014/main" id="{A8297569-8F1B-44D1-87F9-59915B549092}"/>
               </a:ext>
             </a:extLst>
           </p:cNvPr>
@@ -12714,7 +12714,7 @@
           <p:cNvPr id="2" name="">
             <a:extLst xmlns:a="http://schemas.openxmlformats.org/drawingml/2006/main">
               <a:ext uri="{FF2B5EF4-FFF2-40B4-BE49-F238E27FC236}">
-                <a16:creationId xmlns:a16="http://schemas.microsoft.com/office/drawing/2014/main" id="{4F7049CC-AFCB-41CF-9BA0-A249C0ADB2B5}"/>
+                <a16:creationId xmlns:a16="http://schemas.microsoft.com/office/drawing/2014/main" id="{414C58C7-1764-48EA-8643-0BA36630A6F9}"/>
               </a:ext>
             </a:extLst>
           </p:cNvPr>
@@ -12771,7 +12771,7 @@
           <p:cNvPr id="3" name="">
             <a:extLst xmlns:a="http://schemas.openxmlformats.org/drawingml/2006/main">
               <a:ext uri="{FF2B5EF4-FFF2-40B4-BE49-F238E27FC236}">
-                <a16:creationId xmlns:a16="http://schemas.microsoft.com/office/drawing/2014/main" id="{FC78F6C0-5B35-48AB-B285-89F28FB2D19D}"/>
+                <a16:creationId xmlns:a16="http://schemas.microsoft.com/office/drawing/2014/main" id="{125DC874-A606-4E7F-A4AA-9E25120D0B0E}"/>
               </a:ext>
             </a:extLst>
           </p:cNvPr>
@@ -12828,7 +12828,7 @@
           <p:cNvPr id="4" name="">
             <a:extLst xmlns:a="http://schemas.openxmlformats.org/drawingml/2006/main">
               <a:ext uri="{FF2B5EF4-FFF2-40B4-BE49-F238E27FC236}">
-                <a16:creationId xmlns:a16="http://schemas.microsoft.com/office/drawing/2014/main" id="{BCD8D139-0954-4D46-AB8C-C9849CE2CEB3}"/>
+                <a16:creationId xmlns:a16="http://schemas.microsoft.com/office/drawing/2014/main" id="{77712802-02AC-4BE9-B325-FCAE9B9616A0}"/>
               </a:ext>
             </a:extLst>
           </p:cNvPr>
@@ -12885,7 +12885,7 @@
           <p:cNvPr id="5" name="">
             <a:extLst xmlns:a="http://schemas.openxmlformats.org/drawingml/2006/main">
               <a:ext uri="{FF2B5EF4-FFF2-40B4-BE49-F238E27FC236}">
-                <a16:creationId xmlns:a16="http://schemas.microsoft.com/office/drawing/2014/main" id="{13B6EA4D-5CC4-4C6E-9AA3-D31AE812EA3D}"/>
+                <a16:creationId xmlns:a16="http://schemas.microsoft.com/office/drawing/2014/main" id="{F1BBAF5C-E6A5-4FD5-9E61-F89BD37783A0}"/>
               </a:ext>
             </a:extLst>
           </p:cNvPr>
@@ -12915,7 +12915,7 @@
           <p:cNvPr id="6" name="">
             <a:extLst xmlns:a="http://schemas.openxmlformats.org/drawingml/2006/main">
               <a:ext uri="{FF2B5EF4-FFF2-40B4-BE49-F238E27FC236}">
-                <a16:creationId xmlns:a16="http://schemas.microsoft.com/office/drawing/2014/main" id="{10020560-0CFD-4F93-AB74-8753C99CCEEA}"/>
+                <a16:creationId xmlns:a16="http://schemas.microsoft.com/office/drawing/2014/main" id="{8EAEE17E-101C-4EBE-996C-3711C3B48148}"/>
               </a:ext>
             </a:extLst>
           </p:cNvPr>
@@ -12945,7 +12945,7 @@
           <p:cNvPr id="7" name="">
             <a:extLst xmlns:a="http://schemas.openxmlformats.org/drawingml/2006/main">
               <a:ext uri="{FF2B5EF4-FFF2-40B4-BE49-F238E27FC236}">
-                <a16:creationId xmlns:a16="http://schemas.microsoft.com/office/drawing/2014/main" id="{53BCB826-71EB-4190-BB9D-9732F781197C}"/>
+                <a16:creationId xmlns:a16="http://schemas.microsoft.com/office/drawing/2014/main" id="{8C0B5258-08F3-4E3A-8FE1-0E1F3B01C6E3}"/>
               </a:ext>
             </a:extLst>
           </p:cNvPr>
@@ -12975,7 +12975,7 @@
           <p:cNvPr id="8" name="">
             <a:extLst xmlns:a="http://schemas.openxmlformats.org/drawingml/2006/main">
               <a:ext uri="{FF2B5EF4-FFF2-40B4-BE49-F238E27FC236}">
-                <a16:creationId xmlns:a16="http://schemas.microsoft.com/office/drawing/2014/main" id="{F485B231-6033-468A-B401-CBC1FC1DBE26}"/>
+                <a16:creationId xmlns:a16="http://schemas.microsoft.com/office/drawing/2014/main" id="{E9C7EFC4-3F99-434F-B6EF-69AAEF84D121}"/>
               </a:ext>
             </a:extLst>
           </p:cNvPr>
@@ -13005,7 +13005,7 @@
           <p:cNvPr id="9" name="">
             <a:extLst xmlns:a="http://schemas.openxmlformats.org/drawingml/2006/main">
               <a:ext uri="{FF2B5EF4-FFF2-40B4-BE49-F238E27FC236}">
-                <a16:creationId xmlns:a16="http://schemas.microsoft.com/office/drawing/2014/main" id="{1C19CCD4-D7DF-4B67-8392-2E212B9F8010}"/>
+                <a16:creationId xmlns:a16="http://schemas.microsoft.com/office/drawing/2014/main" id="{A4D08E12-1BDF-400D-8255-343E830D5A43}"/>
               </a:ext>
             </a:extLst>
           </p:cNvPr>
@@ -13035,7 +13035,7 @@
           <p:cNvPr id="10" name="">
             <a:extLst xmlns:a="http://schemas.openxmlformats.org/drawingml/2006/main">
               <a:ext uri="{FF2B5EF4-FFF2-40B4-BE49-F238E27FC236}">
-                <a16:creationId xmlns:a16="http://schemas.microsoft.com/office/drawing/2014/main" id="{CF394780-844B-4396-9914-32670D32B4C6}"/>
+                <a16:creationId xmlns:a16="http://schemas.microsoft.com/office/drawing/2014/main" id="{0043AF27-239A-478E-8F62-680E374F22AA}"/>
               </a:ext>
             </a:extLst>
           </p:cNvPr>
@@ -13065,7 +13065,7 @@
           <p:cNvPr id="11" name="">
             <a:extLst xmlns:a="http://schemas.openxmlformats.org/drawingml/2006/main">
               <a:ext uri="{FF2B5EF4-FFF2-40B4-BE49-F238E27FC236}">
-                <a16:creationId xmlns:a16="http://schemas.microsoft.com/office/drawing/2014/main" id="{16A306D0-59BA-4913-94B4-09395238805F}"/>
+                <a16:creationId xmlns:a16="http://schemas.microsoft.com/office/drawing/2014/main" id="{78AE1DEC-BF1C-4E18-ABF7-51C93EF2F669}"/>
               </a:ext>
             </a:extLst>
           </p:cNvPr>
@@ -13095,7 +13095,7 @@
           <p:cNvPr id="12" name="">
             <a:extLst xmlns:a="http://schemas.openxmlformats.org/drawingml/2006/main">
               <a:ext uri="{FF2B5EF4-FFF2-40B4-BE49-F238E27FC236}">
-                <a16:creationId xmlns:a16="http://schemas.microsoft.com/office/drawing/2014/main" id="{4420F197-F19B-4FC2-85AC-E1486A2A3E2D}"/>
+                <a16:creationId xmlns:a16="http://schemas.microsoft.com/office/drawing/2014/main" id="{990EAFC4-8FE5-4F92-A112-D45DC79E1030}"/>
               </a:ext>
             </a:extLst>
           </p:cNvPr>
@@ -13125,7 +13125,7 @@
           <p:cNvPr id="13" name="">
             <a:extLst xmlns:a="http://schemas.openxmlformats.org/drawingml/2006/main">
               <a:ext uri="{FF2B5EF4-FFF2-40B4-BE49-F238E27FC236}">
-                <a16:creationId xmlns:a16="http://schemas.microsoft.com/office/drawing/2014/main" id="{D6544F8A-D032-4034-9E37-9982B5C31FD5}"/>
+                <a16:creationId xmlns:a16="http://schemas.microsoft.com/office/drawing/2014/main" id="{42B01E6B-144E-4F6D-956B-09578672159A}"/>
               </a:ext>
             </a:extLst>
           </p:cNvPr>
@@ -13155,7 +13155,7 @@
           <p:cNvPr id="14" name="">
             <a:extLst xmlns:a="http://schemas.openxmlformats.org/drawingml/2006/main">
               <a:ext uri="{FF2B5EF4-FFF2-40B4-BE49-F238E27FC236}">
-                <a16:creationId xmlns:a16="http://schemas.microsoft.com/office/drawing/2014/main" id="{D93FA19E-F29E-43CE-B8B2-9A0ADFCB90FD}"/>
+                <a16:creationId xmlns:a16="http://schemas.microsoft.com/office/drawing/2014/main" id="{3F65113F-3109-461D-9BF0-C19169558DB4}"/>
               </a:ext>
             </a:extLst>
           </p:cNvPr>
@@ -13185,7 +13185,7 @@
           <p:cNvPr id="15" name="">
             <a:extLst xmlns:a="http://schemas.openxmlformats.org/drawingml/2006/main">
               <a:ext uri="{FF2B5EF4-FFF2-40B4-BE49-F238E27FC236}">
-                <a16:creationId xmlns:a16="http://schemas.microsoft.com/office/drawing/2014/main" id="{39E2AA0A-2356-4AA9-88BE-608E0C4C31BC}"/>
+                <a16:creationId xmlns:a16="http://schemas.microsoft.com/office/drawing/2014/main" id="{E90628DE-4936-42FC-ACFC-D2FF15D82F60}"/>
               </a:ext>
             </a:extLst>
           </p:cNvPr>
@@ -13215,7 +13215,7 @@
           <p:cNvPr id="16" name="">
             <a:extLst xmlns:a="http://schemas.openxmlformats.org/drawingml/2006/main">
               <a:ext uri="{FF2B5EF4-FFF2-40B4-BE49-F238E27FC236}">
-                <a16:creationId xmlns:a16="http://schemas.microsoft.com/office/drawing/2014/main" id="{A6F2B6D7-1393-40AE-ACAD-4226644004E2}"/>
+                <a16:creationId xmlns:a16="http://schemas.microsoft.com/office/drawing/2014/main" id="{ABDF84F4-6B74-445A-A96D-F2F030580E5D}"/>
               </a:ext>
             </a:extLst>
           </p:cNvPr>
@@ -13245,7 +13245,7 @@
           <p:cNvPr id="17" name="">
             <a:extLst xmlns:a="http://schemas.openxmlformats.org/drawingml/2006/main">
               <a:ext uri="{FF2B5EF4-FFF2-40B4-BE49-F238E27FC236}">
-                <a16:creationId xmlns:a16="http://schemas.microsoft.com/office/drawing/2014/main" id="{9884EAED-C487-43EC-A2E5-221B9C35F9ED}"/>
+                <a16:creationId xmlns:a16="http://schemas.microsoft.com/office/drawing/2014/main" id="{6EBC3B72-B8D8-4DF0-8A1B-E9E717BFB649}"/>
               </a:ext>
             </a:extLst>
           </p:cNvPr>
@@ -13275,7 +13275,7 @@
           <p:cNvPr id="18" name="">
             <a:extLst xmlns:a="http://schemas.openxmlformats.org/drawingml/2006/main">
               <a:ext uri="{FF2B5EF4-FFF2-40B4-BE49-F238E27FC236}">
-                <a16:creationId xmlns:a16="http://schemas.microsoft.com/office/drawing/2014/main" id="{A1D69A76-4748-4138-87D3-6237AC0913FF}"/>
+                <a16:creationId xmlns:a16="http://schemas.microsoft.com/office/drawing/2014/main" id="{C9A4EE6C-8608-4495-9309-9D32066ECC64}"/>
               </a:ext>
             </a:extLst>
           </p:cNvPr>
@@ -13305,7 +13305,7 @@
           <p:cNvPr id="19" name="">
             <a:extLst xmlns:a="http://schemas.openxmlformats.org/drawingml/2006/main">
               <a:ext uri="{FF2B5EF4-FFF2-40B4-BE49-F238E27FC236}">
-                <a16:creationId xmlns:a16="http://schemas.microsoft.com/office/drawing/2014/main" id="{3D0D8F10-43E3-45F7-A8BC-4A382BE677AC}"/>
+                <a16:creationId xmlns:a16="http://schemas.microsoft.com/office/drawing/2014/main" id="{5923E155-E878-4960-B9D9-08F8AB04E41B}"/>
               </a:ext>
             </a:extLst>
           </p:cNvPr>
@@ -13335,7 +13335,7 @@
           <p:cNvPr id="20" name="">
             <a:extLst xmlns:a="http://schemas.openxmlformats.org/drawingml/2006/main">
               <a:ext uri="{FF2B5EF4-FFF2-40B4-BE49-F238E27FC236}">
-                <a16:creationId xmlns:a16="http://schemas.microsoft.com/office/drawing/2014/main" id="{A6E48164-E99C-41C8-A361-D41584900DC3}"/>
+                <a16:creationId xmlns:a16="http://schemas.microsoft.com/office/drawing/2014/main" id="{ECB954EB-30C1-4FFD-AACC-BF1F2F5C1C9B}"/>
               </a:ext>
             </a:extLst>
           </p:cNvPr>
@@ -13365,7 +13365,7 @@
           <p:cNvPr id="21" name="">
             <a:extLst xmlns:a="http://schemas.openxmlformats.org/drawingml/2006/main">
               <a:ext uri="{FF2B5EF4-FFF2-40B4-BE49-F238E27FC236}">
-                <a16:creationId xmlns:a16="http://schemas.microsoft.com/office/drawing/2014/main" id="{5EAB8DB2-01C3-4DDD-A77C-A86326987D64}"/>
+                <a16:creationId xmlns:a16="http://schemas.microsoft.com/office/drawing/2014/main" id="{2F19EF15-10C9-45EB-B14A-8A4D46A5151C}"/>
               </a:ext>
             </a:extLst>
           </p:cNvPr>
@@ -13395,7 +13395,7 @@
           <p:cNvPr id="22" name="">
             <a:extLst xmlns:a="http://schemas.openxmlformats.org/drawingml/2006/main">
               <a:ext uri="{FF2B5EF4-FFF2-40B4-BE49-F238E27FC236}">
-                <a16:creationId xmlns:a16="http://schemas.microsoft.com/office/drawing/2014/main" id="{D8B00A63-6A3C-4AB9-A28C-1AE80ECEE412}"/>
+                <a16:creationId xmlns:a16="http://schemas.microsoft.com/office/drawing/2014/main" id="{66AE18F9-180F-41B8-9441-175D6E33F705}"/>
               </a:ext>
             </a:extLst>
           </p:cNvPr>
@@ -13425,7 +13425,7 @@
           <p:cNvPr id="23" name="">
             <a:extLst xmlns:a="http://schemas.openxmlformats.org/drawingml/2006/main">
               <a:ext uri="{FF2B5EF4-FFF2-40B4-BE49-F238E27FC236}">
-                <a16:creationId xmlns:a16="http://schemas.microsoft.com/office/drawing/2014/main" id="{2B589356-9BAB-4C3F-AAAA-6E3FE5DB08F0}"/>
+                <a16:creationId xmlns:a16="http://schemas.microsoft.com/office/drawing/2014/main" id="{14B2B13B-AA15-44E8-B7E9-D3D5D43DE8A8}"/>
               </a:ext>
             </a:extLst>
           </p:cNvPr>
@@ -13455,7 +13455,7 @@
           <p:cNvPr id="24" name="">
             <a:extLst xmlns:a="http://schemas.openxmlformats.org/drawingml/2006/main">
               <a:ext uri="{FF2B5EF4-FFF2-40B4-BE49-F238E27FC236}">
-                <a16:creationId xmlns:a16="http://schemas.microsoft.com/office/drawing/2014/main" id="{D82C1A3C-5880-450A-9C6E-C22AA698FDB2}"/>
+                <a16:creationId xmlns:a16="http://schemas.microsoft.com/office/drawing/2014/main" id="{61E5A189-F0AD-42A4-8055-2CBE22493603}"/>
               </a:ext>
             </a:extLst>
           </p:cNvPr>
@@ -13485,7 +13485,7 @@
           <p:cNvPr id="25" name="">
             <a:extLst xmlns:a="http://schemas.openxmlformats.org/drawingml/2006/main">
               <a:ext uri="{FF2B5EF4-FFF2-40B4-BE49-F238E27FC236}">
-                <a16:creationId xmlns:a16="http://schemas.microsoft.com/office/drawing/2014/main" id="{8F00F682-1E79-436D-8F1A-C338AFC6E41F}"/>
+                <a16:creationId xmlns:a16="http://schemas.microsoft.com/office/drawing/2014/main" id="{3888D0DC-40DD-427E-ADBA-5BEF08973DDA}"/>
               </a:ext>
             </a:extLst>
           </p:cNvPr>
@@ -13515,7 +13515,7 @@
           <p:cNvPr id="26" name="">
             <a:extLst xmlns:a="http://schemas.openxmlformats.org/drawingml/2006/main">
               <a:ext uri="{FF2B5EF4-FFF2-40B4-BE49-F238E27FC236}">
-                <a16:creationId xmlns:a16="http://schemas.microsoft.com/office/drawing/2014/main" id="{09E9FE1F-BCA0-410E-B757-FB255CBA1700}"/>
+                <a16:creationId xmlns:a16="http://schemas.microsoft.com/office/drawing/2014/main" id="{824AD5B3-5E6D-451A-8F55-10279B46AF3D}"/>
               </a:ext>
             </a:extLst>
           </p:cNvPr>
@@ -13545,7 +13545,7 @@
           <p:cNvPr id="27" name="">
             <a:extLst xmlns:a="http://schemas.openxmlformats.org/drawingml/2006/main">
               <a:ext uri="{FF2B5EF4-FFF2-40B4-BE49-F238E27FC236}">
-                <a16:creationId xmlns:a16="http://schemas.microsoft.com/office/drawing/2014/main" id="{95A8ABBE-595D-47D7-9BBC-66087F7DFF4B}"/>
+                <a16:creationId xmlns:a16="http://schemas.microsoft.com/office/drawing/2014/main" id="{263DC185-8337-4AB6-BC68-502D85B0D1D6}"/>
               </a:ext>
             </a:extLst>
           </p:cNvPr>
@@ -13575,7 +13575,7 @@
           <p:cNvPr id="28" name="">
             <a:extLst xmlns:a="http://schemas.openxmlformats.org/drawingml/2006/main">
               <a:ext uri="{FF2B5EF4-FFF2-40B4-BE49-F238E27FC236}">
-                <a16:creationId xmlns:a16="http://schemas.microsoft.com/office/drawing/2014/main" id="{31FBF679-D716-4D6B-A976-99F93E41F2EB}"/>
+                <a16:creationId xmlns:a16="http://schemas.microsoft.com/office/drawing/2014/main" id="{E81D7A7A-5611-48ED-8363-E8AB131C3EB0}"/>
               </a:ext>
             </a:extLst>
           </p:cNvPr>
@@ -13605,7 +13605,7 @@
           <p:cNvPr id="29" name="">
             <a:extLst xmlns:a="http://schemas.openxmlformats.org/drawingml/2006/main">
               <a:ext uri="{FF2B5EF4-FFF2-40B4-BE49-F238E27FC236}">
-                <a16:creationId xmlns:a16="http://schemas.microsoft.com/office/drawing/2014/main" id="{1F758CDE-6832-43DB-ABB9-63E95B9CE2CC}"/>
+                <a16:creationId xmlns:a16="http://schemas.microsoft.com/office/drawing/2014/main" id="{5C50D02D-F2F3-4C14-8870-F2D5C6CC1DB6}"/>
               </a:ext>
             </a:extLst>
           </p:cNvPr>
@@ -13635,7 +13635,7 @@
           <p:cNvPr id="30" name="">
             <a:extLst xmlns:a="http://schemas.openxmlformats.org/drawingml/2006/main">
               <a:ext uri="{FF2B5EF4-FFF2-40B4-BE49-F238E27FC236}">
-                <a16:creationId xmlns:a16="http://schemas.microsoft.com/office/drawing/2014/main" id="{745CD1E7-9B8E-4638-8190-3BD4AFD62062}"/>
+                <a16:creationId xmlns:a16="http://schemas.microsoft.com/office/drawing/2014/main" id="{63523D16-214C-4C6A-B82E-AC63339BBA08}"/>
               </a:ext>
             </a:extLst>
           </p:cNvPr>
@@ -13665,7 +13665,7 @@
           <p:cNvPr id="31" name="">
             <a:extLst xmlns:a="http://schemas.openxmlformats.org/drawingml/2006/main">
               <a:ext uri="{FF2B5EF4-FFF2-40B4-BE49-F238E27FC236}">
-                <a16:creationId xmlns:a16="http://schemas.microsoft.com/office/drawing/2014/main" id="{D9F97F3C-EE30-4177-B440-32E80AD6BFD9}"/>
+                <a16:creationId xmlns:a16="http://schemas.microsoft.com/office/drawing/2014/main" id="{19106410-89E1-4947-ACF3-7FDF11CED46A}"/>
               </a:ext>
             </a:extLst>
           </p:cNvPr>
@@ -13695,7 +13695,7 @@
           <p:cNvPr id="32" name="">
             <a:extLst xmlns:a="http://schemas.openxmlformats.org/drawingml/2006/main">
               <a:ext uri="{FF2B5EF4-FFF2-40B4-BE49-F238E27FC236}">
-                <a16:creationId xmlns:a16="http://schemas.microsoft.com/office/drawing/2014/main" id="{57DB759B-39E0-4C78-A42E-484EA6D766C2}"/>
+                <a16:creationId xmlns:a16="http://schemas.microsoft.com/office/drawing/2014/main" id="{53E09886-B56A-4438-B8E0-7F2DC2247FAE}"/>
               </a:ext>
             </a:extLst>
           </p:cNvPr>
@@ -13725,7 +13725,7 @@
           <p:cNvPr id="33" name="">
             <a:extLst xmlns:a="http://schemas.openxmlformats.org/drawingml/2006/main">
               <a:ext uri="{FF2B5EF4-FFF2-40B4-BE49-F238E27FC236}">
-                <a16:creationId xmlns:a16="http://schemas.microsoft.com/office/drawing/2014/main" id="{82DC6660-3E20-4608-97C1-A87235DAF775}"/>
+                <a16:creationId xmlns:a16="http://schemas.microsoft.com/office/drawing/2014/main" id="{2E560D2C-A3D1-40C7-AD77-FA2B336F6D05}"/>
               </a:ext>
             </a:extLst>
           </p:cNvPr>
@@ -13755,7 +13755,7 @@
           <p:cNvPr id="34" name="">
             <a:extLst xmlns:a="http://schemas.openxmlformats.org/drawingml/2006/main">
               <a:ext uri="{FF2B5EF4-FFF2-40B4-BE49-F238E27FC236}">
-                <a16:creationId xmlns:a16="http://schemas.microsoft.com/office/drawing/2014/main" id="{99F98CEB-2E62-4C07-8888-7F5ACCE7E8A1}"/>
+                <a16:creationId xmlns:a16="http://schemas.microsoft.com/office/drawing/2014/main" id="{EC3E7EC3-2F6C-4B39-9F14-C4C2501D971C}"/>
               </a:ext>
             </a:extLst>
           </p:cNvPr>
@@ -13785,7 +13785,7 @@
           <p:cNvPr id="35" name="">
             <a:extLst xmlns:a="http://schemas.openxmlformats.org/drawingml/2006/main">
               <a:ext uri="{FF2B5EF4-FFF2-40B4-BE49-F238E27FC236}">
-                <a16:creationId xmlns:a16="http://schemas.microsoft.com/office/drawing/2014/main" id="{4582A066-056B-45E2-A256-1CCD67DC74D4}"/>
+                <a16:creationId xmlns:a16="http://schemas.microsoft.com/office/drawing/2014/main" id="{B44740F5-6D04-47EF-A5CA-72E0142BEDB3}"/>
               </a:ext>
             </a:extLst>
           </p:cNvPr>
@@ -13815,7 +13815,7 @@
           <p:cNvPr id="36" name="">
             <a:extLst xmlns:a="http://schemas.openxmlformats.org/drawingml/2006/main">
               <a:ext uri="{FF2B5EF4-FFF2-40B4-BE49-F238E27FC236}">
-                <a16:creationId xmlns:a16="http://schemas.microsoft.com/office/drawing/2014/main" id="{75FD1913-24D3-44BD-B499-563981251CFA}"/>
+                <a16:creationId xmlns:a16="http://schemas.microsoft.com/office/drawing/2014/main" id="{AFE16A53-0D85-4185-A3E6-B413755C1DB8}"/>
               </a:ext>
             </a:extLst>
           </p:cNvPr>
@@ -13845,7 +13845,7 @@
           <p:cNvPr id="37" name="">
             <a:extLst xmlns:a="http://schemas.openxmlformats.org/drawingml/2006/main">
               <a:ext uri="{FF2B5EF4-FFF2-40B4-BE49-F238E27FC236}">
-                <a16:creationId xmlns:a16="http://schemas.microsoft.com/office/drawing/2014/main" id="{8D12A592-0186-40E4-A8BA-ADF872BF4A0B}"/>
+                <a16:creationId xmlns:a16="http://schemas.microsoft.com/office/drawing/2014/main" id="{621DD3A1-EA7D-4FD4-9B57-1E160AAED55C}"/>
               </a:ext>
             </a:extLst>
           </p:cNvPr>
@@ -13875,7 +13875,7 @@
           <p:cNvPr id="38" name="">
             <a:extLst xmlns:a="http://schemas.openxmlformats.org/drawingml/2006/main">
               <a:ext uri="{FF2B5EF4-FFF2-40B4-BE49-F238E27FC236}">
-                <a16:creationId xmlns:a16="http://schemas.microsoft.com/office/drawing/2014/main" id="{5BC48818-926D-4E3E-B84F-5E2B56241648}"/>
+                <a16:creationId xmlns:a16="http://schemas.microsoft.com/office/drawing/2014/main" id="{1BA1115C-E6E7-400F-85AA-05745E3B994B}"/>
               </a:ext>
             </a:extLst>
           </p:cNvPr>
@@ -13905,7 +13905,7 @@
           <p:cNvPr id="39" name="">
             <a:extLst xmlns:a="http://schemas.openxmlformats.org/drawingml/2006/main">
               <a:ext uri="{FF2B5EF4-FFF2-40B4-BE49-F238E27FC236}">
-                <a16:creationId xmlns:a16="http://schemas.microsoft.com/office/drawing/2014/main" id="{36EF75DC-E638-48FA-A3A5-129509EB40DC}"/>
+                <a16:creationId xmlns:a16="http://schemas.microsoft.com/office/drawing/2014/main" id="{EB4728B9-2256-45F9-95C7-A07A14AF0AD1}"/>
               </a:ext>
             </a:extLst>
           </p:cNvPr>
@@ -13935,7 +13935,7 @@
           <p:cNvPr id="40" name="">
             <a:extLst xmlns:a="http://schemas.openxmlformats.org/drawingml/2006/main">
               <a:ext uri="{FF2B5EF4-FFF2-40B4-BE49-F238E27FC236}">
-                <a16:creationId xmlns:a16="http://schemas.microsoft.com/office/drawing/2014/main" id="{CD0521C7-E70A-469D-B998-58E996DFDD1B}"/>
+                <a16:creationId xmlns:a16="http://schemas.microsoft.com/office/drawing/2014/main" id="{781EFCB7-375F-48CD-8072-8C47ACD6122D}"/>
               </a:ext>
             </a:extLst>
           </p:cNvPr>
@@ -13965,7 +13965,7 @@
           <p:cNvPr id="41" name="">
             <a:extLst xmlns:a="http://schemas.openxmlformats.org/drawingml/2006/main">
               <a:ext uri="{FF2B5EF4-FFF2-40B4-BE49-F238E27FC236}">
-                <a16:creationId xmlns:a16="http://schemas.microsoft.com/office/drawing/2014/main" id="{6C430CDD-419C-4BF8-8B27-39CB04B8E7B6}"/>
+                <a16:creationId xmlns:a16="http://schemas.microsoft.com/office/drawing/2014/main" id="{4D39EDB2-EAFB-4380-9AF7-DE8655424445}"/>
               </a:ext>
             </a:extLst>
           </p:cNvPr>
@@ -13995,7 +13995,7 @@
           <p:cNvPr id="42" name="">
             <a:extLst xmlns:a="http://schemas.openxmlformats.org/drawingml/2006/main">
               <a:ext uri="{FF2B5EF4-FFF2-40B4-BE49-F238E27FC236}">
-                <a16:creationId xmlns:a16="http://schemas.microsoft.com/office/drawing/2014/main" id="{44FE0479-5063-4303-950D-0FE2EB1B1C03}"/>
+                <a16:creationId xmlns:a16="http://schemas.microsoft.com/office/drawing/2014/main" id="{0BEAF5D5-35B1-4855-930F-B64E627DBFF7}"/>
               </a:ext>
             </a:extLst>
           </p:cNvPr>
@@ -14025,7 +14025,7 @@
           <p:cNvPr id="43" name="">
             <a:extLst xmlns:a="http://schemas.openxmlformats.org/drawingml/2006/main">
               <a:ext uri="{FF2B5EF4-FFF2-40B4-BE49-F238E27FC236}">
-                <a16:creationId xmlns:a16="http://schemas.microsoft.com/office/drawing/2014/main" id="{8C67B73E-F700-44C6-8D1C-072B1539C200}"/>
+                <a16:creationId xmlns:a16="http://schemas.microsoft.com/office/drawing/2014/main" id="{30E996EE-FA57-4F2D-8E76-2038AEEE4FBC}"/>
               </a:ext>
             </a:extLst>
           </p:cNvPr>
@@ -14055,7 +14055,7 @@
           <p:cNvPr id="44" name="">
             <a:extLst xmlns:a="http://schemas.openxmlformats.org/drawingml/2006/main">
               <a:ext uri="{FF2B5EF4-FFF2-40B4-BE49-F238E27FC236}">
-                <a16:creationId xmlns:a16="http://schemas.microsoft.com/office/drawing/2014/main" id="{6B3DBCEB-DF71-4719-9096-35C371E4051C}"/>
+                <a16:creationId xmlns:a16="http://schemas.microsoft.com/office/drawing/2014/main" id="{69B68C83-CAEF-4944-A940-5A14AD1E1F4C}"/>
               </a:ext>
             </a:extLst>
           </p:cNvPr>
@@ -14085,7 +14085,7 @@
           <p:cNvPr id="45" name="">
             <a:extLst xmlns:a="http://schemas.openxmlformats.org/drawingml/2006/main">
               <a:ext uri="{FF2B5EF4-FFF2-40B4-BE49-F238E27FC236}">
-                <a16:creationId xmlns:a16="http://schemas.microsoft.com/office/drawing/2014/main" id="{54ED3B53-B23B-499E-AAA7-B87CA2D82E0F}"/>
+                <a16:creationId xmlns:a16="http://schemas.microsoft.com/office/drawing/2014/main" id="{89910D76-B9FF-4BA8-A374-7C08B712D2C4}"/>
               </a:ext>
             </a:extLst>
           </p:cNvPr>
@@ -14142,7 +14142,7 @@
           <p:cNvPr id="46" name="">
             <a:extLst xmlns:a="http://schemas.openxmlformats.org/drawingml/2006/main">
               <a:ext uri="{FF2B5EF4-FFF2-40B4-BE49-F238E27FC236}">
-                <a16:creationId xmlns:a16="http://schemas.microsoft.com/office/drawing/2014/main" id="{143E9862-D53E-4C7C-849B-3C13B7BBEF2E}"/>
+                <a16:creationId xmlns:a16="http://schemas.microsoft.com/office/drawing/2014/main" id="{06C94472-2962-4643-A4B1-182A0A6E0686}"/>
               </a:ext>
             </a:extLst>
           </p:cNvPr>
@@ -14199,7 +14199,7 @@
           <p:cNvPr id="47" name="">
             <a:extLst xmlns:a="http://schemas.openxmlformats.org/drawingml/2006/main">
               <a:ext uri="{FF2B5EF4-FFF2-40B4-BE49-F238E27FC236}">
-                <a16:creationId xmlns:a16="http://schemas.microsoft.com/office/drawing/2014/main" id="{92D477A9-1B40-4F92-A306-FB2D62012429}"/>
+                <a16:creationId xmlns:a16="http://schemas.microsoft.com/office/drawing/2014/main" id="{8688B80C-0B15-4B0C-B0BF-125EC7149E9E}"/>
               </a:ext>
             </a:extLst>
           </p:cNvPr>
@@ -14256,7 +14256,7 @@
           <p:cNvPr id="48" name="">
             <a:extLst xmlns:a="http://schemas.openxmlformats.org/drawingml/2006/main">
               <a:ext uri="{FF2B5EF4-FFF2-40B4-BE49-F238E27FC236}">
-                <a16:creationId xmlns:a16="http://schemas.microsoft.com/office/drawing/2014/main" id="{F2DD8E18-02C6-433B-A271-CA3395CF942B}"/>
+                <a16:creationId xmlns:a16="http://schemas.microsoft.com/office/drawing/2014/main" id="{65FFEB83-566F-416E-BB30-3243CE70B8EE}"/>
               </a:ext>
             </a:extLst>
           </p:cNvPr>
@@ -14313,7 +14313,7 @@
           <p:cNvPr id="49" name="">
             <a:extLst xmlns:a="http://schemas.openxmlformats.org/drawingml/2006/main">
               <a:ext uri="{FF2B5EF4-FFF2-40B4-BE49-F238E27FC236}">
-                <a16:creationId xmlns:a16="http://schemas.microsoft.com/office/drawing/2014/main" id="{00DD02B9-37B5-4103-9D58-3B754B27B255}"/>
+                <a16:creationId xmlns:a16="http://schemas.microsoft.com/office/drawing/2014/main" id="{70541805-AAD0-4D25-8DF9-2B841100320C}"/>
               </a:ext>
             </a:extLst>
           </p:cNvPr>
@@ -14370,7 +14370,7 @@
           <p:cNvPr id="50" name="">
             <a:extLst xmlns:a="http://schemas.openxmlformats.org/drawingml/2006/main">
               <a:ext uri="{FF2B5EF4-FFF2-40B4-BE49-F238E27FC236}">
-                <a16:creationId xmlns:a16="http://schemas.microsoft.com/office/drawing/2014/main" id="{A2EC6DE7-D7D3-48FC-99DE-361C02ACAB15}"/>
+                <a16:creationId xmlns:a16="http://schemas.microsoft.com/office/drawing/2014/main" id="{95794B4F-E8BF-4C0C-ACE2-6EB08BCF2A67}"/>
               </a:ext>
             </a:extLst>
           </p:cNvPr>
@@ -14400,7 +14400,7 @@
           <p:cNvPr id="51" name="">
             <a:extLst xmlns:a="http://schemas.openxmlformats.org/drawingml/2006/main">
               <a:ext uri="{FF2B5EF4-FFF2-40B4-BE49-F238E27FC236}">
-                <a16:creationId xmlns:a16="http://schemas.microsoft.com/office/drawing/2014/main" id="{24169F2A-9CEF-450D-8A81-515C5893271A}"/>
+                <a16:creationId xmlns:a16="http://schemas.microsoft.com/office/drawing/2014/main" id="{D0AC6563-B9F0-4349-909A-0B1BBFB1990E}"/>
               </a:ext>
             </a:extLst>
           </p:cNvPr>
@@ -14457,7 +14457,7 @@
           <p:cNvPr id="52" name="">
             <a:extLst xmlns:a="http://schemas.openxmlformats.org/drawingml/2006/main">
               <a:ext uri="{FF2B5EF4-FFF2-40B4-BE49-F238E27FC236}">
-                <a16:creationId xmlns:a16="http://schemas.microsoft.com/office/drawing/2014/main" id="{B78DB4F8-704E-4F16-A5AC-4C127C1D8685}"/>
+                <a16:creationId xmlns:a16="http://schemas.microsoft.com/office/drawing/2014/main" id="{63A02C98-86F2-4F73-939C-D92A59ED5619}"/>
               </a:ext>
             </a:extLst>
           </p:cNvPr>
@@ -14512,7 +14512,7 @@
     </p:spTree>
     <p:extLst>
       <p:ext uri="{BB962C8B-B14F-4D97-AF65-F5344CB8AC3E}">
-        <p14:creationId xmlns:p14="http://schemas.microsoft.com/office/powerpoint/2010/main" val="1402196288"/>
+        <p14:creationId xmlns:p14="http://schemas.microsoft.com/office/powerpoint/2010/main" val="254696724"/>
       </p:ext>
     </p:extLst>
   </p:cSld>
@@ -14543,7 +14543,7 @@
           <p:cNvPr id="19" name="">
             <a:extLst xmlns:a="http://schemas.openxmlformats.org/drawingml/2006/main">
               <a:ext uri="{FF2B5EF4-FFF2-40B4-BE49-F238E27FC236}">
-                <a16:creationId xmlns:a16="http://schemas.microsoft.com/office/drawing/2014/main" id="{F65E950B-5B17-4744-960C-3801604D2B7F}"/>
+                <a16:creationId xmlns:a16="http://schemas.microsoft.com/office/drawing/2014/main" id="{26702309-AC27-48A8-8EBB-1C1FDF98C850}"/>
               </a:ext>
             </a:extLst>
           </p:cNvPr>
@@ -14600,7 +14600,7 @@
           <p:cNvPr id="2" name="">
             <a:extLst xmlns:a="http://schemas.openxmlformats.org/drawingml/2006/main">
               <a:ext uri="{FF2B5EF4-FFF2-40B4-BE49-F238E27FC236}">
-                <a16:creationId xmlns:a16="http://schemas.microsoft.com/office/drawing/2014/main" id="{7A348587-2668-47CC-8D60-06446B7AA7B5}"/>
+                <a16:creationId xmlns:a16="http://schemas.microsoft.com/office/drawing/2014/main" id="{4187BCC1-FDEB-4EA7-9D14-819506979BFC}"/>
               </a:ext>
             </a:extLst>
           </p:cNvPr>
@@ -14657,7 +14657,7 @@
           <p:cNvPr id="3" name="">
             <a:extLst xmlns:a="http://schemas.openxmlformats.org/drawingml/2006/main">
               <a:ext uri="{FF2B5EF4-FFF2-40B4-BE49-F238E27FC236}">
-                <a16:creationId xmlns:a16="http://schemas.microsoft.com/office/drawing/2014/main" id="{897A4AE8-D499-40D2-8F78-D6BFAA7BEAE5}"/>
+                <a16:creationId xmlns:a16="http://schemas.microsoft.com/office/drawing/2014/main" id="{403A8C19-57A2-4A91-A642-9D18028085A1}"/>
               </a:ext>
             </a:extLst>
           </p:cNvPr>
@@ -14714,7 +14714,7 @@
           <p:cNvPr id="4" name="">
             <a:extLst xmlns:a="http://schemas.openxmlformats.org/drawingml/2006/main">
               <a:ext uri="{FF2B5EF4-FFF2-40B4-BE49-F238E27FC236}">
-                <a16:creationId xmlns:a16="http://schemas.microsoft.com/office/drawing/2014/main" id="{D07FDC13-3B66-45C4-92CD-6F1387AD75ED}"/>
+                <a16:creationId xmlns:a16="http://schemas.microsoft.com/office/drawing/2014/main" id="{0B5A5C0B-A180-4CA7-A92A-4FD65F40B774}"/>
               </a:ext>
             </a:extLst>
           </p:cNvPr>
@@ -14743,7 +14743,7 @@
           <a:lstStyle xmlns:a="http://schemas.openxmlformats.org/drawingml/2006/main"/>
           <a:p xmlns:a="http://schemas.openxmlformats.org/drawingml/2006/main">
             <a:pPr>
-              <a:defRPr sz="1950" b="0">
+              <a:defRPr sz="1650" b="0">
                 <a:solidFill>
                   <a:srgbClr val="166569"/>
                 </a:solidFill>
@@ -14753,7 +14753,7 @@
               </a:defRPr>
             </a:pPr>
             <a:r>
-              <a:rPr sz="1950" b="0">
+              <a:rPr sz="1650" b="0">
                 <a:solidFill>
                   <a:srgbClr val="166569"/>
                 </a:solidFill>
@@ -14771,7 +14771,7 @@
           <p:cNvPr id="5" name="">
             <a:extLst xmlns:a="http://schemas.openxmlformats.org/drawingml/2006/main">
               <a:ext uri="{FF2B5EF4-FFF2-40B4-BE49-F238E27FC236}">
-                <a16:creationId xmlns:a16="http://schemas.microsoft.com/office/drawing/2014/main" id="{D0C97C39-991D-4736-A64F-B01C47265A9A}"/>
+                <a16:creationId xmlns:a16="http://schemas.microsoft.com/office/drawing/2014/main" id="{2645A77A-6DE6-4264-967A-B3A55D7C46A9}"/>
               </a:ext>
             </a:extLst>
           </p:cNvPr>
@@ -14828,7 +14828,7 @@
           <p:cNvPr id="6" name="">
             <a:extLst xmlns:a="http://schemas.openxmlformats.org/drawingml/2006/main">
               <a:ext uri="{FF2B5EF4-FFF2-40B4-BE49-F238E27FC236}">
-                <a16:creationId xmlns:a16="http://schemas.microsoft.com/office/drawing/2014/main" id="{47E2B770-931E-48C6-8A8E-E08612FCB61A}"/>
+                <a16:creationId xmlns:a16="http://schemas.microsoft.com/office/drawing/2014/main" id="{36883AAE-84B0-4DB6-9118-A9775F56FBD3}"/>
               </a:ext>
             </a:extLst>
           </p:cNvPr>
@@ -14858,7 +14858,7 @@
           <p:cNvPr id="7" name="">
             <a:extLst xmlns:a="http://schemas.openxmlformats.org/drawingml/2006/main">
               <a:ext uri="{FF2B5EF4-FFF2-40B4-BE49-F238E27FC236}">
-                <a16:creationId xmlns:a16="http://schemas.microsoft.com/office/drawing/2014/main" id="{E80CD499-EAA3-4CE8-879E-69B549607F15}"/>
+                <a16:creationId xmlns:a16="http://schemas.microsoft.com/office/drawing/2014/main" id="{7AB643D0-F407-4B34-91DC-FEA4C91F2B77}"/>
               </a:ext>
             </a:extLst>
           </p:cNvPr>
@@ -14887,7 +14887,7 @@
           <a:lstStyle xmlns:a="http://schemas.openxmlformats.org/drawingml/2006/main"/>
           <a:p xmlns:a="http://schemas.openxmlformats.org/drawingml/2006/main">
             <a:pPr>
-              <a:defRPr sz="1950" b="0">
+              <a:defRPr sz="1650" b="0">
                 <a:solidFill>
                   <a:srgbClr val="166569"/>
                 </a:solidFill>
@@ -14897,7 +14897,7 @@
               </a:defRPr>
             </a:pPr>
             <a:r>
-              <a:rPr sz="1950" b="0">
+              <a:rPr sz="1650" b="0">
                 <a:solidFill>
                   <a:srgbClr val="166569"/>
                 </a:solidFill>
@@ -14915,7 +14915,7 @@
           <p:cNvPr id="8" name="">
             <a:extLst xmlns:a="http://schemas.openxmlformats.org/drawingml/2006/main">
               <a:ext uri="{FF2B5EF4-FFF2-40B4-BE49-F238E27FC236}">
-                <a16:creationId xmlns:a16="http://schemas.microsoft.com/office/drawing/2014/main" id="{066DF1A3-A9BA-4539-B45F-1DCF33E849BA}"/>
+                <a16:creationId xmlns:a16="http://schemas.microsoft.com/office/drawing/2014/main" id="{A83C718A-1DD1-4FF9-9A04-F5AC868532A3}"/>
               </a:ext>
             </a:extLst>
           </p:cNvPr>
@@ -14972,7 +14972,7 @@
           <p:cNvPr id="9" name="">
             <a:extLst xmlns:a="http://schemas.openxmlformats.org/drawingml/2006/main">
               <a:ext uri="{FF2B5EF4-FFF2-40B4-BE49-F238E27FC236}">
-                <a16:creationId xmlns:a16="http://schemas.microsoft.com/office/drawing/2014/main" id="{903728C8-58D6-4380-896B-FB0089FF49AC}"/>
+                <a16:creationId xmlns:a16="http://schemas.microsoft.com/office/drawing/2014/main" id="{37455276-67F9-4399-97FD-FFFA3830CB78}"/>
               </a:ext>
             </a:extLst>
           </p:cNvPr>
@@ -15002,7 +15002,7 @@
           <p:cNvPr id="10" name="">
             <a:extLst xmlns:a="http://schemas.openxmlformats.org/drawingml/2006/main">
               <a:ext uri="{FF2B5EF4-FFF2-40B4-BE49-F238E27FC236}">
-                <a16:creationId xmlns:a16="http://schemas.microsoft.com/office/drawing/2014/main" id="{C009C4A1-A2A1-4E59-B6D9-E91CB6804051}"/>
+                <a16:creationId xmlns:a16="http://schemas.microsoft.com/office/drawing/2014/main" id="{71317E4F-5AB3-48AC-A169-65DBFA8F85AB}"/>
               </a:ext>
             </a:extLst>
           </p:cNvPr>
@@ -15059,7 +15059,7 @@
           <p:cNvPr id="11" name="">
             <a:extLst xmlns:a="http://schemas.openxmlformats.org/drawingml/2006/main">
               <a:ext uri="{FF2B5EF4-FFF2-40B4-BE49-F238E27FC236}">
-                <a16:creationId xmlns:a16="http://schemas.microsoft.com/office/drawing/2014/main" id="{16D427CC-F21A-4048-8453-9A3514B726CA}"/>
+                <a16:creationId xmlns:a16="http://schemas.microsoft.com/office/drawing/2014/main" id="{8F1A8E22-6871-4A20-B77F-AF60D54B4F45}"/>
               </a:ext>
             </a:extLst>
           </p:cNvPr>
@@ -15116,7 +15116,7 @@
           <p:cNvPr id="12" name="">
             <a:extLst xmlns:a="http://schemas.openxmlformats.org/drawingml/2006/main">
               <a:ext uri="{FF2B5EF4-FFF2-40B4-BE49-F238E27FC236}">
-                <a16:creationId xmlns:a16="http://schemas.microsoft.com/office/drawing/2014/main" id="{A485E837-9170-473B-ADD0-9063F9C4C79A}"/>
+                <a16:creationId xmlns:a16="http://schemas.microsoft.com/office/drawing/2014/main" id="{1973E725-3560-4AFF-A7E4-B08DB9DD89B5}"/>
               </a:ext>
             </a:extLst>
           </p:cNvPr>
@@ -15146,7 +15146,7 @@
           <p:cNvPr id="13" name="">
             <a:extLst xmlns:a="http://schemas.openxmlformats.org/drawingml/2006/main">
               <a:ext uri="{FF2B5EF4-FFF2-40B4-BE49-F238E27FC236}">
-                <a16:creationId xmlns:a16="http://schemas.microsoft.com/office/drawing/2014/main" id="{1B366AE2-9FD1-42BE-91AE-88458AA2A4E7}"/>
+                <a16:creationId xmlns:a16="http://schemas.microsoft.com/office/drawing/2014/main" id="{F3387EA1-F3B9-42C5-96CB-0F7D23BDE3E1}"/>
               </a:ext>
             </a:extLst>
           </p:cNvPr>
@@ -15203,7 +15203,7 @@
           <p:cNvPr id="14" name="">
             <a:extLst xmlns:a="http://schemas.openxmlformats.org/drawingml/2006/main">
               <a:ext uri="{FF2B5EF4-FFF2-40B4-BE49-F238E27FC236}">
-                <a16:creationId xmlns:a16="http://schemas.microsoft.com/office/drawing/2014/main" id="{3E0A52B4-F4AF-434D-AB96-F6D35493DA08}"/>
+                <a16:creationId xmlns:a16="http://schemas.microsoft.com/office/drawing/2014/main" id="{38C427EE-FAE9-4889-991E-A01ADEBE1855}"/>
               </a:ext>
             </a:extLst>
           </p:cNvPr>
@@ -15260,7 +15260,7 @@
           <p:cNvPr id="15" name="">
             <a:extLst xmlns:a="http://schemas.openxmlformats.org/drawingml/2006/main">
               <a:ext uri="{FF2B5EF4-FFF2-40B4-BE49-F238E27FC236}">
-                <a16:creationId xmlns:a16="http://schemas.microsoft.com/office/drawing/2014/main" id="{63D5B8C4-355E-43B8-9803-B767C24D5DBD}"/>
+                <a16:creationId xmlns:a16="http://schemas.microsoft.com/office/drawing/2014/main" id="{6DAFB004-AF3E-4AEA-B152-7427D6D2C3A9}"/>
               </a:ext>
             </a:extLst>
           </p:cNvPr>
@@ -15317,7 +15317,7 @@
           <p:cNvPr id="16" name="">
             <a:extLst xmlns:a="http://schemas.openxmlformats.org/drawingml/2006/main">
               <a:ext uri="{FF2B5EF4-FFF2-40B4-BE49-F238E27FC236}">
-                <a16:creationId xmlns:a16="http://schemas.microsoft.com/office/drawing/2014/main" id="{D8BDF9E3-0DF2-4BF8-A3E7-DD08084E6CBE}"/>
+                <a16:creationId xmlns:a16="http://schemas.microsoft.com/office/drawing/2014/main" id="{63786F2C-11DF-451C-84B4-4BC2E545F655}"/>
               </a:ext>
             </a:extLst>
           </p:cNvPr>
@@ -15347,7 +15347,7 @@
           <p:cNvPr id="17" name="">
             <a:extLst xmlns:a="http://schemas.openxmlformats.org/drawingml/2006/main">
               <a:ext uri="{FF2B5EF4-FFF2-40B4-BE49-F238E27FC236}">
-                <a16:creationId xmlns:a16="http://schemas.microsoft.com/office/drawing/2014/main" id="{A5155A4D-5B70-418E-A957-8DEE86FF5DB3}"/>
+                <a16:creationId xmlns:a16="http://schemas.microsoft.com/office/drawing/2014/main" id="{425677DB-0637-4647-830E-D3533D49F007}"/>
               </a:ext>
             </a:extLst>
           </p:cNvPr>
@@ -15404,7 +15404,7 @@
           <p:cNvPr id="18" name="">
             <a:extLst xmlns:a="http://schemas.openxmlformats.org/drawingml/2006/main">
               <a:ext uri="{FF2B5EF4-FFF2-40B4-BE49-F238E27FC236}">
-                <a16:creationId xmlns:a16="http://schemas.microsoft.com/office/drawing/2014/main" id="{2DB043E7-462E-4A0F-AB51-A656138C7643}"/>
+                <a16:creationId xmlns:a16="http://schemas.microsoft.com/office/drawing/2014/main" id="{212D52DD-02DB-4277-86C5-8EA7E88F6186}"/>
               </a:ext>
             </a:extLst>
           </p:cNvPr>
@@ -15459,7 +15459,7 @@
     </p:spTree>
     <p:extLst>
       <p:ext uri="{BB962C8B-B14F-4D97-AF65-F5344CB8AC3E}">
-        <p14:creationId xmlns:p14="http://schemas.microsoft.com/office/powerpoint/2010/main" val="1062350996"/>
+        <p14:creationId xmlns:p14="http://schemas.microsoft.com/office/powerpoint/2010/main" val="1332318806"/>
       </p:ext>
     </p:extLst>
   </p:cSld>
@@ -15490,7 +15490,7 @@
           <p:cNvPr id="12" name="">
             <a:extLst xmlns:a="http://schemas.openxmlformats.org/drawingml/2006/main">
               <a:ext uri="{FF2B5EF4-FFF2-40B4-BE49-F238E27FC236}">
-                <a16:creationId xmlns:a16="http://schemas.microsoft.com/office/drawing/2014/main" id="{967F7332-EA71-4E33-BBCC-DC3DABA4A4FD}"/>
+                <a16:creationId xmlns:a16="http://schemas.microsoft.com/office/drawing/2014/main" id="{ED5F9C97-E9F8-43C3-969C-F6227B2D53D8}"/>
               </a:ext>
             </a:extLst>
           </p:cNvPr>
@@ -15547,7 +15547,7 @@
           <p:cNvPr id="2" name="">
             <a:extLst xmlns:a="http://schemas.openxmlformats.org/drawingml/2006/main">
               <a:ext uri="{FF2B5EF4-FFF2-40B4-BE49-F238E27FC236}">
-                <a16:creationId xmlns:a16="http://schemas.microsoft.com/office/drawing/2014/main" id="{B921716F-9433-4E60-B11E-2E80ECC40C20}"/>
+                <a16:creationId xmlns:a16="http://schemas.microsoft.com/office/drawing/2014/main" id="{39228BF3-AF30-4399-B196-FDC8D06E481D}"/>
               </a:ext>
             </a:extLst>
           </p:cNvPr>
@@ -15604,7 +15604,7 @@
           <p:cNvPr id="3" name="">
             <a:extLst xmlns:a="http://schemas.openxmlformats.org/drawingml/2006/main">
               <a:ext uri="{FF2B5EF4-FFF2-40B4-BE49-F238E27FC236}">
-                <a16:creationId xmlns:a16="http://schemas.microsoft.com/office/drawing/2014/main" id="{17D7B683-DD68-4FA7-A5CD-AC9067005AF1}"/>
+                <a16:creationId xmlns:a16="http://schemas.microsoft.com/office/drawing/2014/main" id="{C42AF50B-8B51-47F3-84F0-3924E061D91A}"/>
               </a:ext>
             </a:extLst>
           </p:cNvPr>
@@ -15665,7 +15665,7 @@
           <p:nvPr/>
         </p:nvPicPr>
         <p:blipFill>
-          <a:blip xmlns:r="http://schemas.openxmlformats.org/officeDocument/2006/relationships" xmlns:a="http://schemas.openxmlformats.org/drawingml/2006/main" r:embed="R111420bc03a2443f"/>
+          <a:blip xmlns:r="http://schemas.openxmlformats.org/officeDocument/2006/relationships" xmlns:a="http://schemas.openxmlformats.org/drawingml/2006/main" r:embed="R2d8ca49e84cb42ad"/>
           <a:stretch xmlns:a="http://schemas.openxmlformats.org/drawingml/2006/main"/>
         </p:blipFill>
         <p:spPr>
@@ -15683,7 +15683,7 @@
           <p:cNvPr id="5" name="">
             <a:extLst xmlns:a="http://schemas.openxmlformats.org/drawingml/2006/main">
               <a:ext uri="{FF2B5EF4-FFF2-40B4-BE49-F238E27FC236}">
-                <a16:creationId xmlns:a16="http://schemas.microsoft.com/office/drawing/2014/main" id="{85CE13A6-C453-408E-B1D6-4D045375246F}"/>
+                <a16:creationId xmlns:a16="http://schemas.microsoft.com/office/drawing/2014/main" id="{E564D21A-8137-4847-911E-7972495952E7}"/>
               </a:ext>
             </a:extLst>
           </p:cNvPr>
@@ -15740,7 +15740,7 @@
           <p:cNvPr id="6" name="">
             <a:extLst xmlns:a="http://schemas.openxmlformats.org/drawingml/2006/main">
               <a:ext uri="{FF2B5EF4-FFF2-40B4-BE49-F238E27FC236}">
-                <a16:creationId xmlns:a16="http://schemas.microsoft.com/office/drawing/2014/main" id="{0E4BCBDD-FF43-4944-944B-46E84750B44C}"/>
+                <a16:creationId xmlns:a16="http://schemas.microsoft.com/office/drawing/2014/main" id="{F1D8C4C3-B2C2-46D6-898F-D946D77EE0D5}"/>
               </a:ext>
             </a:extLst>
           </p:cNvPr>
@@ -15797,7 +15797,7 @@
           <p:cNvPr id="7" name="">
             <a:extLst xmlns:a="http://schemas.openxmlformats.org/drawingml/2006/main">
               <a:ext uri="{FF2B5EF4-FFF2-40B4-BE49-F238E27FC236}">
-                <a16:creationId xmlns:a16="http://schemas.microsoft.com/office/drawing/2014/main" id="{5E04A15A-78FF-4AC2-8994-A3CAF200D183}"/>
+                <a16:creationId xmlns:a16="http://schemas.microsoft.com/office/drawing/2014/main" id="{F75FC435-5FF2-4C3B-B355-C7D302716402}"/>
               </a:ext>
             </a:extLst>
           </p:cNvPr>
@@ -15854,7 +15854,7 @@
           <p:cNvPr id="8" name="">
             <a:extLst xmlns:a="http://schemas.openxmlformats.org/drawingml/2006/main">
               <a:ext uri="{FF2B5EF4-FFF2-40B4-BE49-F238E27FC236}">
-                <a16:creationId xmlns:a16="http://schemas.microsoft.com/office/drawing/2014/main" id="{1B1F0B21-86B3-45F0-8726-9E3E578267A8}"/>
+                <a16:creationId xmlns:a16="http://schemas.microsoft.com/office/drawing/2014/main" id="{BDDBEACD-C380-4D2A-9A2B-917FD601A6AF}"/>
               </a:ext>
             </a:extLst>
           </p:cNvPr>
@@ -15911,7 +15911,7 @@
           <p:cNvPr id="9" name="">
             <a:extLst xmlns:a="http://schemas.openxmlformats.org/drawingml/2006/main">
               <a:ext uri="{FF2B5EF4-FFF2-40B4-BE49-F238E27FC236}">
-                <a16:creationId xmlns:a16="http://schemas.microsoft.com/office/drawing/2014/main" id="{EF255CEC-C3E9-43BB-986D-68F06E7C7F73}"/>
+                <a16:creationId xmlns:a16="http://schemas.microsoft.com/office/drawing/2014/main" id="{51F4C02B-FB80-412E-8AE4-33238444A0B9}"/>
               </a:ext>
             </a:extLst>
           </p:cNvPr>
@@ -15941,7 +15941,7 @@
           <p:cNvPr id="10" name="">
             <a:extLst xmlns:a="http://schemas.openxmlformats.org/drawingml/2006/main">
               <a:ext uri="{FF2B5EF4-FFF2-40B4-BE49-F238E27FC236}">
-                <a16:creationId xmlns:a16="http://schemas.microsoft.com/office/drawing/2014/main" id="{BF1A5424-D4FB-4237-B4B6-3831733CD964}"/>
+                <a16:creationId xmlns:a16="http://schemas.microsoft.com/office/drawing/2014/main" id="{56F42063-0D76-4CA0-9D5E-5ED583F3876B}"/>
               </a:ext>
             </a:extLst>
           </p:cNvPr>
@@ -15998,7 +15998,7 @@
           <p:cNvPr id="11" name="">
             <a:extLst xmlns:a="http://schemas.openxmlformats.org/drawingml/2006/main">
               <a:ext uri="{FF2B5EF4-FFF2-40B4-BE49-F238E27FC236}">
-                <a16:creationId xmlns:a16="http://schemas.microsoft.com/office/drawing/2014/main" id="{B01F22FF-A2AD-433B-84CA-4C8AC5AD085A}"/>
+                <a16:creationId xmlns:a16="http://schemas.microsoft.com/office/drawing/2014/main" id="{690BA559-73B2-4180-903F-23A2E621C539}"/>
               </a:ext>
             </a:extLst>
           </p:cNvPr>
@@ -16053,7 +16053,7 @@
     </p:spTree>
     <p:extLst>
       <p:ext uri="{BB962C8B-B14F-4D97-AF65-F5344CB8AC3E}">
-        <p14:creationId xmlns:p14="http://schemas.microsoft.com/office/powerpoint/2010/main" val="1194494039"/>
+        <p14:creationId xmlns:p14="http://schemas.microsoft.com/office/powerpoint/2010/main" val="103320972"/>
       </p:ext>
     </p:extLst>
   </p:cSld>
@@ -16084,7 +16084,7 @@
           <p:cNvPr id="12" name="">
             <a:extLst xmlns:a="http://schemas.openxmlformats.org/drawingml/2006/main">
               <a:ext uri="{FF2B5EF4-FFF2-40B4-BE49-F238E27FC236}">
-                <a16:creationId xmlns:a16="http://schemas.microsoft.com/office/drawing/2014/main" id="{DD666ADA-4A53-4A80-A52A-B9D2D70BDA6F}"/>
+                <a16:creationId xmlns:a16="http://schemas.microsoft.com/office/drawing/2014/main" id="{1B602104-B701-47B3-A9FD-BDC05DB3B081}"/>
               </a:ext>
             </a:extLst>
           </p:cNvPr>
@@ -16141,7 +16141,7 @@
           <p:cNvPr id="2" name="">
             <a:extLst xmlns:a="http://schemas.openxmlformats.org/drawingml/2006/main">
               <a:ext uri="{FF2B5EF4-FFF2-40B4-BE49-F238E27FC236}">
-                <a16:creationId xmlns:a16="http://schemas.microsoft.com/office/drawing/2014/main" id="{A84B099A-95CD-4D45-A0A5-4ED0C6A136A8}"/>
+                <a16:creationId xmlns:a16="http://schemas.microsoft.com/office/drawing/2014/main" id="{C2161431-F9EB-4C6D-A036-69781B6084D6}"/>
               </a:ext>
             </a:extLst>
           </p:cNvPr>
@@ -16198,7 +16198,7 @@
           <p:cNvPr id="3" name="">
             <a:extLst xmlns:a="http://schemas.openxmlformats.org/drawingml/2006/main">
               <a:ext uri="{FF2B5EF4-FFF2-40B4-BE49-F238E27FC236}">
-                <a16:creationId xmlns:a16="http://schemas.microsoft.com/office/drawing/2014/main" id="{BF9FC640-C30A-4F96-AB06-06007DC9666F}"/>
+                <a16:creationId xmlns:a16="http://schemas.microsoft.com/office/drawing/2014/main" id="{39651578-20EE-4685-9327-A19F3B7F9A08}"/>
               </a:ext>
             </a:extLst>
           </p:cNvPr>
@@ -16259,7 +16259,7 @@
           <p:nvPr/>
         </p:nvPicPr>
         <p:blipFill>
-          <a:blip xmlns:r="http://schemas.openxmlformats.org/officeDocument/2006/relationships" xmlns:a="http://schemas.openxmlformats.org/drawingml/2006/main" r:embed="Rca0bb9b77b0542b2"/>
+          <a:blip xmlns:r="http://schemas.openxmlformats.org/officeDocument/2006/relationships" xmlns:a="http://schemas.openxmlformats.org/drawingml/2006/main" r:embed="R152b5cc337814e14"/>
           <a:stretch xmlns:a="http://schemas.openxmlformats.org/drawingml/2006/main"/>
         </p:blipFill>
         <p:spPr>
@@ -16277,7 +16277,7 @@
           <p:cNvPr id="5" name="">
             <a:extLst xmlns:a="http://schemas.openxmlformats.org/drawingml/2006/main">
               <a:ext uri="{FF2B5EF4-FFF2-40B4-BE49-F238E27FC236}">
-                <a16:creationId xmlns:a16="http://schemas.microsoft.com/office/drawing/2014/main" id="{845949CB-E478-451E-AC81-C6DF0CBB1FEC}"/>
+                <a16:creationId xmlns:a16="http://schemas.microsoft.com/office/drawing/2014/main" id="{6C4AD182-FE79-4F43-BE62-3F644818585C}"/>
               </a:ext>
             </a:extLst>
           </p:cNvPr>
@@ -16334,7 +16334,7 @@
           <p:cNvPr id="6" name="">
             <a:extLst xmlns:a="http://schemas.openxmlformats.org/drawingml/2006/main">
               <a:ext uri="{FF2B5EF4-FFF2-40B4-BE49-F238E27FC236}">
-                <a16:creationId xmlns:a16="http://schemas.microsoft.com/office/drawing/2014/main" id="{3561C9A6-9EC9-4181-95DD-CA6788E6BF3B}"/>
+                <a16:creationId xmlns:a16="http://schemas.microsoft.com/office/drawing/2014/main" id="{749AC3DC-6A11-4E19-8F50-6F97C4B7F94C}"/>
               </a:ext>
             </a:extLst>
           </p:cNvPr>
@@ -16391,7 +16391,7 @@
           <p:cNvPr id="7" name="">
             <a:extLst xmlns:a="http://schemas.openxmlformats.org/drawingml/2006/main">
               <a:ext uri="{FF2B5EF4-FFF2-40B4-BE49-F238E27FC236}">
-                <a16:creationId xmlns:a16="http://schemas.microsoft.com/office/drawing/2014/main" id="{E1B25647-9522-4F43-ABAE-03EC67B8184D}"/>
+                <a16:creationId xmlns:a16="http://schemas.microsoft.com/office/drawing/2014/main" id="{E75B8850-CF1A-45D7-8686-3D44F60CD052}"/>
               </a:ext>
             </a:extLst>
           </p:cNvPr>
@@ -16448,7 +16448,7 @@
           <p:cNvPr id="8" name="">
             <a:extLst xmlns:a="http://schemas.openxmlformats.org/drawingml/2006/main">
               <a:ext uri="{FF2B5EF4-FFF2-40B4-BE49-F238E27FC236}">
-                <a16:creationId xmlns:a16="http://schemas.microsoft.com/office/drawing/2014/main" id="{C923050A-A567-4BED-B8B3-1A92BF2AF627}"/>
+                <a16:creationId xmlns:a16="http://schemas.microsoft.com/office/drawing/2014/main" id="{E38603B8-DA71-492E-8ADC-D3CED787BCFB}"/>
               </a:ext>
             </a:extLst>
           </p:cNvPr>
@@ -16505,7 +16505,7 @@
           <p:cNvPr id="9" name="">
             <a:extLst xmlns:a="http://schemas.openxmlformats.org/drawingml/2006/main">
               <a:ext uri="{FF2B5EF4-FFF2-40B4-BE49-F238E27FC236}">
-                <a16:creationId xmlns:a16="http://schemas.microsoft.com/office/drawing/2014/main" id="{514AF9C6-2DBE-4313-A1CF-D4D35C0BA72F}"/>
+                <a16:creationId xmlns:a16="http://schemas.microsoft.com/office/drawing/2014/main" id="{0C7E4785-2321-45D5-807D-350CD982123C}"/>
               </a:ext>
             </a:extLst>
           </p:cNvPr>
@@ -16535,7 +16535,7 @@
           <p:cNvPr id="10" name="">
             <a:extLst xmlns:a="http://schemas.openxmlformats.org/drawingml/2006/main">
               <a:ext uri="{FF2B5EF4-FFF2-40B4-BE49-F238E27FC236}">
-                <a16:creationId xmlns:a16="http://schemas.microsoft.com/office/drawing/2014/main" id="{3BB12F58-04F0-4F9F-A8EF-5F26E1FAC52F}"/>
+                <a16:creationId xmlns:a16="http://schemas.microsoft.com/office/drawing/2014/main" id="{2896851C-A2A7-4DFF-96B3-75CD9DD93590}"/>
               </a:ext>
             </a:extLst>
           </p:cNvPr>
@@ -16592,7 +16592,7 @@
           <p:cNvPr id="11" name="">
             <a:extLst xmlns:a="http://schemas.openxmlformats.org/drawingml/2006/main">
               <a:ext uri="{FF2B5EF4-FFF2-40B4-BE49-F238E27FC236}">
-                <a16:creationId xmlns:a16="http://schemas.microsoft.com/office/drawing/2014/main" id="{02A52D56-FBA0-4E75-8ECF-443330BA5CCA}"/>
+                <a16:creationId xmlns:a16="http://schemas.microsoft.com/office/drawing/2014/main" id="{01204F6A-DC5C-4FC5-9233-102C7DA3B2F3}"/>
               </a:ext>
             </a:extLst>
           </p:cNvPr>
@@ -16647,7 +16647,7 @@
     </p:spTree>
     <p:extLst>
       <p:ext uri="{BB962C8B-B14F-4D97-AF65-F5344CB8AC3E}">
-        <p14:creationId xmlns:p14="http://schemas.microsoft.com/office/powerpoint/2010/main" val="397874911"/>
+        <p14:creationId xmlns:p14="http://schemas.microsoft.com/office/powerpoint/2010/main" val="409655970"/>
       </p:ext>
     </p:extLst>
   </p:cSld>

</xml_diff>